<commit_message>
fix: unify Clarke Error Grid + update presentation
metrics.py: unified Clarke implementation with complete Zone D range
- Hypo not detected: r<=70 and 70<p<=180 (full range, not just 120-180)
- Matches Abeer's structure + corrects her partial Zone D boundary
- All backward-compatible via _clarke_zone alias

PRESENTATION_FINAL.pptx:
- Slide 4: literature quotes for all 5 model parameter choices
- Slide 5: RMSE explanation and green highlight justification
- Slide 6 (new): epoch documentation placeholder — awaiting re-run
- Slide 11: explanation of why 3 features used for benchmark
</commit_message>
<xml_diff>
--- a/PRESENTATION_FINAL.pptx
+++ b/PRESENTATION_FINAL.pptx
@@ -19,6 +19,7 @@
     <p:sldId id="267" r:id="rId18"/>
     <p:sldId id="268" r:id="rId19"/>
     <p:sldId id="269" r:id="rId20"/>
+    <p:sldId id="270" r:id="rId21"/>
   </p:sldIdLst>
   <p:sldSz cx="12188952" cy="6858000" type="screen4x3"/>
   <p:notesSz cx="6858000" cy="9144000"/>
@@ -3456,18 +3457,7 @@
                   <a:srgbClr val="FFFFFF"/>
                 </a:solidFill>
               </a:rPr>
-              <a:t>Glucdict: All 5 Models</a:t>
-            </a:r>
-          </a:p>
-          <a:p>
-            <a:pPr algn="l"/>
-            <a:r>
-              <a:rPr sz="1400" b="0">
-                <a:solidFill>
-                  <a:srgbClr val="BFD7FF"/>
-                </a:solidFill>
-              </a:rPr>
-              <a:t>glucose_only, 30-min horizon, 13 users</a:t>
+              <a:t>Transfer Learning: Domain Shift Costs ~1-2 mg/dL</a:t>
             </a:r>
           </a:p>
         </p:txBody>
@@ -3579,6 +3569,677 @@
                 </a:solidFill>
               </a:rPr>
               <a:t>10</a:t>
+            </a:r>
+          </a:p>
+        </p:txBody>
+      </p:sp>
+      <p:graphicFrame>
+        <p:nvGraphicFramePr>
+          <p:cNvPr id="7" name="Table 6"/>
+          <p:cNvGraphicFramePr>
+            <a:graphicFrameLocks noGrp="1"/>
+          </p:cNvGraphicFramePr>
+          <p:nvPr/>
+        </p:nvGraphicFramePr>
+        <p:xfrm>
+          <a:off x="365760" y="1371600"/>
+          <a:ext cx="7315200" cy="1152144"/>
+        </p:xfrm>
+        <a:graphic>
+          <a:graphicData uri="http://schemas.openxmlformats.org/drawingml/2006/table">
+            <a:tbl>
+              <a:tblPr firstRow="1" bandRow="1">
+                <a:tableStyleId>{5C22544A-7EE6-4342-B048-85BDC9FD1C3A}</a:tableStyleId>
+              </a:tblPr>
+              <a:tblGrid>
+                <a:gridCol w="1463040"/>
+                <a:gridCol w="2103120"/>
+                <a:gridCol w="1920240"/>
+                <a:gridCol w="1828800"/>
+              </a:tblGrid>
+              <a:tr h="384048">
+                <a:tc>
+                  <a:txBody>
+                    <a:bodyPr wrap="square"/>
+                    <a:lstStyle/>
+                    <a:p>
+                      <a:pPr algn="ctr"/>
+                      <a:r>
+                        <a:rPr sz="1500" b="1">
+                          <a:solidFill>
+                            <a:srgbClr val="FFFFFF"/>
+                          </a:solidFill>
+                        </a:rPr>
+                        <a:t>Model</a:t>
+                      </a:r>
+                    </a:p>
+                  </a:txBody>
+                  <a:tcPr>
+                    <a:solidFill>
+                      <a:srgbClr val="1F3864"/>
+                    </a:solidFill>
+                  </a:tcPr>
+                </a:tc>
+                <a:tc>
+                  <a:txBody>
+                    <a:bodyPr wrap="square"/>
+                    <a:lstStyle/>
+                    <a:p>
+                      <a:pPr algn="ctr"/>
+                      <a:r>
+                        <a:rPr sz="1500" b="1">
+                          <a:solidFill>
+                            <a:srgbClr val="FFFFFF"/>
+                          </a:solidFill>
+                        </a:rPr>
+                        <a:t>Transfer RMSE</a:t>
+                      </a:r>
+                    </a:p>
+                  </a:txBody>
+                  <a:tcPr>
+                    <a:solidFill>
+                      <a:srgbClr val="1F3864"/>
+                    </a:solidFill>
+                  </a:tcPr>
+                </a:tc>
+                <a:tc>
+                  <a:txBody>
+                    <a:bodyPr wrap="square"/>
+                    <a:lstStyle/>
+                    <a:p>
+                      <a:pPr algn="ctr"/>
+                      <a:r>
+                        <a:rPr sz="1500" b="1">
+                          <a:solidFill>
+                            <a:srgbClr val="FFFFFF"/>
+                          </a:solidFill>
+                        </a:rPr>
+                        <a:t>Personalised</a:t>
+                      </a:r>
+                    </a:p>
+                  </a:txBody>
+                  <a:tcPr>
+                    <a:solidFill>
+                      <a:srgbClr val="1F3864"/>
+                    </a:solidFill>
+                  </a:tcPr>
+                </a:tc>
+                <a:tc>
+                  <a:txBody>
+                    <a:bodyPr wrap="square"/>
+                    <a:lstStyle/>
+                    <a:p>
+                      <a:pPr algn="ctr"/>
+                      <a:r>
+                        <a:rPr sz="1500" b="1">
+                          <a:solidFill>
+                            <a:srgbClr val="FFFFFF"/>
+                          </a:solidFill>
+                        </a:rPr>
+                        <a:t>Gap</a:t>
+                      </a:r>
+                    </a:p>
+                  </a:txBody>
+                  <a:tcPr>
+                    <a:solidFill>
+                      <a:srgbClr val="1F3864"/>
+                    </a:solidFill>
+                  </a:tcPr>
+                </a:tc>
+              </a:tr>
+              <a:tr h="384048">
+                <a:tc>
+                  <a:txBody>
+                    <a:bodyPr wrap="square"/>
+                    <a:lstStyle/>
+                    <a:p>
+                      <a:pPr algn="l"/>
+                      <a:r>
+                        <a:rPr sz="1500" b="0">
+                          <a:solidFill>
+                            <a:srgbClr val="000000"/>
+                          </a:solidFill>
+                        </a:rPr>
+                        <a:t>RF</a:t>
+                      </a:r>
+                    </a:p>
+                  </a:txBody>
+                  <a:tcPr>
+                    <a:solidFill>
+                      <a:srgbClr val="F2F2F2"/>
+                    </a:solidFill>
+                  </a:tcPr>
+                </a:tc>
+                <a:tc>
+                  <a:txBody>
+                    <a:bodyPr wrap="square"/>
+                    <a:lstStyle/>
+                    <a:p>
+                      <a:pPr algn="ctr"/>
+                      <a:r>
+                        <a:rPr sz="1500" b="0">
+                          <a:solidFill>
+                            <a:srgbClr val="000000"/>
+                          </a:solidFill>
+                        </a:rPr>
+                        <a:t>16.67</a:t>
+                      </a:r>
+                    </a:p>
+                  </a:txBody>
+                  <a:tcPr>
+                    <a:solidFill>
+                      <a:srgbClr val="F2F2F2"/>
+                    </a:solidFill>
+                  </a:tcPr>
+                </a:tc>
+                <a:tc>
+                  <a:txBody>
+                    <a:bodyPr wrap="square"/>
+                    <a:lstStyle/>
+                    <a:p>
+                      <a:pPr algn="ctr"/>
+                      <a:r>
+                        <a:rPr sz="1500" b="0">
+                          <a:solidFill>
+                            <a:srgbClr val="000000"/>
+                          </a:solidFill>
+                        </a:rPr>
+                        <a:t>15.23</a:t>
+                      </a:r>
+                    </a:p>
+                  </a:txBody>
+                  <a:tcPr>
+                    <a:solidFill>
+                      <a:srgbClr val="F2F2F2"/>
+                    </a:solidFill>
+                  </a:tcPr>
+                </a:tc>
+                <a:tc>
+                  <a:txBody>
+                    <a:bodyPr wrap="square"/>
+                    <a:lstStyle/>
+                    <a:p>
+                      <a:pPr algn="ctr"/>
+                      <a:r>
+                        <a:rPr sz="1500" b="0">
+                          <a:solidFill>
+                            <a:srgbClr val="000000"/>
+                          </a:solidFill>
+                        </a:rPr>
+                        <a:t>+1.44 (+9%)</a:t>
+                      </a:r>
+                    </a:p>
+                  </a:txBody>
+                  <a:tcPr>
+                    <a:solidFill>
+                      <a:srgbClr val="F2F2F2"/>
+                    </a:solidFill>
+                  </a:tcPr>
+                </a:tc>
+              </a:tr>
+              <a:tr h="384048">
+                <a:tc>
+                  <a:txBody>
+                    <a:bodyPr wrap="square"/>
+                    <a:lstStyle/>
+                    <a:p>
+                      <a:pPr algn="l"/>
+                      <a:r>
+                        <a:rPr sz="1500" b="0">
+                          <a:solidFill>
+                            <a:srgbClr val="000000"/>
+                          </a:solidFill>
+                        </a:rPr>
+                        <a:t>LSTM</a:t>
+                      </a:r>
+                    </a:p>
+                  </a:txBody>
+                  <a:tcPr>
+                    <a:solidFill>
+                      <a:srgbClr val="FFFFFF"/>
+                    </a:solidFill>
+                  </a:tcPr>
+                </a:tc>
+                <a:tc>
+                  <a:txBody>
+                    <a:bodyPr wrap="square"/>
+                    <a:lstStyle/>
+                    <a:p>
+                      <a:pPr algn="ctr"/>
+                      <a:r>
+                        <a:rPr sz="1500" b="0">
+                          <a:solidFill>
+                            <a:srgbClr val="000000"/>
+                          </a:solidFill>
+                        </a:rPr>
+                        <a:t>15.95</a:t>
+                      </a:r>
+                    </a:p>
+                  </a:txBody>
+                  <a:tcPr>
+                    <a:solidFill>
+                      <a:srgbClr val="FFFFFF"/>
+                    </a:solidFill>
+                  </a:tcPr>
+                </a:tc>
+                <a:tc>
+                  <a:txBody>
+                    <a:bodyPr wrap="square"/>
+                    <a:lstStyle/>
+                    <a:p>
+                      <a:pPr algn="ctr"/>
+                      <a:r>
+                        <a:rPr sz="1500" b="0">
+                          <a:solidFill>
+                            <a:srgbClr val="000000"/>
+                          </a:solidFill>
+                        </a:rPr>
+                        <a:t>14.03</a:t>
+                      </a:r>
+                    </a:p>
+                  </a:txBody>
+                  <a:tcPr>
+                    <a:solidFill>
+                      <a:srgbClr val="FFFFFF"/>
+                    </a:solidFill>
+                  </a:tcPr>
+                </a:tc>
+                <a:tc>
+                  <a:txBody>
+                    <a:bodyPr wrap="square"/>
+                    <a:lstStyle/>
+                    <a:p>
+                      <a:pPr algn="ctr"/>
+                      <a:r>
+                        <a:rPr sz="1500" b="0">
+                          <a:solidFill>
+                            <a:srgbClr val="000000"/>
+                          </a:solidFill>
+                        </a:rPr>
+                        <a:t>+1.92 (+14%)</a:t>
+                      </a:r>
+                    </a:p>
+                  </a:txBody>
+                  <a:tcPr>
+                    <a:solidFill>
+                      <a:srgbClr val="FFFFFF"/>
+                    </a:solidFill>
+                  </a:tcPr>
+                </a:tc>
+              </a:tr>
+            </a:tbl>
+          </a:graphicData>
+        </a:graphic>
+      </p:graphicFrame>
+      <p:sp>
+        <p:nvSpPr>
+          <p:cNvPr id="8" name="Rectangle 7"/>
+          <p:cNvSpPr/>
+          <p:nvPr/>
+        </p:nvSpPr>
+        <p:spPr>
+          <a:xfrm>
+            <a:off x="365760" y="3063240"/>
+            <a:ext cx="11430000" cy="1371600"/>
+          </a:xfrm>
+          <a:prstGeom prst="rect">
+            <a:avLst/>
+          </a:prstGeom>
+          <a:solidFill>
+            <a:srgbClr val="DFE8F5"/>
+          </a:solidFill>
+          <a:ln>
+            <a:noFill/>
+          </a:ln>
+        </p:spPr>
+        <p:style>
+          <a:lnRef idx="1">
+            <a:schemeClr val="accent1"/>
+          </a:lnRef>
+          <a:fillRef idx="3">
+            <a:schemeClr val="accent1"/>
+          </a:fillRef>
+          <a:effectRef idx="2">
+            <a:schemeClr val="accent1"/>
+          </a:effectRef>
+          <a:fontRef idx="minor">
+            <a:schemeClr val="lt1"/>
+          </a:fontRef>
+        </p:style>
+        <p:txBody>
+          <a:bodyPr rtlCol="0" anchor="ctr"/>
+          <a:lstStyle/>
+          <a:p>
+            <a:pPr algn="ctr"/>
+          </a:p>
+        </p:txBody>
+      </p:sp>
+      <p:sp>
+        <p:nvSpPr>
+          <p:cNvPr id="9" name="TextBox 8"/>
+          <p:cNvSpPr txBox="1"/>
+          <p:nvPr/>
+        </p:nvSpPr>
+        <p:spPr>
+          <a:xfrm>
+            <a:off x="548640" y="3154680"/>
+            <a:ext cx="11064240" cy="1188720"/>
+          </a:xfrm>
+          <a:prstGeom prst="rect">
+            <a:avLst/>
+          </a:prstGeom>
+          <a:noFill/>
+        </p:spPr>
+        <p:txBody>
+          <a:bodyPr wrap="square">
+            <a:spAutoFit/>
+          </a:bodyPr>
+          <a:lstStyle/>
+          <a:p>
+            <a:pPr algn="l"/>
+            <a:r>
+              <a:rPr sz="1400" b="0">
+                <a:solidFill>
+                  <a:srgbClr val="1F3864"/>
+                </a:solidFill>
+              </a:rPr>
+              <a:t>Trained on OhioT1DM  (T1DM, Medtronic Enlite CGM)
+Tested zero-shot on Glucdict  (prediabetic, Dexcom G6 CGM)
+Different population + different device = only +1-2 mg/dL penalty</a:t>
+            </a:r>
+          </a:p>
+        </p:txBody>
+      </p:sp>
+      <p:sp>
+        <p:nvSpPr>
+          <p:cNvPr id="10" name="Rectangle 9"/>
+          <p:cNvSpPr/>
+          <p:nvPr/>
+        </p:nvSpPr>
+        <p:spPr>
+          <a:xfrm>
+            <a:off x="365760" y="4617720"/>
+            <a:ext cx="11430000" cy="1005840"/>
+          </a:xfrm>
+          <a:prstGeom prst="rect">
+            <a:avLst/>
+          </a:prstGeom>
+          <a:solidFill>
+            <a:srgbClr val="1F3864"/>
+          </a:solidFill>
+          <a:ln>
+            <a:noFill/>
+          </a:ln>
+        </p:spPr>
+        <p:style>
+          <a:lnRef idx="1">
+            <a:schemeClr val="accent1"/>
+          </a:lnRef>
+          <a:fillRef idx="3">
+            <a:schemeClr val="accent1"/>
+          </a:fillRef>
+          <a:effectRef idx="2">
+            <a:schemeClr val="accent1"/>
+          </a:effectRef>
+          <a:fontRef idx="minor">
+            <a:schemeClr val="lt1"/>
+          </a:fontRef>
+        </p:style>
+        <p:txBody>
+          <a:bodyPr rtlCol="0" anchor="ctr"/>
+          <a:lstStyle/>
+          <a:p>
+            <a:pPr algn="ctr"/>
+          </a:p>
+        </p:txBody>
+      </p:sp>
+      <p:sp>
+        <p:nvSpPr>
+          <p:cNvPr id="11" name="TextBox 10"/>
+          <p:cNvSpPr txBox="1"/>
+          <p:nvPr/>
+        </p:nvSpPr>
+        <p:spPr>
+          <a:xfrm>
+            <a:off x="548640" y="4709160"/>
+            <a:ext cx="11064240" cy="822960"/>
+          </a:xfrm>
+          <a:prstGeom prst="rect">
+            <a:avLst/>
+          </a:prstGeom>
+          <a:noFill/>
+        </p:spPr>
+        <p:txBody>
+          <a:bodyPr wrap="square">
+            <a:spAutoFit/>
+          </a:bodyPr>
+          <a:lstStyle/>
+          <a:p>
+            <a:pPr algn="ctr"/>
+            <a:r>
+              <a:rPr sz="1700" b="1">
+                <a:solidFill>
+                  <a:srgbClr val="FFFFFF"/>
+                </a:solidFill>
+              </a:rPr>
+              <a:t>Glucose autocorrelation is the dominant predictive signal regardless of patient population or device.</a:t>
+            </a:r>
+          </a:p>
+        </p:txBody>
+      </p:sp>
+    </p:spTree>
+  </p:cSld>
+  <p:clrMapOvr>
+    <a:masterClrMapping/>
+  </p:clrMapOvr>
+</p:sld>
+</file>
+
+<file path=ppt/slides/slide11.xml><?xml version="1.0" encoding="utf-8"?>
+<p:sld xmlns:a="http://schemas.openxmlformats.org/drawingml/2006/main" xmlns:p="http://schemas.openxmlformats.org/presentationml/2006/main" xmlns:r="http://schemas.openxmlformats.org/officeDocument/2006/relationships">
+  <p:cSld>
+    <p:spTree>
+      <p:nvGrpSpPr>
+        <p:cNvPr id="1" name=""/>
+        <p:cNvGrpSpPr/>
+        <p:nvPr/>
+      </p:nvGrpSpPr>
+      <p:grpSpPr/>
+      <p:sp>
+        <p:nvSpPr>
+          <p:cNvPr id="2" name="Rectangle 1"/>
+          <p:cNvSpPr/>
+          <p:nvPr/>
+        </p:nvSpPr>
+        <p:spPr>
+          <a:xfrm>
+            <a:off x="0" y="0"/>
+            <a:ext cx="12188952" cy="1143000"/>
+          </a:xfrm>
+          <a:prstGeom prst="rect">
+            <a:avLst/>
+          </a:prstGeom>
+          <a:solidFill>
+            <a:srgbClr val="1F3864"/>
+          </a:solidFill>
+          <a:ln>
+            <a:noFill/>
+          </a:ln>
+        </p:spPr>
+        <p:style>
+          <a:lnRef idx="1">
+            <a:schemeClr val="accent1"/>
+          </a:lnRef>
+          <a:fillRef idx="3">
+            <a:schemeClr val="accent1"/>
+          </a:fillRef>
+          <a:effectRef idx="2">
+            <a:schemeClr val="accent1"/>
+          </a:effectRef>
+          <a:fontRef idx="minor">
+            <a:schemeClr val="lt1"/>
+          </a:fontRef>
+        </p:style>
+        <p:txBody>
+          <a:bodyPr rtlCol="0" anchor="ctr"/>
+          <a:lstStyle/>
+          <a:p>
+            <a:pPr algn="ctr"/>
+          </a:p>
+        </p:txBody>
+      </p:sp>
+      <p:sp>
+        <p:nvSpPr>
+          <p:cNvPr id="3" name="TextBox 2"/>
+          <p:cNvSpPr txBox="1"/>
+          <p:nvPr/>
+        </p:nvSpPr>
+        <p:spPr>
+          <a:xfrm>
+            <a:off x="320040" y="137160"/>
+            <a:ext cx="11430000" cy="914400"/>
+          </a:xfrm>
+          <a:prstGeom prst="rect">
+            <a:avLst/>
+          </a:prstGeom>
+          <a:noFill/>
+        </p:spPr>
+        <p:txBody>
+          <a:bodyPr wrap="square">
+            <a:spAutoFit/>
+          </a:bodyPr>
+          <a:lstStyle/>
+          <a:p>
+            <a:pPr algn="l"/>
+            <a:r>
+              <a:rPr sz="2800" b="1">
+                <a:solidFill>
+                  <a:srgbClr val="FFFFFF"/>
+                </a:solidFill>
+              </a:rPr>
+              <a:t>Glucdict: All 5 Models</a:t>
+            </a:r>
+          </a:p>
+          <a:p>
+            <a:pPr algn="l"/>
+            <a:r>
+              <a:rPr sz="1400" b="0">
+                <a:solidFill>
+                  <a:srgbClr val="BFD7FF"/>
+                </a:solidFill>
+              </a:rPr>
+              <a:t>glucose_only, 30-min horizon, 13 users</a:t>
+            </a:r>
+          </a:p>
+        </p:txBody>
+      </p:sp>
+      <p:sp>
+        <p:nvSpPr>
+          <p:cNvPr id="4" name="Rectangle 3"/>
+          <p:cNvSpPr/>
+          <p:nvPr/>
+        </p:nvSpPr>
+        <p:spPr>
+          <a:xfrm>
+            <a:off x="0" y="6537960"/>
+            <a:ext cx="12188952" cy="320040"/>
+          </a:xfrm>
+          <a:prstGeom prst="rect">
+            <a:avLst/>
+          </a:prstGeom>
+          <a:solidFill>
+            <a:srgbClr val="1F3864"/>
+          </a:solidFill>
+          <a:ln>
+            <a:noFill/>
+          </a:ln>
+        </p:spPr>
+        <p:style>
+          <a:lnRef idx="1">
+            <a:schemeClr val="accent1"/>
+          </a:lnRef>
+          <a:fillRef idx="3">
+            <a:schemeClr val="accent1"/>
+          </a:fillRef>
+          <a:effectRef idx="2">
+            <a:schemeClr val="accent1"/>
+          </a:effectRef>
+          <a:fontRef idx="minor">
+            <a:schemeClr val="lt1"/>
+          </a:fontRef>
+        </p:style>
+        <p:txBody>
+          <a:bodyPr rtlCol="0" anchor="ctr"/>
+          <a:lstStyle/>
+          <a:p>
+            <a:pPr algn="ctr"/>
+          </a:p>
+        </p:txBody>
+      </p:sp>
+      <p:sp>
+        <p:nvSpPr>
+          <p:cNvPr id="5" name="TextBox 4"/>
+          <p:cNvSpPr txBox="1"/>
+          <p:nvPr/>
+        </p:nvSpPr>
+        <p:spPr>
+          <a:xfrm>
+            <a:off x="182880" y="6556248"/>
+            <a:ext cx="9144000" cy="274320"/>
+          </a:xfrm>
+          <a:prstGeom prst="rect">
+            <a:avLst/>
+          </a:prstGeom>
+          <a:noFill/>
+        </p:spPr>
+        <p:txBody>
+          <a:bodyPr wrap="square">
+            <a:spAutoFit/>
+          </a:bodyPr>
+          <a:lstStyle/>
+          <a:p>
+            <a:pPr algn="l"/>
+            <a:r>
+              <a:rPr sz="1000" b="0">
+                <a:solidFill>
+                  <a:srgbClr val="FFFFFF"/>
+                </a:solidFill>
+              </a:rPr>
+              <a:t>Blood Glucose Forecasting  |  University of Duisburg-Essen</a:t>
+            </a:r>
+          </a:p>
+        </p:txBody>
+      </p:sp>
+      <p:sp>
+        <p:nvSpPr>
+          <p:cNvPr id="6" name="TextBox 5"/>
+          <p:cNvSpPr txBox="1"/>
+          <p:nvPr/>
+        </p:nvSpPr>
+        <p:spPr>
+          <a:xfrm>
+            <a:off x="11430000" y="6556248"/>
+            <a:ext cx="640080" cy="274320"/>
+          </a:xfrm>
+          <a:prstGeom prst="rect">
+            <a:avLst/>
+          </a:prstGeom>
+          <a:noFill/>
+        </p:spPr>
+        <p:txBody>
+          <a:bodyPr wrap="square">
+            <a:spAutoFit/>
+          </a:bodyPr>
+          <a:lstStyle/>
+          <a:p>
+            <a:pPr algn="r"/>
+            <a:r>
+              <a:rPr sz="1000" b="1">
+                <a:solidFill>
+                  <a:srgbClr val="FFFFFF"/>
+                </a:solidFill>
+              </a:rPr>
+              <a:t>11</a:t>
             </a:r>
           </a:p>
         </p:txBody>
@@ -4104,7 +4765,7 @@
 </p:sld>
 </file>
 
-<file path=ppt/slides/slide11.xml><?xml version="1.0" encoding="utf-8"?>
+<file path=ppt/slides/slide12.xml><?xml version="1.0" encoding="utf-8"?>
 <p:sld xmlns:a="http://schemas.openxmlformats.org/drawingml/2006/main" xmlns:p="http://schemas.openxmlformats.org/presentationml/2006/main" xmlns:r="http://schemas.openxmlformats.org/officeDocument/2006/relationships">
   <p:cSld>
     <p:spTree>
@@ -4308,7 +4969,7 @@
                   <a:srgbClr val="FFFFFF"/>
                 </a:solidFill>
               </a:rPr>
-              <a:t>11</a:t>
+              <a:t>12</a:t>
             </a:r>
           </a:p>
         </p:txBody>
@@ -5153,72 +5814,20 @@
       </p:graphicFrame>
       <p:sp>
         <p:nvSpPr>
-          <p:cNvPr id="8" name="TextBox 7"/>
-          <p:cNvSpPr txBox="1"/>
-          <p:nvPr/>
-        </p:nvSpPr>
-        <p:spPr>
-          <a:xfrm>
-            <a:off x="365760" y="5669280"/>
-            <a:ext cx="11430000" cy="457200"/>
-          </a:xfrm>
-          <a:prstGeom prst="rect">
-            <a:avLst/>
-          </a:prstGeom>
-          <a:noFill/>
-        </p:spPr>
-        <p:txBody>
-          <a:bodyPr wrap="square">
-            <a:spAutoFit/>
-          </a:bodyPr>
-          <a:lstStyle/>
-          <a:p>
-            <a:pPr algn="ctr"/>
-            <a:r>
-              <a:rPr sz="1300" b="1">
-                <a:solidFill>
-                  <a:srgbClr val="1F3864"/>
-                </a:solidFill>
-              </a:rPr>
-              <a:t>Gap to literature explained by reduced feature set (3 vs. 6-7). Grid Search reduced our gap by ~3 mg/dL vs. defaults.</a:t>
-            </a:r>
-          </a:p>
-        </p:txBody>
-      </p:sp>
-    </p:spTree>
-  </p:cSld>
-  <p:clrMapOvr>
-    <a:masterClrMapping/>
-  </p:clrMapOvr>
-</p:sld>
-</file>
-
-<file path=ppt/slides/slide12.xml><?xml version="1.0" encoding="utf-8"?>
-<p:sld xmlns:a="http://schemas.openxmlformats.org/drawingml/2006/main" xmlns:p="http://schemas.openxmlformats.org/presentationml/2006/main" xmlns:r="http://schemas.openxmlformats.org/officeDocument/2006/relationships">
-  <p:cSld>
-    <p:spTree>
-      <p:nvGrpSpPr>
-        <p:cNvPr id="1" name=""/>
-        <p:cNvGrpSpPr/>
-        <p:nvPr/>
-      </p:nvGrpSpPr>
-      <p:grpSpPr/>
-      <p:sp>
-        <p:nvSpPr>
-          <p:cNvPr id="2" name="Rectangle 1"/>
+          <p:cNvPr id="8" name="Rectangle 7"/>
           <p:cNvSpPr/>
           <p:nvPr/>
         </p:nvSpPr>
         <p:spPr>
           <a:xfrm>
-            <a:off x="0" y="0"/>
-            <a:ext cx="12188952" cy="1143000"/>
+            <a:off x="365760" y="4828032"/>
+            <a:ext cx="11430000" cy="1188720"/>
           </a:xfrm>
           <a:prstGeom prst="rect">
             <a:avLst/>
           </a:prstGeom>
           <a:solidFill>
-            <a:srgbClr val="1F3864"/>
+            <a:srgbClr val="DFE8F5"/>
           </a:solidFill>
           <a:ln>
             <a:noFill/>
@@ -5248,14 +5857,14 @@
       </p:sp>
       <p:sp>
         <p:nvSpPr>
-          <p:cNvPr id="3" name="TextBox 2"/>
+          <p:cNvPr id="9" name="TextBox 8"/>
           <p:cNvSpPr txBox="1"/>
           <p:nvPr/>
         </p:nvSpPr>
         <p:spPr>
           <a:xfrm>
-            <a:off x="320040" y="137160"/>
-            <a:ext cx="11430000" cy="914400"/>
+            <a:off x="502920" y="4901184"/>
+            <a:ext cx="11155680" cy="1042416"/>
           </a:xfrm>
           <a:prstGeom prst="rect">
             <a:avLst/>
@@ -5264,32 +5873,84 @@
         </p:spPr>
         <p:txBody>
           <a:bodyPr wrap="square">
+            <a:normAutofit/>
+          </a:bodyPr>
+          <a:lstStyle/>
+          <a:p>
+            <a:pPr algn="l"/>
+            <a:r>
+              <a:rPr sz="1200">
+                <a:solidFill>
+                  <a:srgbClr val="1F3864"/>
+                </a:solidFill>
+              </a:rPr>
+              <a:t>Why 3 features? (1) Only glucose, insulin bolus, and carbohydrates are present for ALL 12 patients across both cohorts — the 2018 cohort has heart rate and steps while the 2020 cohort has acceleration instead. No single wearable feature is universal. (2) Using 3 features as the controlled baseline enables the ablation study (Slide 8) to isolate the contribution of each additional signal. (3) The ablation confirmed wearable features consistently degrade performance — the gap to literature is therefore architectural, not feature-driven.</a:t>
+            </a:r>
+          </a:p>
+        </p:txBody>
+      </p:sp>
+      <p:sp>
+        <p:nvSpPr>
+          <p:cNvPr id="10" name="TextBox 9"/>
+          <p:cNvSpPr txBox="1"/>
+          <p:nvPr/>
+        </p:nvSpPr>
+        <p:spPr>
+          <a:xfrm>
+            <a:off x="365760" y="6080760"/>
+            <a:ext cx="11430000" cy="411480"/>
+          </a:xfrm>
+          <a:prstGeom prst="rect">
+            <a:avLst/>
+          </a:prstGeom>
+          <a:noFill/>
+        </p:spPr>
+        <p:txBody>
+          <a:bodyPr wrap="square">
             <a:spAutoFit/>
           </a:bodyPr>
           <a:lstStyle/>
           <a:p>
-            <a:pPr algn="l"/>
-            <a:r>
-              <a:rPr sz="2800" b="1">
+            <a:pPr algn="ctr"/>
+            <a:r>
+              <a:rPr sz="1200" b="1">
                 <a:solidFill>
-                  <a:srgbClr val="FFFFFF"/>
+                  <a:srgbClr val="1F3864"/>
                 </a:solidFill>
               </a:rPr>
-              <a:t>Preprocessing Comparison vs. Literature</a:t>
-            </a:r>
-          </a:p>
-        </p:txBody>
-      </p:sp>
-      <p:sp>
-        <p:nvSpPr>
-          <p:cNvPr id="4" name="Rectangle 3"/>
+              <a:t>Gap to literature explained by reduced feature set (3 vs. 6-7). Grid Search reduced our gap by ~3 mg/dL vs. defaults.</a:t>
+            </a:r>
+          </a:p>
+        </p:txBody>
+      </p:sp>
+    </p:spTree>
+  </p:cSld>
+  <p:clrMapOvr>
+    <a:masterClrMapping/>
+  </p:clrMapOvr>
+</p:sld>
+</file>
+
+<file path=ppt/slides/slide13.xml><?xml version="1.0" encoding="utf-8"?>
+<p:sld xmlns:a="http://schemas.openxmlformats.org/drawingml/2006/main" xmlns:p="http://schemas.openxmlformats.org/presentationml/2006/main" xmlns:r="http://schemas.openxmlformats.org/officeDocument/2006/relationships">
+  <p:cSld>
+    <p:spTree>
+      <p:nvGrpSpPr>
+        <p:cNvPr id="1" name=""/>
+        <p:cNvGrpSpPr/>
+        <p:nvPr/>
+      </p:nvGrpSpPr>
+      <p:grpSpPr/>
+      <p:sp>
+        <p:nvSpPr>
+          <p:cNvPr id="2" name="Rectangle 1"/>
           <p:cNvSpPr/>
           <p:nvPr/>
         </p:nvSpPr>
         <p:spPr>
           <a:xfrm>
-            <a:off x="0" y="6537960"/>
-            <a:ext cx="12188952" cy="320040"/>
+            <a:off x="0" y="0"/>
+            <a:ext cx="12188952" cy="1143000"/>
           </a:xfrm>
           <a:prstGeom prst="rect">
             <a:avLst/>
@@ -5325,6 +5986,83 @@
       </p:sp>
       <p:sp>
         <p:nvSpPr>
+          <p:cNvPr id="3" name="TextBox 2"/>
+          <p:cNvSpPr txBox="1"/>
+          <p:nvPr/>
+        </p:nvSpPr>
+        <p:spPr>
+          <a:xfrm>
+            <a:off x="320040" y="137160"/>
+            <a:ext cx="11430000" cy="914400"/>
+          </a:xfrm>
+          <a:prstGeom prst="rect">
+            <a:avLst/>
+          </a:prstGeom>
+          <a:noFill/>
+        </p:spPr>
+        <p:txBody>
+          <a:bodyPr wrap="square">
+            <a:spAutoFit/>
+          </a:bodyPr>
+          <a:lstStyle/>
+          <a:p>
+            <a:pPr algn="l"/>
+            <a:r>
+              <a:rPr sz="2800" b="1">
+                <a:solidFill>
+                  <a:srgbClr val="FFFFFF"/>
+                </a:solidFill>
+              </a:rPr>
+              <a:t>Preprocessing Comparison vs. Literature</a:t>
+            </a:r>
+          </a:p>
+        </p:txBody>
+      </p:sp>
+      <p:sp>
+        <p:nvSpPr>
+          <p:cNvPr id="4" name="Rectangle 3"/>
+          <p:cNvSpPr/>
+          <p:nvPr/>
+        </p:nvSpPr>
+        <p:spPr>
+          <a:xfrm>
+            <a:off x="0" y="6537960"/>
+            <a:ext cx="12188952" cy="320040"/>
+          </a:xfrm>
+          <a:prstGeom prst="rect">
+            <a:avLst/>
+          </a:prstGeom>
+          <a:solidFill>
+            <a:srgbClr val="1F3864"/>
+          </a:solidFill>
+          <a:ln>
+            <a:noFill/>
+          </a:ln>
+        </p:spPr>
+        <p:style>
+          <a:lnRef idx="1">
+            <a:schemeClr val="accent1"/>
+          </a:lnRef>
+          <a:fillRef idx="3">
+            <a:schemeClr val="accent1"/>
+          </a:fillRef>
+          <a:effectRef idx="2">
+            <a:schemeClr val="accent1"/>
+          </a:effectRef>
+          <a:fontRef idx="minor">
+            <a:schemeClr val="lt1"/>
+          </a:fontRef>
+        </p:style>
+        <p:txBody>
+          <a:bodyPr rtlCol="0" anchor="ctr"/>
+          <a:lstStyle/>
+          <a:p>
+            <a:pPr algn="ctr"/>
+          </a:p>
+        </p:txBody>
+      </p:sp>
+      <p:sp>
+        <p:nvSpPr>
           <p:cNvPr id="5" name="TextBox 4"/>
           <p:cNvSpPr txBox="1"/>
           <p:nvPr/>
@@ -5386,7 +6124,7 @@
                   <a:srgbClr val="FFFFFF"/>
                 </a:solidFill>
               </a:rPr>
-              <a:t>12</a:t>
+              <a:t>13</a:t>
             </a:r>
           </a:p>
         </p:txBody>
@@ -6224,7 +6962,7 @@
 </p:sld>
 </file>
 
-<file path=ppt/slides/slide13.xml><?xml version="1.0" encoding="utf-8"?>
+<file path=ppt/slides/slide14.xml><?xml version="1.0" encoding="utf-8"?>
 <p:sld xmlns:a="http://schemas.openxmlformats.org/drawingml/2006/main" xmlns:p="http://schemas.openxmlformats.org/presentationml/2006/main" xmlns:r="http://schemas.openxmlformats.org/officeDocument/2006/relationships">
   <p:cSld>
     <p:spTree>
@@ -6417,7 +7155,7 @@
                   <a:srgbClr val="FFFFFF"/>
                 </a:solidFill>
               </a:rPr>
-              <a:t>13</a:t>
+              <a:t>14</a:t>
             </a:r>
           </a:p>
         </p:txBody>
@@ -6868,7 +7606,7 @@
 </p:sld>
 </file>
 
-<file path=ppt/slides/slide14.xml><?xml version="1.0" encoding="utf-8"?>
+<file path=ppt/slides/slide15.xml><?xml version="1.0" encoding="utf-8"?>
 <p:sld xmlns:a="http://schemas.openxmlformats.org/drawingml/2006/main" xmlns:p="http://schemas.openxmlformats.org/presentationml/2006/main" xmlns:r="http://schemas.openxmlformats.org/officeDocument/2006/relationships">
   <p:cSld>
     <p:spTree>
@@ -7061,7 +7799,7 @@
                   <a:srgbClr val="FFFFFF"/>
                 </a:solidFill>
               </a:rPr>
-              <a:t>14</a:t>
+              <a:t>15</a:t>
             </a:r>
           </a:p>
         </p:txBody>
@@ -9107,7 +9845,7 @@
         <p:spPr>
           <a:xfrm>
             <a:off x="365760" y="4023360"/>
-            <a:ext cx="11430000" cy="777240"/>
+            <a:ext cx="11430000" cy="594360"/>
           </a:xfrm>
           <a:prstGeom prst="rect">
             <a:avLst/>
@@ -9149,8 +9887,8 @@
         </p:nvSpPr>
         <p:spPr>
           <a:xfrm>
-            <a:off x="548640" y="4114800"/>
-            <a:ext cx="10972800" cy="640080"/>
+            <a:off x="548640" y="4087368"/>
+            <a:ext cx="10972800" cy="502920"/>
           </a:xfrm>
           <a:prstGeom prst="rect">
             <a:avLst/>
@@ -9171,6 +9909,124 @@
                 </a:solidFill>
               </a:rPr>
               <a:t>Grid Search used Walk-Forward Validation  (TimeSeriesSplit, n_splits=3)  on patient 559 — Cerqueira et al. (2020)</a:t>
+            </a:r>
+          </a:p>
+        </p:txBody>
+      </p:sp>
+      <p:sp>
+        <p:nvSpPr>
+          <p:cNvPr id="10" name="TextBox 9"/>
+          <p:cNvSpPr txBox="1"/>
+          <p:nvPr/>
+        </p:nvSpPr>
+        <p:spPr>
+          <a:xfrm>
+            <a:off x="365760" y="4754880"/>
+            <a:ext cx="11430000" cy="1691640"/>
+          </a:xfrm>
+          <a:prstGeom prst="rect">
+            <a:avLst/>
+          </a:prstGeom>
+          <a:noFill/>
+        </p:spPr>
+        <p:txBody>
+          <a:bodyPr wrap="square">
+            <a:normAutofit/>
+          </a:bodyPr>
+          <a:lstStyle/>
+          <a:p>
+            <a:pPr algn="l"/>
+            <a:r>
+              <a:rPr sz="1100" b="1">
+                <a:solidFill>
+                  <a:srgbClr val="1F3864"/>
+                </a:solidFill>
+              </a:rPr>
+              <a:t>RF — Probst et al. (2019): </a:t>
+            </a:r>
+            <a:r>
+              <a:rPr sz="1100" b="0" i="1">
+                <a:solidFill>
+                  <a:srgbClr val="1F3864"/>
+                </a:solidFill>
+              </a:rPr>
+              <a:t>"The number of trees is the most important hyperparameter... with min.node.size and mtry being the most important parameters after ntree."</a:t>
+            </a:r>
+          </a:p>
+          <a:p>
+            <a:pPr algn="l"/>
+            <a:r>
+              <a:rPr sz="1100" b="1">
+                <a:solidFill>
+                  <a:srgbClr val="1F3864"/>
+                </a:solidFill>
+              </a:rPr>
+              <a:t>LSTM — Kingma &amp; Ba (2015): </a:t>
+            </a:r>
+            <a:r>
+              <a:rPr sz="1100" b="0" i="1">
+                <a:solidFill>
+                  <a:srgbClr val="1F3864"/>
+                </a:solidFill>
+              </a:rPr>
+              <a:t>"Good default settings for the tested machine learning problems are α = 0.001, β₁ = 0.9, β₂ = 0.999 and ε = 10⁻⁸."</a:t>
+            </a:r>
+          </a:p>
+          <a:p>
+            <a:pPr algn="l"/>
+            <a:r>
+              <a:rPr sz="1100" b="1">
+                <a:solidFill>
+                  <a:srgbClr val="1F3864"/>
+                </a:solidFill>
+              </a:rPr>
+              <a:t>Autoencoder — Srivastava et al. (2015): </a:t>
+            </a:r>
+            <a:r>
+              <a:rPr sz="1100" b="0" i="1">
+                <a:solidFill>
+                  <a:srgbClr val="1F3864"/>
+                </a:solidFill>
+              </a:rPr>
+              <a:t>"The encoder LSTM reads the input sequence and maps it to a fixed-length vector representation. The decoder LSTM then generates the output sequence from this representation."</a:t>
+            </a:r>
+          </a:p>
+          <a:p>
+            <a:pPr algn="l"/>
+            <a:r>
+              <a:rPr sz="1100" b="1">
+                <a:solidFill>
+                  <a:srgbClr val="1F3864"/>
+                </a:solidFill>
+              </a:rPr>
+              <a:t>TCN — Bai et al. (2018): </a:t>
+            </a:r>
+            <a:r>
+              <a:rPr sz="1100" b="0" i="1">
+                <a:solidFill>
+                  <a:srgbClr val="1F3864"/>
+                </a:solidFill>
+              </a:rPr>
+              <a:t>"We show that TCN outperforms canonical recurrent networks across a diverse range of tasks and datasets."</a:t>
+            </a:r>
+          </a:p>
+          <a:p>
+            <a:pPr algn="l"/>
+            <a:r>
+              <a:rPr sz="1100" b="1">
+                <a:solidFill>
+                  <a:srgbClr val="1F3864"/>
+                </a:solidFill>
+              </a:rPr>
+              <a:t>Transformer — Vaswani et al. (2017): </a:t>
+            </a:r>
+            <a:r>
+              <a:rPr sz="1100" b="0" i="1">
+                <a:solidFill>
+                  <a:srgbClr val="1F3864"/>
+                </a:solidFill>
+              </a:rPr>
+              <a:t>"Multi-head attention allows the model to jointly attend to information from different representation subspaces at different positions."</a:t>
             </a:r>
           </a:p>
         </p:txBody>
@@ -9994,6 +10850,182 @@
           </a:p>
         </p:txBody>
       </p:sp>
+      <p:sp>
+        <p:nvSpPr>
+          <p:cNvPr id="9" name="Rectangle 8"/>
+          <p:cNvSpPr/>
+          <p:nvPr/>
+        </p:nvSpPr>
+        <p:spPr>
+          <a:xfrm>
+            <a:off x="365760" y="4617720"/>
+            <a:ext cx="11430000" cy="1234440"/>
+          </a:xfrm>
+          <a:prstGeom prst="rect">
+            <a:avLst/>
+          </a:prstGeom>
+          <a:solidFill>
+            <a:srgbClr val="FFF0D0"/>
+          </a:solidFill>
+          <a:ln>
+            <a:noFill/>
+          </a:ln>
+        </p:spPr>
+        <p:style>
+          <a:lnRef idx="1">
+            <a:schemeClr val="accent1"/>
+          </a:lnRef>
+          <a:fillRef idx="3">
+            <a:schemeClr val="accent1"/>
+          </a:fillRef>
+          <a:effectRef idx="2">
+            <a:schemeClr val="accent1"/>
+          </a:effectRef>
+          <a:fontRef idx="minor">
+            <a:schemeClr val="lt1"/>
+          </a:fontRef>
+        </p:style>
+        <p:txBody>
+          <a:bodyPr rtlCol="0" anchor="ctr"/>
+          <a:lstStyle/>
+          <a:p>
+            <a:pPr algn="ctr"/>
+          </a:p>
+        </p:txBody>
+      </p:sp>
+      <p:sp>
+        <p:nvSpPr>
+          <p:cNvPr id="10" name="TextBox 9"/>
+          <p:cNvSpPr txBox="1"/>
+          <p:nvPr/>
+        </p:nvSpPr>
+        <p:spPr>
+          <a:xfrm>
+            <a:off x="502920" y="4690872"/>
+            <a:ext cx="11155680" cy="1088136"/>
+          </a:xfrm>
+          <a:prstGeom prst="rect">
+            <a:avLst/>
+          </a:prstGeom>
+          <a:noFill/>
+        </p:spPr>
+        <p:txBody>
+          <a:bodyPr wrap="square">
+            <a:normAutofit/>
+          </a:bodyPr>
+          <a:lstStyle/>
+          <a:p>
+            <a:pPr algn="l"/>
+            <a:r>
+              <a:rPr sz="1300" b="1">
+                <a:solidFill>
+                  <a:srgbClr val="7F4F00"/>
+                </a:solidFill>
+              </a:rPr>
+              <a:t>Why RMSE?</a:t>
+            </a:r>
+          </a:p>
+          <a:p>
+            <a:pPr algn="l"/>
+            <a:r>
+              <a:rPr sz="1200">
+                <a:solidFill>
+                  <a:srgbClr val="7F4F00"/>
+                </a:solidFill>
+              </a:rPr>
+              <a:t>All values are RMSE (Root Mean Squared Error) in mg/dL. RMSE was chosen because: (1) it is the standard metric in all comparison papers (Kalita &amp; Mirza 2025, Xiong 2025, Rodríguez-Rodríguez 2024), enabling direct literature comparison; (2) it penalises large errors more heavily than MAE — clinically appropriate since a 40 mg/dL error is far more dangerous than four 10 mg/dL errors.</a:t>
+            </a:r>
+          </a:p>
+        </p:txBody>
+      </p:sp>
+      <p:sp>
+        <p:nvSpPr>
+          <p:cNvPr id="11" name="Rectangle 10"/>
+          <p:cNvSpPr/>
+          <p:nvPr/>
+        </p:nvSpPr>
+        <p:spPr>
+          <a:xfrm>
+            <a:off x="365760" y="5943600"/>
+            <a:ext cx="11430000" cy="548640"/>
+          </a:xfrm>
+          <a:prstGeom prst="rect">
+            <a:avLst/>
+          </a:prstGeom>
+          <a:solidFill>
+            <a:srgbClr val="E8F5E8"/>
+          </a:solidFill>
+          <a:ln>
+            <a:noFill/>
+          </a:ln>
+        </p:spPr>
+        <p:style>
+          <a:lnRef idx="1">
+            <a:schemeClr val="accent1"/>
+          </a:lnRef>
+          <a:fillRef idx="3">
+            <a:schemeClr val="accent1"/>
+          </a:fillRef>
+          <a:effectRef idx="2">
+            <a:schemeClr val="accent1"/>
+          </a:effectRef>
+          <a:fontRef idx="minor">
+            <a:schemeClr val="lt1"/>
+          </a:fontRef>
+        </p:style>
+        <p:txBody>
+          <a:bodyPr rtlCol="0" anchor="ctr"/>
+          <a:lstStyle/>
+          <a:p>
+            <a:pPr algn="ctr"/>
+          </a:p>
+        </p:txBody>
+      </p:sp>
+      <p:sp>
+        <p:nvSpPr>
+          <p:cNvPr id="12" name="TextBox 11"/>
+          <p:cNvSpPr txBox="1"/>
+          <p:nvPr/>
+        </p:nvSpPr>
+        <p:spPr>
+          <a:xfrm>
+            <a:off x="502920" y="6016752"/>
+            <a:ext cx="11155680" cy="402335"/>
+          </a:xfrm>
+          <a:prstGeom prst="rect">
+            <a:avLst/>
+          </a:prstGeom>
+          <a:noFill/>
+        </p:spPr>
+        <p:txBody>
+          <a:bodyPr wrap="square">
+            <a:normAutofit/>
+          </a:bodyPr>
+          <a:lstStyle/>
+          <a:p>
+            <a:pPr algn="l"/>
+            <a:r>
+              <a:rPr sz="1300" b="1">
+                <a:solidFill>
+                  <a:srgbClr val="1F6B3A"/>
+                </a:solidFill>
+              </a:rPr>
+              <a:t>Why highlighted green?</a:t>
+            </a:r>
+          </a:p>
+          <a:p>
+            <a:pPr algn="l"/>
+            <a:r>
+              <a:rPr sz="1200">
+                <a:solidFill>
+                  <a:srgbClr val="1F6B3A"/>
+                </a:solidFill>
+              </a:rPr>
+              <a:t>LSTM and Autoencoder highlighted: lowest RMSE at 30-minute horizon — the most clinically relevant prediction window for insulin dosing decisions.</a:t>
+            </a:r>
+          </a:p>
+        </p:txBody>
+      </p:sp>
     </p:spTree>
   </p:cSld>
   <p:clrMapOvr>
@@ -10084,7 +11116,7 @@
                   <a:srgbClr val="FFFFFF"/>
                 </a:solidFill>
               </a:rPr>
-              <a:t>Clarke Error Grid</a:t>
+              <a:t>Training Epochs (Early Stopping)</a:t>
             </a:r>
           </a:p>
           <a:p>
@@ -10095,7 +11127,7 @@
                   <a:srgbClr val="BFD7FF"/>
                 </a:solidFill>
               </a:rPr>
-              <a:t>30-min horizon</a:t>
+              <a:t>Number of actual training epochs before early stopping triggered (patience=15, max_epochs=150). Lower = faster convergence.</a:t>
             </a:r>
           </a:p>
         </p:txBody>
@@ -10207,6 +11239,1034 @@
                 </a:solidFill>
               </a:rPr>
               <a:t>6</a:t>
+            </a:r>
+          </a:p>
+        </p:txBody>
+      </p:sp>
+      <p:graphicFrame>
+        <p:nvGraphicFramePr>
+          <p:cNvPr id="7" name="Table 6"/>
+          <p:cNvGraphicFramePr>
+            <a:graphicFrameLocks noGrp="1"/>
+          </p:cNvGraphicFramePr>
+          <p:nvPr/>
+        </p:nvGraphicFramePr>
+        <p:xfrm>
+          <a:off x="365760" y="1554480"/>
+          <a:ext cx="11430000" cy="1920240"/>
+        </p:xfrm>
+        <a:graphic>
+          <a:graphicData uri="http://schemas.openxmlformats.org/drawingml/2006/table">
+            <a:tbl>
+              <a:tblPr firstRow="1" bandRow="1">
+                <a:tableStyleId>{5C22544A-7EE6-4342-B048-85BDC9FD1C3A}</a:tableStyleId>
+              </a:tblPr>
+              <a:tblGrid>
+                <a:gridCol w="2194560"/>
+                <a:gridCol w="1920240"/>
+                <a:gridCol w="1463040"/>
+                <a:gridCol w="1463040"/>
+                <a:gridCol w="1463040"/>
+                <a:gridCol w="2926080"/>
+              </a:tblGrid>
+              <a:tr h="384048">
+                <a:tc>
+                  <a:txBody>
+                    <a:bodyPr wrap="square"/>
+                    <a:lstStyle/>
+                    <a:p>
+                      <a:pPr algn="ctr"/>
+                      <a:r>
+                        <a:rPr sz="1500" b="1">
+                          <a:solidFill>
+                            <a:srgbClr val="FFFFFF"/>
+                          </a:solidFill>
+                        </a:rPr>
+                        <a:t>Model</a:t>
+                      </a:r>
+                    </a:p>
+                  </a:txBody>
+                  <a:tcPr>
+                    <a:solidFill>
+                      <a:srgbClr val="1F3864"/>
+                    </a:solidFill>
+                  </a:tcPr>
+                </a:tc>
+                <a:tc>
+                  <a:txBody>
+                    <a:bodyPr wrap="square"/>
+                    <a:lstStyle/>
+                    <a:p>
+                      <a:pPr algn="ctr"/>
+                      <a:r>
+                        <a:rPr sz="1500" b="1">
+                          <a:solidFill>
+                            <a:srgbClr val="FFFFFF"/>
+                          </a:solidFill>
+                        </a:rPr>
+                        <a:t>Mean epochs</a:t>
+                      </a:r>
+                    </a:p>
+                  </a:txBody>
+                  <a:tcPr>
+                    <a:solidFill>
+                      <a:srgbClr val="1F3864"/>
+                    </a:solidFill>
+                  </a:tcPr>
+                </a:tc>
+                <a:tc>
+                  <a:txBody>
+                    <a:bodyPr wrap="square"/>
+                    <a:lstStyle/>
+                    <a:p>
+                      <a:pPr algn="ctr"/>
+                      <a:r>
+                        <a:rPr sz="1500" b="1">
+                          <a:solidFill>
+                            <a:srgbClr val="FFFFFF"/>
+                          </a:solidFill>
+                        </a:rPr>
+                        <a:t>Std</a:t>
+                      </a:r>
+                    </a:p>
+                  </a:txBody>
+                  <a:tcPr>
+                    <a:solidFill>
+                      <a:srgbClr val="1F3864"/>
+                    </a:solidFill>
+                  </a:tcPr>
+                </a:tc>
+                <a:tc>
+                  <a:txBody>
+                    <a:bodyPr wrap="square"/>
+                    <a:lstStyle/>
+                    <a:p>
+                      <a:pPr algn="ctr"/>
+                      <a:r>
+                        <a:rPr sz="1500" b="1">
+                          <a:solidFill>
+                            <a:srgbClr val="FFFFFF"/>
+                          </a:solidFill>
+                        </a:rPr>
+                        <a:t>Min</a:t>
+                      </a:r>
+                    </a:p>
+                  </a:txBody>
+                  <a:tcPr>
+                    <a:solidFill>
+                      <a:srgbClr val="1F3864"/>
+                    </a:solidFill>
+                  </a:tcPr>
+                </a:tc>
+                <a:tc>
+                  <a:txBody>
+                    <a:bodyPr wrap="square"/>
+                    <a:lstStyle/>
+                    <a:p>
+                      <a:pPr algn="ctr"/>
+                      <a:r>
+                        <a:rPr sz="1500" b="1">
+                          <a:solidFill>
+                            <a:srgbClr val="FFFFFF"/>
+                          </a:solidFill>
+                        </a:rPr>
+                        <a:t>Max</a:t>
+                      </a:r>
+                    </a:p>
+                  </a:txBody>
+                  <a:tcPr>
+                    <a:solidFill>
+                      <a:srgbClr val="1F3864"/>
+                    </a:solidFill>
+                  </a:tcPr>
+                </a:tc>
+                <a:tc>
+                  <a:txBody>
+                    <a:bodyPr wrap="square"/>
+                    <a:lstStyle/>
+                    <a:p>
+                      <a:pPr algn="ctr"/>
+                      <a:r>
+                        <a:rPr sz="1500" b="1">
+                          <a:solidFill>
+                            <a:srgbClr val="FFFFFF"/>
+                          </a:solidFill>
+                        </a:rPr>
+                        <a:t>Note</a:t>
+                      </a:r>
+                    </a:p>
+                  </a:txBody>
+                  <a:tcPr>
+                    <a:solidFill>
+                      <a:srgbClr val="1F3864"/>
+                    </a:solidFill>
+                  </a:tcPr>
+                </a:tc>
+              </a:tr>
+              <a:tr h="384048">
+                <a:tc>
+                  <a:txBody>
+                    <a:bodyPr wrap="square"/>
+                    <a:lstStyle/>
+                    <a:p>
+                      <a:pPr algn="l"/>
+                      <a:r>
+                        <a:rPr sz="1500" b="0">
+                          <a:solidFill>
+                            <a:srgbClr val="000000"/>
+                          </a:solidFill>
+                        </a:rPr>
+                        <a:t>LSTM</a:t>
+                      </a:r>
+                    </a:p>
+                  </a:txBody>
+                  <a:tcPr>
+                    <a:solidFill>
+                      <a:srgbClr val="F2F2F2"/>
+                    </a:solidFill>
+                  </a:tcPr>
+                </a:tc>
+                <a:tc>
+                  <a:txBody>
+                    <a:bodyPr wrap="square"/>
+                    <a:lstStyle/>
+                    <a:p>
+                      <a:pPr algn="ctr"/>
+                      <a:r>
+                        <a:rPr sz="1500" b="0">
+                          <a:solidFill>
+                            <a:srgbClr val="000000"/>
+                          </a:solidFill>
+                        </a:rPr>
+                        <a:t>—</a:t>
+                      </a:r>
+                    </a:p>
+                  </a:txBody>
+                  <a:tcPr>
+                    <a:solidFill>
+                      <a:srgbClr val="F2F2F2"/>
+                    </a:solidFill>
+                  </a:tcPr>
+                </a:tc>
+                <a:tc>
+                  <a:txBody>
+                    <a:bodyPr wrap="square"/>
+                    <a:lstStyle/>
+                    <a:p>
+                      <a:pPr algn="ctr"/>
+                      <a:r>
+                        <a:rPr sz="1500" b="0">
+                          <a:solidFill>
+                            <a:srgbClr val="000000"/>
+                          </a:solidFill>
+                        </a:rPr>
+                        <a:t>—</a:t>
+                      </a:r>
+                    </a:p>
+                  </a:txBody>
+                  <a:tcPr>
+                    <a:solidFill>
+                      <a:srgbClr val="F2F2F2"/>
+                    </a:solidFill>
+                  </a:tcPr>
+                </a:tc>
+                <a:tc>
+                  <a:txBody>
+                    <a:bodyPr wrap="square"/>
+                    <a:lstStyle/>
+                    <a:p>
+                      <a:pPr algn="ctr"/>
+                      <a:r>
+                        <a:rPr sz="1500" b="0">
+                          <a:solidFill>
+                            <a:srgbClr val="000000"/>
+                          </a:solidFill>
+                        </a:rPr>
+                        <a:t>—</a:t>
+                      </a:r>
+                    </a:p>
+                  </a:txBody>
+                  <a:tcPr>
+                    <a:solidFill>
+                      <a:srgbClr val="F2F2F2"/>
+                    </a:solidFill>
+                  </a:tcPr>
+                </a:tc>
+                <a:tc>
+                  <a:txBody>
+                    <a:bodyPr wrap="square"/>
+                    <a:lstStyle/>
+                    <a:p>
+                      <a:pPr algn="ctr"/>
+                      <a:r>
+                        <a:rPr sz="1500" b="0">
+                          <a:solidFill>
+                            <a:srgbClr val="000000"/>
+                          </a:solidFill>
+                        </a:rPr>
+                        <a:t>—</a:t>
+                      </a:r>
+                    </a:p>
+                  </a:txBody>
+                  <a:tcPr>
+                    <a:solidFill>
+                      <a:srgbClr val="F2F2F2"/>
+                    </a:solidFill>
+                  </a:tcPr>
+                </a:tc>
+                <a:tc>
+                  <a:txBody>
+                    <a:bodyPr wrap="square"/>
+                    <a:lstStyle/>
+                    <a:p>
+                      <a:pPr algn="ctr"/>
+                      <a:r>
+                        <a:rPr sz="1500" b="0">
+                          <a:solidFill>
+                            <a:srgbClr val="000000"/>
+                          </a:solidFill>
+                        </a:rPr>
+                        <a:t>Awaiting re-run</a:t>
+                      </a:r>
+                    </a:p>
+                  </a:txBody>
+                  <a:tcPr>
+                    <a:solidFill>
+                      <a:srgbClr val="F2F2F2"/>
+                    </a:solidFill>
+                  </a:tcPr>
+                </a:tc>
+              </a:tr>
+              <a:tr h="384048">
+                <a:tc>
+                  <a:txBody>
+                    <a:bodyPr wrap="square"/>
+                    <a:lstStyle/>
+                    <a:p>
+                      <a:pPr algn="l"/>
+                      <a:r>
+                        <a:rPr sz="1500" b="0">
+                          <a:solidFill>
+                            <a:srgbClr val="000000"/>
+                          </a:solidFill>
+                        </a:rPr>
+                        <a:t>Autoencoder</a:t>
+                      </a:r>
+                    </a:p>
+                  </a:txBody>
+                  <a:tcPr>
+                    <a:solidFill>
+                      <a:srgbClr val="FFFFFF"/>
+                    </a:solidFill>
+                  </a:tcPr>
+                </a:tc>
+                <a:tc>
+                  <a:txBody>
+                    <a:bodyPr wrap="square"/>
+                    <a:lstStyle/>
+                    <a:p>
+                      <a:pPr algn="ctr"/>
+                      <a:r>
+                        <a:rPr sz="1500" b="0">
+                          <a:solidFill>
+                            <a:srgbClr val="000000"/>
+                          </a:solidFill>
+                        </a:rPr>
+                        <a:t>—</a:t>
+                      </a:r>
+                    </a:p>
+                  </a:txBody>
+                  <a:tcPr>
+                    <a:solidFill>
+                      <a:srgbClr val="FFFFFF"/>
+                    </a:solidFill>
+                  </a:tcPr>
+                </a:tc>
+                <a:tc>
+                  <a:txBody>
+                    <a:bodyPr wrap="square"/>
+                    <a:lstStyle/>
+                    <a:p>
+                      <a:pPr algn="ctr"/>
+                      <a:r>
+                        <a:rPr sz="1500" b="0">
+                          <a:solidFill>
+                            <a:srgbClr val="000000"/>
+                          </a:solidFill>
+                        </a:rPr>
+                        <a:t>—</a:t>
+                      </a:r>
+                    </a:p>
+                  </a:txBody>
+                  <a:tcPr>
+                    <a:solidFill>
+                      <a:srgbClr val="FFFFFF"/>
+                    </a:solidFill>
+                  </a:tcPr>
+                </a:tc>
+                <a:tc>
+                  <a:txBody>
+                    <a:bodyPr wrap="square"/>
+                    <a:lstStyle/>
+                    <a:p>
+                      <a:pPr algn="ctr"/>
+                      <a:r>
+                        <a:rPr sz="1500" b="0">
+                          <a:solidFill>
+                            <a:srgbClr val="000000"/>
+                          </a:solidFill>
+                        </a:rPr>
+                        <a:t>—</a:t>
+                      </a:r>
+                    </a:p>
+                  </a:txBody>
+                  <a:tcPr>
+                    <a:solidFill>
+                      <a:srgbClr val="FFFFFF"/>
+                    </a:solidFill>
+                  </a:tcPr>
+                </a:tc>
+                <a:tc>
+                  <a:txBody>
+                    <a:bodyPr wrap="square"/>
+                    <a:lstStyle/>
+                    <a:p>
+                      <a:pPr algn="ctr"/>
+                      <a:r>
+                        <a:rPr sz="1500" b="0">
+                          <a:solidFill>
+                            <a:srgbClr val="000000"/>
+                          </a:solidFill>
+                        </a:rPr>
+                        <a:t>—</a:t>
+                      </a:r>
+                    </a:p>
+                  </a:txBody>
+                  <a:tcPr>
+                    <a:solidFill>
+                      <a:srgbClr val="FFFFFF"/>
+                    </a:solidFill>
+                  </a:tcPr>
+                </a:tc>
+                <a:tc>
+                  <a:txBody>
+                    <a:bodyPr wrap="square"/>
+                    <a:lstStyle/>
+                    <a:p>
+                      <a:pPr algn="ctr"/>
+                      <a:r>
+                        <a:rPr sz="1500" b="0">
+                          <a:solidFill>
+                            <a:srgbClr val="000000"/>
+                          </a:solidFill>
+                        </a:rPr>
+                        <a:t>Awaiting re-run</a:t>
+                      </a:r>
+                    </a:p>
+                  </a:txBody>
+                  <a:tcPr>
+                    <a:solidFill>
+                      <a:srgbClr val="FFFFFF"/>
+                    </a:solidFill>
+                  </a:tcPr>
+                </a:tc>
+              </a:tr>
+              <a:tr h="384048">
+                <a:tc>
+                  <a:txBody>
+                    <a:bodyPr wrap="square"/>
+                    <a:lstStyle/>
+                    <a:p>
+                      <a:pPr algn="l"/>
+                      <a:r>
+                        <a:rPr sz="1500" b="0">
+                          <a:solidFill>
+                            <a:srgbClr val="000000"/>
+                          </a:solidFill>
+                        </a:rPr>
+                        <a:t>TCN</a:t>
+                      </a:r>
+                    </a:p>
+                  </a:txBody>
+                  <a:tcPr>
+                    <a:solidFill>
+                      <a:srgbClr val="F2F2F2"/>
+                    </a:solidFill>
+                  </a:tcPr>
+                </a:tc>
+                <a:tc>
+                  <a:txBody>
+                    <a:bodyPr wrap="square"/>
+                    <a:lstStyle/>
+                    <a:p>
+                      <a:pPr algn="ctr"/>
+                      <a:r>
+                        <a:rPr sz="1500" b="0">
+                          <a:solidFill>
+                            <a:srgbClr val="000000"/>
+                          </a:solidFill>
+                        </a:rPr>
+                        <a:t>—</a:t>
+                      </a:r>
+                    </a:p>
+                  </a:txBody>
+                  <a:tcPr>
+                    <a:solidFill>
+                      <a:srgbClr val="F2F2F2"/>
+                    </a:solidFill>
+                  </a:tcPr>
+                </a:tc>
+                <a:tc>
+                  <a:txBody>
+                    <a:bodyPr wrap="square"/>
+                    <a:lstStyle/>
+                    <a:p>
+                      <a:pPr algn="ctr"/>
+                      <a:r>
+                        <a:rPr sz="1500" b="0">
+                          <a:solidFill>
+                            <a:srgbClr val="000000"/>
+                          </a:solidFill>
+                        </a:rPr>
+                        <a:t>—</a:t>
+                      </a:r>
+                    </a:p>
+                  </a:txBody>
+                  <a:tcPr>
+                    <a:solidFill>
+                      <a:srgbClr val="F2F2F2"/>
+                    </a:solidFill>
+                  </a:tcPr>
+                </a:tc>
+                <a:tc>
+                  <a:txBody>
+                    <a:bodyPr wrap="square"/>
+                    <a:lstStyle/>
+                    <a:p>
+                      <a:pPr algn="ctr"/>
+                      <a:r>
+                        <a:rPr sz="1500" b="0">
+                          <a:solidFill>
+                            <a:srgbClr val="000000"/>
+                          </a:solidFill>
+                        </a:rPr>
+                        <a:t>—</a:t>
+                      </a:r>
+                    </a:p>
+                  </a:txBody>
+                  <a:tcPr>
+                    <a:solidFill>
+                      <a:srgbClr val="F2F2F2"/>
+                    </a:solidFill>
+                  </a:tcPr>
+                </a:tc>
+                <a:tc>
+                  <a:txBody>
+                    <a:bodyPr wrap="square"/>
+                    <a:lstStyle/>
+                    <a:p>
+                      <a:pPr algn="ctr"/>
+                      <a:r>
+                        <a:rPr sz="1500" b="0">
+                          <a:solidFill>
+                            <a:srgbClr val="000000"/>
+                          </a:solidFill>
+                        </a:rPr>
+                        <a:t>—</a:t>
+                      </a:r>
+                    </a:p>
+                  </a:txBody>
+                  <a:tcPr>
+                    <a:solidFill>
+                      <a:srgbClr val="F2F2F2"/>
+                    </a:solidFill>
+                  </a:tcPr>
+                </a:tc>
+                <a:tc>
+                  <a:txBody>
+                    <a:bodyPr wrap="square"/>
+                    <a:lstStyle/>
+                    <a:p>
+                      <a:pPr algn="ctr"/>
+                      <a:r>
+                        <a:rPr sz="1500" b="0">
+                          <a:solidFill>
+                            <a:srgbClr val="000000"/>
+                          </a:solidFill>
+                        </a:rPr>
+                        <a:t>Awaiting re-run</a:t>
+                      </a:r>
+                    </a:p>
+                  </a:txBody>
+                  <a:tcPr>
+                    <a:solidFill>
+                      <a:srgbClr val="F2F2F2"/>
+                    </a:solidFill>
+                  </a:tcPr>
+                </a:tc>
+              </a:tr>
+              <a:tr h="384048">
+                <a:tc>
+                  <a:txBody>
+                    <a:bodyPr wrap="square"/>
+                    <a:lstStyle/>
+                    <a:p>
+                      <a:pPr algn="l"/>
+                      <a:r>
+                        <a:rPr sz="1500" b="0">
+                          <a:solidFill>
+                            <a:srgbClr val="000000"/>
+                          </a:solidFill>
+                        </a:rPr>
+                        <a:t>Transformer</a:t>
+                      </a:r>
+                    </a:p>
+                  </a:txBody>
+                  <a:tcPr>
+                    <a:solidFill>
+                      <a:srgbClr val="FFFFFF"/>
+                    </a:solidFill>
+                  </a:tcPr>
+                </a:tc>
+                <a:tc>
+                  <a:txBody>
+                    <a:bodyPr wrap="square"/>
+                    <a:lstStyle/>
+                    <a:p>
+                      <a:pPr algn="ctr"/>
+                      <a:r>
+                        <a:rPr sz="1500" b="0">
+                          <a:solidFill>
+                            <a:srgbClr val="000000"/>
+                          </a:solidFill>
+                        </a:rPr>
+                        <a:t>—</a:t>
+                      </a:r>
+                    </a:p>
+                  </a:txBody>
+                  <a:tcPr>
+                    <a:solidFill>
+                      <a:srgbClr val="FFFFFF"/>
+                    </a:solidFill>
+                  </a:tcPr>
+                </a:tc>
+                <a:tc>
+                  <a:txBody>
+                    <a:bodyPr wrap="square"/>
+                    <a:lstStyle/>
+                    <a:p>
+                      <a:pPr algn="ctr"/>
+                      <a:r>
+                        <a:rPr sz="1500" b="0">
+                          <a:solidFill>
+                            <a:srgbClr val="000000"/>
+                          </a:solidFill>
+                        </a:rPr>
+                        <a:t>—</a:t>
+                      </a:r>
+                    </a:p>
+                  </a:txBody>
+                  <a:tcPr>
+                    <a:solidFill>
+                      <a:srgbClr val="FFFFFF"/>
+                    </a:solidFill>
+                  </a:tcPr>
+                </a:tc>
+                <a:tc>
+                  <a:txBody>
+                    <a:bodyPr wrap="square"/>
+                    <a:lstStyle/>
+                    <a:p>
+                      <a:pPr algn="ctr"/>
+                      <a:r>
+                        <a:rPr sz="1500" b="0">
+                          <a:solidFill>
+                            <a:srgbClr val="000000"/>
+                          </a:solidFill>
+                        </a:rPr>
+                        <a:t>—</a:t>
+                      </a:r>
+                    </a:p>
+                  </a:txBody>
+                  <a:tcPr>
+                    <a:solidFill>
+                      <a:srgbClr val="FFFFFF"/>
+                    </a:solidFill>
+                  </a:tcPr>
+                </a:tc>
+                <a:tc>
+                  <a:txBody>
+                    <a:bodyPr wrap="square"/>
+                    <a:lstStyle/>
+                    <a:p>
+                      <a:pPr algn="ctr"/>
+                      <a:r>
+                        <a:rPr sz="1500" b="0">
+                          <a:solidFill>
+                            <a:srgbClr val="000000"/>
+                          </a:solidFill>
+                        </a:rPr>
+                        <a:t>—</a:t>
+                      </a:r>
+                    </a:p>
+                  </a:txBody>
+                  <a:tcPr>
+                    <a:solidFill>
+                      <a:srgbClr val="FFFFFF"/>
+                    </a:solidFill>
+                  </a:tcPr>
+                </a:tc>
+                <a:tc>
+                  <a:txBody>
+                    <a:bodyPr wrap="square"/>
+                    <a:lstStyle/>
+                    <a:p>
+                      <a:pPr algn="ctr"/>
+                      <a:r>
+                        <a:rPr sz="1500" b="0">
+                          <a:solidFill>
+                            <a:srgbClr val="000000"/>
+                          </a:solidFill>
+                        </a:rPr>
+                        <a:t>Awaiting re-run</a:t>
+                      </a:r>
+                    </a:p>
+                  </a:txBody>
+                  <a:tcPr>
+                    <a:solidFill>
+                      <a:srgbClr val="FFFFFF"/>
+                    </a:solidFill>
+                  </a:tcPr>
+                </a:tc>
+              </a:tr>
+            </a:tbl>
+          </a:graphicData>
+        </a:graphic>
+      </p:graphicFrame>
+      <p:sp>
+        <p:nvSpPr>
+          <p:cNvPr id="8" name="Rectangle 7"/>
+          <p:cNvSpPr/>
+          <p:nvPr/>
+        </p:nvSpPr>
+        <p:spPr>
+          <a:xfrm>
+            <a:off x="365760" y="3749039"/>
+            <a:ext cx="11430000" cy="914400"/>
+          </a:xfrm>
+          <a:prstGeom prst="rect">
+            <a:avLst/>
+          </a:prstGeom>
+          <a:solidFill>
+            <a:srgbClr val="DFE8F5"/>
+          </a:solidFill>
+          <a:ln>
+            <a:noFill/>
+          </a:ln>
+        </p:spPr>
+        <p:style>
+          <a:lnRef idx="1">
+            <a:schemeClr val="accent1"/>
+          </a:lnRef>
+          <a:fillRef idx="3">
+            <a:schemeClr val="accent1"/>
+          </a:fillRef>
+          <a:effectRef idx="2">
+            <a:schemeClr val="accent1"/>
+          </a:effectRef>
+          <a:fontRef idx="minor">
+            <a:schemeClr val="lt1"/>
+          </a:fontRef>
+        </p:style>
+        <p:txBody>
+          <a:bodyPr rtlCol="0" anchor="ctr"/>
+          <a:lstStyle/>
+          <a:p>
+            <a:pPr algn="ctr"/>
+          </a:p>
+        </p:txBody>
+      </p:sp>
+      <p:sp>
+        <p:nvSpPr>
+          <p:cNvPr id="9" name="TextBox 8"/>
+          <p:cNvSpPr txBox="1"/>
+          <p:nvPr/>
+        </p:nvSpPr>
+        <p:spPr>
+          <a:xfrm>
+            <a:off x="502920" y="3822191"/>
+            <a:ext cx="11155680" cy="768096"/>
+          </a:xfrm>
+          <a:prstGeom prst="rect">
+            <a:avLst/>
+          </a:prstGeom>
+          <a:noFill/>
+        </p:spPr>
+        <p:txBody>
+          <a:bodyPr wrap="square">
+            <a:normAutofit/>
+          </a:bodyPr>
+          <a:lstStyle/>
+          <a:p>
+            <a:pPr algn="l"/>
+            <a:r>
+              <a:rPr sz="1300">
+                <a:solidFill>
+                  <a:srgbClr val="1F3864"/>
+                </a:solidFill>
+              </a:rPr>
+              <a:t>Epoch counts recorded per patient. Full results available after experiment re-run completes. Early stopping prevents overfitting — training stops when validation loss does not improve for 15 consecutive epochs.</a:t>
+            </a:r>
+          </a:p>
+        </p:txBody>
+      </p:sp>
+      <p:sp>
+        <p:nvSpPr>
+          <p:cNvPr id="10" name="TextBox 9"/>
+          <p:cNvSpPr txBox="1"/>
+          <p:nvPr/>
+        </p:nvSpPr>
+        <p:spPr>
+          <a:xfrm>
+            <a:off x="365760" y="5943600"/>
+            <a:ext cx="11430000" cy="457200"/>
+          </a:xfrm>
+          <a:prstGeom prst="rect">
+            <a:avLst/>
+          </a:prstGeom>
+          <a:noFill/>
+        </p:spPr>
+        <p:txBody>
+          <a:bodyPr wrap="square">
+            <a:spAutoFit/>
+          </a:bodyPr>
+          <a:lstStyle/>
+          <a:p>
+            <a:pPr algn="l"/>
+            <a:r>
+              <a:rPr sz="1100" b="0">
+                <a:solidFill>
+                  <a:srgbClr val="2E5496"/>
+                </a:solidFill>
+              </a:rPr>
+              <a:t>Early stopping reference: Prechelt (1998), 'Early Stopping — But When?', Neural Networks: Tricks of the Trade.</a:t>
+            </a:r>
+          </a:p>
+        </p:txBody>
+      </p:sp>
+    </p:spTree>
+  </p:cSld>
+  <p:clrMapOvr>
+    <a:masterClrMapping/>
+  </p:clrMapOvr>
+</p:sld>
+</file>
+
+<file path=ppt/slides/slide7.xml><?xml version="1.0" encoding="utf-8"?>
+<p:sld xmlns:a="http://schemas.openxmlformats.org/drawingml/2006/main" xmlns:p="http://schemas.openxmlformats.org/presentationml/2006/main" xmlns:r="http://schemas.openxmlformats.org/officeDocument/2006/relationships">
+  <p:cSld>
+    <p:spTree>
+      <p:nvGrpSpPr>
+        <p:cNvPr id="1" name=""/>
+        <p:cNvGrpSpPr/>
+        <p:nvPr/>
+      </p:nvGrpSpPr>
+      <p:grpSpPr/>
+      <p:sp>
+        <p:nvSpPr>
+          <p:cNvPr id="2" name="Rectangle 1"/>
+          <p:cNvSpPr/>
+          <p:nvPr/>
+        </p:nvSpPr>
+        <p:spPr>
+          <a:xfrm>
+            <a:off x="0" y="0"/>
+            <a:ext cx="12188952" cy="1143000"/>
+          </a:xfrm>
+          <a:prstGeom prst="rect">
+            <a:avLst/>
+          </a:prstGeom>
+          <a:solidFill>
+            <a:srgbClr val="1F3864"/>
+          </a:solidFill>
+          <a:ln>
+            <a:noFill/>
+          </a:ln>
+        </p:spPr>
+        <p:style>
+          <a:lnRef idx="1">
+            <a:schemeClr val="accent1"/>
+          </a:lnRef>
+          <a:fillRef idx="3">
+            <a:schemeClr val="accent1"/>
+          </a:fillRef>
+          <a:effectRef idx="2">
+            <a:schemeClr val="accent1"/>
+          </a:effectRef>
+          <a:fontRef idx="minor">
+            <a:schemeClr val="lt1"/>
+          </a:fontRef>
+        </p:style>
+        <p:txBody>
+          <a:bodyPr rtlCol="0" anchor="ctr"/>
+          <a:lstStyle/>
+          <a:p>
+            <a:pPr algn="ctr"/>
+          </a:p>
+        </p:txBody>
+      </p:sp>
+      <p:sp>
+        <p:nvSpPr>
+          <p:cNvPr id="3" name="TextBox 2"/>
+          <p:cNvSpPr txBox="1"/>
+          <p:nvPr/>
+        </p:nvSpPr>
+        <p:spPr>
+          <a:xfrm>
+            <a:off x="320040" y="137160"/>
+            <a:ext cx="11430000" cy="914400"/>
+          </a:xfrm>
+          <a:prstGeom prst="rect">
+            <a:avLst/>
+          </a:prstGeom>
+          <a:noFill/>
+        </p:spPr>
+        <p:txBody>
+          <a:bodyPr wrap="square">
+            <a:spAutoFit/>
+          </a:bodyPr>
+          <a:lstStyle/>
+          <a:p>
+            <a:pPr algn="l"/>
+            <a:r>
+              <a:rPr sz="2800" b="1">
+                <a:solidFill>
+                  <a:srgbClr val="FFFFFF"/>
+                </a:solidFill>
+              </a:rPr>
+              <a:t>Clarke Error Grid</a:t>
+            </a:r>
+          </a:p>
+          <a:p>
+            <a:pPr algn="l"/>
+            <a:r>
+              <a:rPr sz="1400" b="0">
+                <a:solidFill>
+                  <a:srgbClr val="BFD7FF"/>
+                </a:solidFill>
+              </a:rPr>
+              <a:t>30-min horizon</a:t>
+            </a:r>
+          </a:p>
+        </p:txBody>
+      </p:sp>
+      <p:sp>
+        <p:nvSpPr>
+          <p:cNvPr id="4" name="Rectangle 3"/>
+          <p:cNvSpPr/>
+          <p:nvPr/>
+        </p:nvSpPr>
+        <p:spPr>
+          <a:xfrm>
+            <a:off x="0" y="6537960"/>
+            <a:ext cx="12188952" cy="320040"/>
+          </a:xfrm>
+          <a:prstGeom prst="rect">
+            <a:avLst/>
+          </a:prstGeom>
+          <a:solidFill>
+            <a:srgbClr val="1F3864"/>
+          </a:solidFill>
+          <a:ln>
+            <a:noFill/>
+          </a:ln>
+        </p:spPr>
+        <p:style>
+          <a:lnRef idx="1">
+            <a:schemeClr val="accent1"/>
+          </a:lnRef>
+          <a:fillRef idx="3">
+            <a:schemeClr val="accent1"/>
+          </a:fillRef>
+          <a:effectRef idx="2">
+            <a:schemeClr val="accent1"/>
+          </a:effectRef>
+          <a:fontRef idx="minor">
+            <a:schemeClr val="lt1"/>
+          </a:fontRef>
+        </p:style>
+        <p:txBody>
+          <a:bodyPr rtlCol="0" anchor="ctr"/>
+          <a:lstStyle/>
+          <a:p>
+            <a:pPr algn="ctr"/>
+          </a:p>
+        </p:txBody>
+      </p:sp>
+      <p:sp>
+        <p:nvSpPr>
+          <p:cNvPr id="5" name="TextBox 4"/>
+          <p:cNvSpPr txBox="1"/>
+          <p:nvPr/>
+        </p:nvSpPr>
+        <p:spPr>
+          <a:xfrm>
+            <a:off x="182880" y="6556248"/>
+            <a:ext cx="9144000" cy="274320"/>
+          </a:xfrm>
+          <a:prstGeom prst="rect">
+            <a:avLst/>
+          </a:prstGeom>
+          <a:noFill/>
+        </p:spPr>
+        <p:txBody>
+          <a:bodyPr wrap="square">
+            <a:spAutoFit/>
+          </a:bodyPr>
+          <a:lstStyle/>
+          <a:p>
+            <a:pPr algn="l"/>
+            <a:r>
+              <a:rPr sz="1000" b="0">
+                <a:solidFill>
+                  <a:srgbClr val="FFFFFF"/>
+                </a:solidFill>
+              </a:rPr>
+              <a:t>Blood Glucose Forecasting  |  University of Duisburg-Essen</a:t>
+            </a:r>
+          </a:p>
+        </p:txBody>
+      </p:sp>
+      <p:sp>
+        <p:nvSpPr>
+          <p:cNvPr id="6" name="TextBox 5"/>
+          <p:cNvSpPr txBox="1"/>
+          <p:nvPr/>
+        </p:nvSpPr>
+        <p:spPr>
+          <a:xfrm>
+            <a:off x="11430000" y="6556248"/>
+            <a:ext cx="640080" cy="274320"/>
+          </a:xfrm>
+          <a:prstGeom prst="rect">
+            <a:avLst/>
+          </a:prstGeom>
+          <a:noFill/>
+        </p:spPr>
+        <p:txBody>
+          <a:bodyPr wrap="square">
+            <a:spAutoFit/>
+          </a:bodyPr>
+          <a:lstStyle/>
+          <a:p>
+            <a:pPr algn="r"/>
+            <a:r>
+              <a:rPr sz="1000" b="1">
+                <a:solidFill>
+                  <a:srgbClr val="FFFFFF"/>
+                </a:solidFill>
+              </a:rPr>
+              <a:t>7</a:t>
             </a:r>
           </a:p>
         </p:txBody>
@@ -10758,7 +12818,7 @@
 </p:sld>
 </file>
 
-<file path=ppt/slides/slide7.xml><?xml version="1.0" encoding="utf-8"?>
+<file path=ppt/slides/slide8.xml><?xml version="1.0" encoding="utf-8"?>
 <p:sld xmlns:a="http://schemas.openxmlformats.org/drawingml/2006/main" xmlns:p="http://schemas.openxmlformats.org/presentationml/2006/main" xmlns:r="http://schemas.openxmlformats.org/officeDocument/2006/relationships">
   <p:cSld>
     <p:spTree>
@@ -10951,7 +13011,7 @@
                   <a:srgbClr val="FFFFFF"/>
                 </a:solidFill>
               </a:rPr>
-              <a:t>7</a:t>
+              <a:t>8</a:t>
             </a:r>
           </a:p>
         </p:txBody>
@@ -11392,7 +13452,7 @@
 </p:sld>
 </file>
 
-<file path=ppt/slides/slide8.xml><?xml version="1.0" encoding="utf-8"?>
+<file path=ppt/slides/slide9.xml><?xml version="1.0" encoding="utf-8"?>
 <p:sld xmlns:a="http://schemas.openxmlformats.org/drawingml/2006/main" xmlns:p="http://schemas.openxmlformats.org/presentationml/2006/main" xmlns:r="http://schemas.openxmlformats.org/officeDocument/2006/relationships">
   <p:cSld>
     <p:spTree>
@@ -11585,7 +13645,7 @@
                   <a:srgbClr val="FFFFFF"/>
                 </a:solidFill>
               </a:rPr>
-              <a:t>8</a:t>
+              <a:t>9</a:t>
             </a:r>
           </a:p>
         </p:txBody>
@@ -12031,666 +14091,6 @@
               <a:t>A population model trained on 11 patients generalises almost as well as a personalised model for a new unseen patient.
 RF actually improves with pooling — more data outweighs loss of patient-specificity.
 Clinical implication: one deployed model could serve new patients without requiring 8 weeks of personalised data.</a:t>
-            </a:r>
-          </a:p>
-        </p:txBody>
-      </p:sp>
-    </p:spTree>
-  </p:cSld>
-  <p:clrMapOvr>
-    <a:masterClrMapping/>
-  </p:clrMapOvr>
-</p:sld>
-</file>
-
-<file path=ppt/slides/slide9.xml><?xml version="1.0" encoding="utf-8"?>
-<p:sld xmlns:a="http://schemas.openxmlformats.org/drawingml/2006/main" xmlns:p="http://schemas.openxmlformats.org/presentationml/2006/main" xmlns:r="http://schemas.openxmlformats.org/officeDocument/2006/relationships">
-  <p:cSld>
-    <p:spTree>
-      <p:nvGrpSpPr>
-        <p:cNvPr id="1" name=""/>
-        <p:cNvGrpSpPr/>
-        <p:nvPr/>
-      </p:nvGrpSpPr>
-      <p:grpSpPr/>
-      <p:sp>
-        <p:nvSpPr>
-          <p:cNvPr id="2" name="Rectangle 1"/>
-          <p:cNvSpPr/>
-          <p:nvPr/>
-        </p:nvSpPr>
-        <p:spPr>
-          <a:xfrm>
-            <a:off x="0" y="0"/>
-            <a:ext cx="12188952" cy="1143000"/>
-          </a:xfrm>
-          <a:prstGeom prst="rect">
-            <a:avLst/>
-          </a:prstGeom>
-          <a:solidFill>
-            <a:srgbClr val="1F3864"/>
-          </a:solidFill>
-          <a:ln>
-            <a:noFill/>
-          </a:ln>
-        </p:spPr>
-        <p:style>
-          <a:lnRef idx="1">
-            <a:schemeClr val="accent1"/>
-          </a:lnRef>
-          <a:fillRef idx="3">
-            <a:schemeClr val="accent1"/>
-          </a:fillRef>
-          <a:effectRef idx="2">
-            <a:schemeClr val="accent1"/>
-          </a:effectRef>
-          <a:fontRef idx="minor">
-            <a:schemeClr val="lt1"/>
-          </a:fontRef>
-        </p:style>
-        <p:txBody>
-          <a:bodyPr rtlCol="0" anchor="ctr"/>
-          <a:lstStyle/>
-          <a:p>
-            <a:pPr algn="ctr"/>
-          </a:p>
-        </p:txBody>
-      </p:sp>
-      <p:sp>
-        <p:nvSpPr>
-          <p:cNvPr id="3" name="TextBox 2"/>
-          <p:cNvSpPr txBox="1"/>
-          <p:nvPr/>
-        </p:nvSpPr>
-        <p:spPr>
-          <a:xfrm>
-            <a:off x="320040" y="137160"/>
-            <a:ext cx="11430000" cy="914400"/>
-          </a:xfrm>
-          <a:prstGeom prst="rect">
-            <a:avLst/>
-          </a:prstGeom>
-          <a:noFill/>
-        </p:spPr>
-        <p:txBody>
-          <a:bodyPr wrap="square">
-            <a:spAutoFit/>
-          </a:bodyPr>
-          <a:lstStyle/>
-          <a:p>
-            <a:pPr algn="l"/>
-            <a:r>
-              <a:rPr sz="2800" b="1">
-                <a:solidFill>
-                  <a:srgbClr val="FFFFFF"/>
-                </a:solidFill>
-              </a:rPr>
-              <a:t>Transfer Learning: Domain Shift Costs ~1-2 mg/dL</a:t>
-            </a:r>
-          </a:p>
-        </p:txBody>
-      </p:sp>
-      <p:sp>
-        <p:nvSpPr>
-          <p:cNvPr id="4" name="Rectangle 3"/>
-          <p:cNvSpPr/>
-          <p:nvPr/>
-        </p:nvSpPr>
-        <p:spPr>
-          <a:xfrm>
-            <a:off x="0" y="6537960"/>
-            <a:ext cx="12188952" cy="320040"/>
-          </a:xfrm>
-          <a:prstGeom prst="rect">
-            <a:avLst/>
-          </a:prstGeom>
-          <a:solidFill>
-            <a:srgbClr val="1F3864"/>
-          </a:solidFill>
-          <a:ln>
-            <a:noFill/>
-          </a:ln>
-        </p:spPr>
-        <p:style>
-          <a:lnRef idx="1">
-            <a:schemeClr val="accent1"/>
-          </a:lnRef>
-          <a:fillRef idx="3">
-            <a:schemeClr val="accent1"/>
-          </a:fillRef>
-          <a:effectRef idx="2">
-            <a:schemeClr val="accent1"/>
-          </a:effectRef>
-          <a:fontRef idx="minor">
-            <a:schemeClr val="lt1"/>
-          </a:fontRef>
-        </p:style>
-        <p:txBody>
-          <a:bodyPr rtlCol="0" anchor="ctr"/>
-          <a:lstStyle/>
-          <a:p>
-            <a:pPr algn="ctr"/>
-          </a:p>
-        </p:txBody>
-      </p:sp>
-      <p:sp>
-        <p:nvSpPr>
-          <p:cNvPr id="5" name="TextBox 4"/>
-          <p:cNvSpPr txBox="1"/>
-          <p:nvPr/>
-        </p:nvSpPr>
-        <p:spPr>
-          <a:xfrm>
-            <a:off x="182880" y="6556248"/>
-            <a:ext cx="9144000" cy="274320"/>
-          </a:xfrm>
-          <a:prstGeom prst="rect">
-            <a:avLst/>
-          </a:prstGeom>
-          <a:noFill/>
-        </p:spPr>
-        <p:txBody>
-          <a:bodyPr wrap="square">
-            <a:spAutoFit/>
-          </a:bodyPr>
-          <a:lstStyle/>
-          <a:p>
-            <a:pPr algn="l"/>
-            <a:r>
-              <a:rPr sz="1000" b="0">
-                <a:solidFill>
-                  <a:srgbClr val="FFFFFF"/>
-                </a:solidFill>
-              </a:rPr>
-              <a:t>Blood Glucose Forecasting  |  University of Duisburg-Essen</a:t>
-            </a:r>
-          </a:p>
-        </p:txBody>
-      </p:sp>
-      <p:sp>
-        <p:nvSpPr>
-          <p:cNvPr id="6" name="TextBox 5"/>
-          <p:cNvSpPr txBox="1"/>
-          <p:nvPr/>
-        </p:nvSpPr>
-        <p:spPr>
-          <a:xfrm>
-            <a:off x="11430000" y="6556248"/>
-            <a:ext cx="640080" cy="274320"/>
-          </a:xfrm>
-          <a:prstGeom prst="rect">
-            <a:avLst/>
-          </a:prstGeom>
-          <a:noFill/>
-        </p:spPr>
-        <p:txBody>
-          <a:bodyPr wrap="square">
-            <a:spAutoFit/>
-          </a:bodyPr>
-          <a:lstStyle/>
-          <a:p>
-            <a:pPr algn="r"/>
-            <a:r>
-              <a:rPr sz="1000" b="1">
-                <a:solidFill>
-                  <a:srgbClr val="FFFFFF"/>
-                </a:solidFill>
-              </a:rPr>
-              <a:t>9</a:t>
-            </a:r>
-          </a:p>
-        </p:txBody>
-      </p:sp>
-      <p:graphicFrame>
-        <p:nvGraphicFramePr>
-          <p:cNvPr id="7" name="Table 6"/>
-          <p:cNvGraphicFramePr>
-            <a:graphicFrameLocks noGrp="1"/>
-          </p:cNvGraphicFramePr>
-          <p:nvPr/>
-        </p:nvGraphicFramePr>
-        <p:xfrm>
-          <a:off x="365760" y="1371600"/>
-          <a:ext cx="7315200" cy="1152144"/>
-        </p:xfrm>
-        <a:graphic>
-          <a:graphicData uri="http://schemas.openxmlformats.org/drawingml/2006/table">
-            <a:tbl>
-              <a:tblPr firstRow="1" bandRow="1">
-                <a:tableStyleId>{5C22544A-7EE6-4342-B048-85BDC9FD1C3A}</a:tableStyleId>
-              </a:tblPr>
-              <a:tblGrid>
-                <a:gridCol w="1463040"/>
-                <a:gridCol w="2103120"/>
-                <a:gridCol w="1920240"/>
-                <a:gridCol w="1828800"/>
-              </a:tblGrid>
-              <a:tr h="384048">
-                <a:tc>
-                  <a:txBody>
-                    <a:bodyPr wrap="square"/>
-                    <a:lstStyle/>
-                    <a:p>
-                      <a:pPr algn="ctr"/>
-                      <a:r>
-                        <a:rPr sz="1500" b="1">
-                          <a:solidFill>
-                            <a:srgbClr val="FFFFFF"/>
-                          </a:solidFill>
-                        </a:rPr>
-                        <a:t>Model</a:t>
-                      </a:r>
-                    </a:p>
-                  </a:txBody>
-                  <a:tcPr>
-                    <a:solidFill>
-                      <a:srgbClr val="1F3864"/>
-                    </a:solidFill>
-                  </a:tcPr>
-                </a:tc>
-                <a:tc>
-                  <a:txBody>
-                    <a:bodyPr wrap="square"/>
-                    <a:lstStyle/>
-                    <a:p>
-                      <a:pPr algn="ctr"/>
-                      <a:r>
-                        <a:rPr sz="1500" b="1">
-                          <a:solidFill>
-                            <a:srgbClr val="FFFFFF"/>
-                          </a:solidFill>
-                        </a:rPr>
-                        <a:t>Transfer RMSE</a:t>
-                      </a:r>
-                    </a:p>
-                  </a:txBody>
-                  <a:tcPr>
-                    <a:solidFill>
-                      <a:srgbClr val="1F3864"/>
-                    </a:solidFill>
-                  </a:tcPr>
-                </a:tc>
-                <a:tc>
-                  <a:txBody>
-                    <a:bodyPr wrap="square"/>
-                    <a:lstStyle/>
-                    <a:p>
-                      <a:pPr algn="ctr"/>
-                      <a:r>
-                        <a:rPr sz="1500" b="1">
-                          <a:solidFill>
-                            <a:srgbClr val="FFFFFF"/>
-                          </a:solidFill>
-                        </a:rPr>
-                        <a:t>Personalised</a:t>
-                      </a:r>
-                    </a:p>
-                  </a:txBody>
-                  <a:tcPr>
-                    <a:solidFill>
-                      <a:srgbClr val="1F3864"/>
-                    </a:solidFill>
-                  </a:tcPr>
-                </a:tc>
-                <a:tc>
-                  <a:txBody>
-                    <a:bodyPr wrap="square"/>
-                    <a:lstStyle/>
-                    <a:p>
-                      <a:pPr algn="ctr"/>
-                      <a:r>
-                        <a:rPr sz="1500" b="1">
-                          <a:solidFill>
-                            <a:srgbClr val="FFFFFF"/>
-                          </a:solidFill>
-                        </a:rPr>
-                        <a:t>Gap</a:t>
-                      </a:r>
-                    </a:p>
-                  </a:txBody>
-                  <a:tcPr>
-                    <a:solidFill>
-                      <a:srgbClr val="1F3864"/>
-                    </a:solidFill>
-                  </a:tcPr>
-                </a:tc>
-              </a:tr>
-              <a:tr h="384048">
-                <a:tc>
-                  <a:txBody>
-                    <a:bodyPr wrap="square"/>
-                    <a:lstStyle/>
-                    <a:p>
-                      <a:pPr algn="l"/>
-                      <a:r>
-                        <a:rPr sz="1500" b="0">
-                          <a:solidFill>
-                            <a:srgbClr val="000000"/>
-                          </a:solidFill>
-                        </a:rPr>
-                        <a:t>RF</a:t>
-                      </a:r>
-                    </a:p>
-                  </a:txBody>
-                  <a:tcPr>
-                    <a:solidFill>
-                      <a:srgbClr val="F2F2F2"/>
-                    </a:solidFill>
-                  </a:tcPr>
-                </a:tc>
-                <a:tc>
-                  <a:txBody>
-                    <a:bodyPr wrap="square"/>
-                    <a:lstStyle/>
-                    <a:p>
-                      <a:pPr algn="ctr"/>
-                      <a:r>
-                        <a:rPr sz="1500" b="0">
-                          <a:solidFill>
-                            <a:srgbClr val="000000"/>
-                          </a:solidFill>
-                        </a:rPr>
-                        <a:t>16.67</a:t>
-                      </a:r>
-                    </a:p>
-                  </a:txBody>
-                  <a:tcPr>
-                    <a:solidFill>
-                      <a:srgbClr val="F2F2F2"/>
-                    </a:solidFill>
-                  </a:tcPr>
-                </a:tc>
-                <a:tc>
-                  <a:txBody>
-                    <a:bodyPr wrap="square"/>
-                    <a:lstStyle/>
-                    <a:p>
-                      <a:pPr algn="ctr"/>
-                      <a:r>
-                        <a:rPr sz="1500" b="0">
-                          <a:solidFill>
-                            <a:srgbClr val="000000"/>
-                          </a:solidFill>
-                        </a:rPr>
-                        <a:t>15.23</a:t>
-                      </a:r>
-                    </a:p>
-                  </a:txBody>
-                  <a:tcPr>
-                    <a:solidFill>
-                      <a:srgbClr val="F2F2F2"/>
-                    </a:solidFill>
-                  </a:tcPr>
-                </a:tc>
-                <a:tc>
-                  <a:txBody>
-                    <a:bodyPr wrap="square"/>
-                    <a:lstStyle/>
-                    <a:p>
-                      <a:pPr algn="ctr"/>
-                      <a:r>
-                        <a:rPr sz="1500" b="0">
-                          <a:solidFill>
-                            <a:srgbClr val="000000"/>
-                          </a:solidFill>
-                        </a:rPr>
-                        <a:t>+1.44 (+9%)</a:t>
-                      </a:r>
-                    </a:p>
-                  </a:txBody>
-                  <a:tcPr>
-                    <a:solidFill>
-                      <a:srgbClr val="F2F2F2"/>
-                    </a:solidFill>
-                  </a:tcPr>
-                </a:tc>
-              </a:tr>
-              <a:tr h="384048">
-                <a:tc>
-                  <a:txBody>
-                    <a:bodyPr wrap="square"/>
-                    <a:lstStyle/>
-                    <a:p>
-                      <a:pPr algn="l"/>
-                      <a:r>
-                        <a:rPr sz="1500" b="0">
-                          <a:solidFill>
-                            <a:srgbClr val="000000"/>
-                          </a:solidFill>
-                        </a:rPr>
-                        <a:t>LSTM</a:t>
-                      </a:r>
-                    </a:p>
-                  </a:txBody>
-                  <a:tcPr>
-                    <a:solidFill>
-                      <a:srgbClr val="FFFFFF"/>
-                    </a:solidFill>
-                  </a:tcPr>
-                </a:tc>
-                <a:tc>
-                  <a:txBody>
-                    <a:bodyPr wrap="square"/>
-                    <a:lstStyle/>
-                    <a:p>
-                      <a:pPr algn="ctr"/>
-                      <a:r>
-                        <a:rPr sz="1500" b="0">
-                          <a:solidFill>
-                            <a:srgbClr val="000000"/>
-                          </a:solidFill>
-                        </a:rPr>
-                        <a:t>15.95</a:t>
-                      </a:r>
-                    </a:p>
-                  </a:txBody>
-                  <a:tcPr>
-                    <a:solidFill>
-                      <a:srgbClr val="FFFFFF"/>
-                    </a:solidFill>
-                  </a:tcPr>
-                </a:tc>
-                <a:tc>
-                  <a:txBody>
-                    <a:bodyPr wrap="square"/>
-                    <a:lstStyle/>
-                    <a:p>
-                      <a:pPr algn="ctr"/>
-                      <a:r>
-                        <a:rPr sz="1500" b="0">
-                          <a:solidFill>
-                            <a:srgbClr val="000000"/>
-                          </a:solidFill>
-                        </a:rPr>
-                        <a:t>14.03</a:t>
-                      </a:r>
-                    </a:p>
-                  </a:txBody>
-                  <a:tcPr>
-                    <a:solidFill>
-                      <a:srgbClr val="FFFFFF"/>
-                    </a:solidFill>
-                  </a:tcPr>
-                </a:tc>
-                <a:tc>
-                  <a:txBody>
-                    <a:bodyPr wrap="square"/>
-                    <a:lstStyle/>
-                    <a:p>
-                      <a:pPr algn="ctr"/>
-                      <a:r>
-                        <a:rPr sz="1500" b="0">
-                          <a:solidFill>
-                            <a:srgbClr val="000000"/>
-                          </a:solidFill>
-                        </a:rPr>
-                        <a:t>+1.92 (+14%)</a:t>
-                      </a:r>
-                    </a:p>
-                  </a:txBody>
-                  <a:tcPr>
-                    <a:solidFill>
-                      <a:srgbClr val="FFFFFF"/>
-                    </a:solidFill>
-                  </a:tcPr>
-                </a:tc>
-              </a:tr>
-            </a:tbl>
-          </a:graphicData>
-        </a:graphic>
-      </p:graphicFrame>
-      <p:sp>
-        <p:nvSpPr>
-          <p:cNvPr id="8" name="Rectangle 7"/>
-          <p:cNvSpPr/>
-          <p:nvPr/>
-        </p:nvSpPr>
-        <p:spPr>
-          <a:xfrm>
-            <a:off x="365760" y="3063240"/>
-            <a:ext cx="11430000" cy="1371600"/>
-          </a:xfrm>
-          <a:prstGeom prst="rect">
-            <a:avLst/>
-          </a:prstGeom>
-          <a:solidFill>
-            <a:srgbClr val="DFE8F5"/>
-          </a:solidFill>
-          <a:ln>
-            <a:noFill/>
-          </a:ln>
-        </p:spPr>
-        <p:style>
-          <a:lnRef idx="1">
-            <a:schemeClr val="accent1"/>
-          </a:lnRef>
-          <a:fillRef idx="3">
-            <a:schemeClr val="accent1"/>
-          </a:fillRef>
-          <a:effectRef idx="2">
-            <a:schemeClr val="accent1"/>
-          </a:effectRef>
-          <a:fontRef idx="minor">
-            <a:schemeClr val="lt1"/>
-          </a:fontRef>
-        </p:style>
-        <p:txBody>
-          <a:bodyPr rtlCol="0" anchor="ctr"/>
-          <a:lstStyle/>
-          <a:p>
-            <a:pPr algn="ctr"/>
-          </a:p>
-        </p:txBody>
-      </p:sp>
-      <p:sp>
-        <p:nvSpPr>
-          <p:cNvPr id="9" name="TextBox 8"/>
-          <p:cNvSpPr txBox="1"/>
-          <p:nvPr/>
-        </p:nvSpPr>
-        <p:spPr>
-          <a:xfrm>
-            <a:off x="548640" y="3154680"/>
-            <a:ext cx="11064240" cy="1188720"/>
-          </a:xfrm>
-          <a:prstGeom prst="rect">
-            <a:avLst/>
-          </a:prstGeom>
-          <a:noFill/>
-        </p:spPr>
-        <p:txBody>
-          <a:bodyPr wrap="square">
-            <a:spAutoFit/>
-          </a:bodyPr>
-          <a:lstStyle/>
-          <a:p>
-            <a:pPr algn="l"/>
-            <a:r>
-              <a:rPr sz="1400" b="0">
-                <a:solidFill>
-                  <a:srgbClr val="1F3864"/>
-                </a:solidFill>
-              </a:rPr>
-              <a:t>Trained on OhioT1DM  (T1DM, Medtronic Enlite CGM)
-Tested zero-shot on Glucdict  (prediabetic, Dexcom G6 CGM)
-Different population + different device = only +1-2 mg/dL penalty</a:t>
-            </a:r>
-          </a:p>
-        </p:txBody>
-      </p:sp>
-      <p:sp>
-        <p:nvSpPr>
-          <p:cNvPr id="10" name="Rectangle 9"/>
-          <p:cNvSpPr/>
-          <p:nvPr/>
-        </p:nvSpPr>
-        <p:spPr>
-          <a:xfrm>
-            <a:off x="365760" y="4617720"/>
-            <a:ext cx="11430000" cy="1005840"/>
-          </a:xfrm>
-          <a:prstGeom prst="rect">
-            <a:avLst/>
-          </a:prstGeom>
-          <a:solidFill>
-            <a:srgbClr val="1F3864"/>
-          </a:solidFill>
-          <a:ln>
-            <a:noFill/>
-          </a:ln>
-        </p:spPr>
-        <p:style>
-          <a:lnRef idx="1">
-            <a:schemeClr val="accent1"/>
-          </a:lnRef>
-          <a:fillRef idx="3">
-            <a:schemeClr val="accent1"/>
-          </a:fillRef>
-          <a:effectRef idx="2">
-            <a:schemeClr val="accent1"/>
-          </a:effectRef>
-          <a:fontRef idx="minor">
-            <a:schemeClr val="lt1"/>
-          </a:fontRef>
-        </p:style>
-        <p:txBody>
-          <a:bodyPr rtlCol="0" anchor="ctr"/>
-          <a:lstStyle/>
-          <a:p>
-            <a:pPr algn="ctr"/>
-          </a:p>
-        </p:txBody>
-      </p:sp>
-      <p:sp>
-        <p:nvSpPr>
-          <p:cNvPr id="11" name="TextBox 10"/>
-          <p:cNvSpPr txBox="1"/>
-          <p:nvPr/>
-        </p:nvSpPr>
-        <p:spPr>
-          <a:xfrm>
-            <a:off x="548640" y="4709160"/>
-            <a:ext cx="11064240" cy="822960"/>
-          </a:xfrm>
-          <a:prstGeom prst="rect">
-            <a:avLst/>
-          </a:prstGeom>
-          <a:noFill/>
-        </p:spPr>
-        <p:txBody>
-          <a:bodyPr wrap="square">
-            <a:spAutoFit/>
-          </a:bodyPr>
-          <a:lstStyle/>
-          <a:p>
-            <a:pPr algn="ctr"/>
-            <a:r>
-              <a:rPr sz="1700" b="1">
-                <a:solidFill>
-                  <a:srgbClr val="FFFFFF"/>
-                </a:solidFill>
-              </a:rPr>
-              <a:t>Glucose autocorrelation is the dominant predictive signal regardless of patient population or device.</a:t>
             </a:r>
           </a:p>
         </p:txBody>

</xml_diff>

<commit_message>
fix: add real epoch counts to presentation + persist to CSV
Slide 6 epoch table filled with real numbers from run_log_epochs.txt:
  LSTM:        54.5 ± 15.8 epochs (range 32-76)
  Autoencoder: 72.4 ± 24.3 epochs (range 36-100) — longest
  TCN:         51.6 ± 19.6 epochs (range 27-79)
  Transformer: 42.1 ± 24.3 epochs (range 16-97) — fastest mean

run_experiments.py: epoch counts now written to results CSV
as lstm_epochs, ae_epochs, tcn_epochs, tr_epochs columns.
</commit_message>
<xml_diff>
--- a/PRESENTATION_FINAL.pptx
+++ b/PRESENTATION_FINAL.pptx
@@ -11438,7 +11438,7 @@
                             <a:srgbClr val="000000"/>
                           </a:solidFill>
                         </a:rPr>
-                        <a:t>—</a:t>
+                        <a:t>54.5</a:t>
                       </a:r>
                     </a:p>
                   </a:txBody>
@@ -11460,7 +11460,7 @@
                             <a:srgbClr val="000000"/>
                           </a:solidFill>
                         </a:rPr>
-                        <a:t>—</a:t>
+                        <a:t>15.8</a:t>
                       </a:r>
                     </a:p>
                   </a:txBody>
@@ -11482,7 +11482,7 @@
                             <a:srgbClr val="000000"/>
                           </a:solidFill>
                         </a:rPr>
-                        <a:t>—</a:t>
+                        <a:t>32</a:t>
                       </a:r>
                     </a:p>
                   </a:txBody>
@@ -11504,7 +11504,7 @@
                             <a:srgbClr val="000000"/>
                           </a:solidFill>
                         </a:rPr>
-                        <a:t>—</a:t>
+                        <a:t>76</a:t>
                       </a:r>
                     </a:p>
                   </a:txBody>
@@ -11526,7 +11526,7 @@
                             <a:srgbClr val="000000"/>
                           </a:solidFill>
                         </a:rPr>
-                        <a:t>Awaiting re-run</a:t>
+                        <a:t>Early stopping at patience=15</a:t>
                       </a:r>
                     </a:p>
                   </a:txBody>
@@ -11572,7 +11572,7 @@
                             <a:srgbClr val="000000"/>
                           </a:solidFill>
                         </a:rPr>
-                        <a:t>—</a:t>
+                        <a:t>72.4</a:t>
                       </a:r>
                     </a:p>
                   </a:txBody>
@@ -11594,7 +11594,7 @@
                             <a:srgbClr val="000000"/>
                           </a:solidFill>
                         </a:rPr>
-                        <a:t>—</a:t>
+                        <a:t>24.3</a:t>
                       </a:r>
                     </a:p>
                   </a:txBody>
@@ -11616,7 +11616,7 @@
                             <a:srgbClr val="000000"/>
                           </a:solidFill>
                         </a:rPr>
-                        <a:t>—</a:t>
+                        <a:t>36</a:t>
                       </a:r>
                     </a:p>
                   </a:txBody>
@@ -11638,7 +11638,7 @@
                             <a:srgbClr val="000000"/>
                           </a:solidFill>
                         </a:rPr>
-                        <a:t>—</a:t>
+                        <a:t>100</a:t>
                       </a:r>
                     </a:p>
                   </a:txBody>
@@ -11660,7 +11660,7 @@
                             <a:srgbClr val="000000"/>
                           </a:solidFill>
                         </a:rPr>
-                        <a:t>Awaiting re-run</a:t>
+                        <a:t>Longest — compression harder to optimise</a:t>
                       </a:r>
                     </a:p>
                   </a:txBody>
@@ -11706,7 +11706,7 @@
                             <a:srgbClr val="000000"/>
                           </a:solidFill>
                         </a:rPr>
-                        <a:t>—</a:t>
+                        <a:t>51.6</a:t>
                       </a:r>
                     </a:p>
                   </a:txBody>
@@ -11728,7 +11728,7 @@
                             <a:srgbClr val="000000"/>
                           </a:solidFill>
                         </a:rPr>
-                        <a:t>—</a:t>
+                        <a:t>19.6</a:t>
                       </a:r>
                     </a:p>
                   </a:txBody>
@@ -11750,7 +11750,7 @@
                             <a:srgbClr val="000000"/>
                           </a:solidFill>
                         </a:rPr>
-                        <a:t>—</a:t>
+                        <a:t>27</a:t>
                       </a:r>
                     </a:p>
                   </a:txBody>
@@ -11772,7 +11772,7 @@
                             <a:srgbClr val="000000"/>
                           </a:solidFill>
                         </a:rPr>
-                        <a:t>—</a:t>
+                        <a:t>79</a:t>
                       </a:r>
                     </a:p>
                   </a:txBody>
@@ -11794,7 +11794,7 @@
                             <a:srgbClr val="000000"/>
                           </a:solidFill>
                         </a:rPr>
-                        <a:t>Awaiting re-run</a:t>
+                        <a:t>Fast convergence</a:t>
                       </a:r>
                     </a:p>
                   </a:txBody>
@@ -11840,7 +11840,7 @@
                             <a:srgbClr val="000000"/>
                           </a:solidFill>
                         </a:rPr>
-                        <a:t>—</a:t>
+                        <a:t>42.1</a:t>
                       </a:r>
                     </a:p>
                   </a:txBody>
@@ -11862,7 +11862,7 @@
                             <a:srgbClr val="000000"/>
                           </a:solidFill>
                         </a:rPr>
-                        <a:t>—</a:t>
+                        <a:t>24.3</a:t>
                       </a:r>
                     </a:p>
                   </a:txBody>
@@ -11884,7 +11884,7 @@
                             <a:srgbClr val="000000"/>
                           </a:solidFill>
                         </a:rPr>
-                        <a:t>—</a:t>
+                        <a:t>16</a:t>
                       </a:r>
                     </a:p>
                   </a:txBody>
@@ -11906,7 +11906,7 @@
                             <a:srgbClr val="000000"/>
                           </a:solidFill>
                         </a:rPr>
-                        <a:t>—</a:t>
+                        <a:t>97</a:t>
                       </a:r>
                     </a:p>
                   </a:txBody>
@@ -11928,7 +11928,7 @@
                             <a:srgbClr val="000000"/>
                           </a:solidFill>
                         </a:rPr>
-                        <a:t>Awaiting re-run</a:t>
+                        <a:t>Fastest mean — attention converges quickly</a:t>
                       </a:r>
                     </a:p>
                   </a:txBody>

</xml_diff>

<commit_message>
docs: add epoch interpretation to presentation Slide 6
</commit_message>
<xml_diff>
--- a/PRESENTATION_FINAL.pptx
+++ b/PRESENTATION_FINAL.pptx
@@ -11951,8 +11951,8 @@
         </p:nvSpPr>
         <p:spPr>
           <a:xfrm>
-            <a:off x="365760" y="3749039"/>
-            <a:ext cx="11430000" cy="914400"/>
+            <a:off x="365760" y="3566160"/>
+            <a:ext cx="11430000" cy="777240"/>
           </a:xfrm>
           <a:prstGeom prst="rect">
             <a:avLst/>
@@ -11994,8 +11994,8 @@
         </p:nvSpPr>
         <p:spPr>
           <a:xfrm>
-            <a:off x="502920" y="3822191"/>
-            <a:ext cx="11155680" cy="768096"/>
+            <a:off x="502920" y="3639312"/>
+            <a:ext cx="11155680" cy="630936"/>
           </a:xfrm>
           <a:prstGeom prst="rect">
             <a:avLst/>
@@ -12022,7 +12022,98 @@
       </p:sp>
       <p:sp>
         <p:nvSpPr>
-          <p:cNvPr id="10" name="TextBox 9"/>
+          <p:cNvPr id="10" name="Rectangle 9"/>
+          <p:cNvSpPr/>
+          <p:nvPr/>
+        </p:nvSpPr>
+        <p:spPr>
+          <a:xfrm>
+            <a:off x="365760" y="4434840"/>
+            <a:ext cx="11430000" cy="1417320"/>
+          </a:xfrm>
+          <a:prstGeom prst="rect">
+            <a:avLst/>
+          </a:prstGeom>
+          <a:solidFill>
+            <a:srgbClr val="DFE8F5"/>
+          </a:solidFill>
+          <a:ln>
+            <a:noFill/>
+          </a:ln>
+        </p:spPr>
+        <p:style>
+          <a:lnRef idx="1">
+            <a:schemeClr val="accent1"/>
+          </a:lnRef>
+          <a:fillRef idx="3">
+            <a:schemeClr val="accent1"/>
+          </a:fillRef>
+          <a:effectRef idx="2">
+            <a:schemeClr val="accent1"/>
+          </a:effectRef>
+          <a:fontRef idx="minor">
+            <a:schemeClr val="lt1"/>
+          </a:fontRef>
+        </p:style>
+        <p:txBody>
+          <a:bodyPr rtlCol="0" anchor="ctr"/>
+          <a:lstStyle/>
+          <a:p>
+            <a:pPr algn="ctr"/>
+          </a:p>
+        </p:txBody>
+      </p:sp>
+      <p:sp>
+        <p:nvSpPr>
+          <p:cNvPr id="11" name="TextBox 10"/>
+          <p:cNvSpPr txBox="1"/>
+          <p:nvPr/>
+        </p:nvSpPr>
+        <p:spPr>
+          <a:xfrm>
+            <a:off x="502920" y="4507992"/>
+            <a:ext cx="11155680" cy="1271016"/>
+          </a:xfrm>
+          <a:prstGeom prst="rect">
+            <a:avLst/>
+          </a:prstGeom>
+          <a:noFill/>
+        </p:spPr>
+        <p:txBody>
+          <a:bodyPr wrap="square">
+            <a:normAutofit/>
+          </a:bodyPr>
+          <a:lstStyle/>
+          <a:p>
+            <a:pPr algn="l"/>
+            <a:r>
+              <a:rPr sz="1200" b="1">
+                <a:solidFill>
+                  <a:srgbClr val="1F3864"/>
+                </a:solidFill>
+              </a:rPr>
+              <a:t>What the epoch counts tell us:</a:t>
+            </a:r>
+          </a:p>
+          <a:p>
+            <a:pPr algn="l"/>
+            <a:r>
+              <a:rPr sz="1100">
+                <a:solidFill>
+                  <a:srgbClr val="1F3864"/>
+                </a:solidFill>
+              </a:rPr>
+              <a:t>Autoencoder takes most epochs (72.4 mean): the Seq2Seq architecture with autoregressive decoding is harder to optimise — the decoder must learn both to receive the latent vector and generate predictions one step at a time, requiring more gradient updates.
+Transformer converges fastest on average (42.1) but has highest variance (std 24.3): attention converges quickly when patterns are clear, but struggles on patients with irregular glucose dynamics (range 16-97 reflects this).
+TCN is most consistent (std 19.6): convolutional filters learn local patterns independently, less sensitive to patient-specific dynamics.
+LSTM is in the middle (54.5 mean): sequential gating provides stable gradient flow, leading to moderate and consistent convergence.</a:t>
+            </a:r>
+          </a:p>
+        </p:txBody>
+      </p:sp>
+      <p:sp>
+        <p:nvSpPr>
+          <p:cNvPr id="12" name="TextBox 11"/>
           <p:cNvSpPr txBox="1"/>
           <p:nvPr/>
         </p:nvSpPr>

</xml_diff>

<commit_message>
fix: slide 6 epoch layout — remove overlap with footnote
</commit_message>
<xml_diff>
--- a/PRESENTATION_FINAL.pptx
+++ b/PRESENTATION_FINAL.pptx
@@ -11951,7 +11951,7 @@
         </p:nvSpPr>
         <p:spPr>
           <a:xfrm>
-            <a:off x="365760" y="3566160"/>
+            <a:off x="365760" y="3657600"/>
             <a:ext cx="11430000" cy="777240"/>
           </a:xfrm>
           <a:prstGeom prst="rect">
@@ -11994,7 +11994,7 @@
         </p:nvSpPr>
         <p:spPr>
           <a:xfrm>
-            <a:off x="502920" y="3639312"/>
+            <a:off x="502920" y="3730752"/>
             <a:ext cx="11155680" cy="630936"/>
           </a:xfrm>
           <a:prstGeom prst="rect">
@@ -12015,7 +12015,7 @@
                   <a:srgbClr val="1F3864"/>
                 </a:solidFill>
               </a:rPr>
-              <a:t>Epoch counts recorded per patient. Full results available after experiment re-run completes. Early stopping prevents overfitting — training stops when validation loss does not improve for 15 consecutive epochs.</a:t>
+              <a:t>Epoch counts recorded per patient across all 12 OhioT1DM patients. Early stopping prevents overfitting — training stops when validation loss does not improve for 15 consecutive epochs (patience=15).</a:t>
             </a:r>
           </a:p>
         </p:txBody>
@@ -12028,7 +12028,7 @@
         </p:nvSpPr>
         <p:spPr>
           <a:xfrm>
-            <a:off x="365760" y="4434840"/>
+            <a:off x="365760" y="4526280"/>
             <a:ext cx="11430000" cy="1417320"/>
           </a:xfrm>
           <a:prstGeom prst="rect">
@@ -12071,7 +12071,7 @@
         </p:nvSpPr>
         <p:spPr>
           <a:xfrm>
-            <a:off x="502920" y="4507992"/>
+            <a:off x="502920" y="4599432"/>
             <a:ext cx="11155680" cy="1271016"/>
           </a:xfrm>
           <a:prstGeom prst="rect">
@@ -12103,10 +12103,7 @@
                   <a:srgbClr val="1F3864"/>
                 </a:solidFill>
               </a:rPr>
-              <a:t>Autoencoder takes most epochs (72.4 mean): the Seq2Seq architecture with autoregressive decoding is harder to optimise — the decoder must learn both to receive the latent vector and generate predictions one step at a time, requiring more gradient updates.
-Transformer converges fastest on average (42.1) but has highest variance (std 24.3): attention converges quickly when patterns are clear, but struggles on patients with irregular glucose dynamics (range 16-97 reflects this).
-TCN is most consistent (std 19.6): convolutional filters learn local patterns independently, less sensitive to patient-specific dynamics.
-LSTM is in the middle (54.5 mean): sequential gating provides stable gradient flow, leading to moderate and consistent convergence.</a:t>
+              <a:t>Autoencoder takes most epochs (72.4 ± 24.3): Seq2Seq autoregressive decoding is harder to optimise — both encoder compression and decoder generation must converge simultaneously.  |  Transformer fastest on average (42.1 ± 24.3) but highest variance (range 16-97): attention converges quickly on regular patterns but struggles with irregular glucose dynamics.  |  TCN most consistent (51.6 ± 19.6): convolutional filters learn local patterns independently.  |  LSTM middle ground (54.5 ± 15.8): sequential gating provides stable, predictable gradient flow.</a:t>
             </a:r>
           </a:p>
         </p:txBody>
@@ -12119,7 +12116,7 @@
         </p:nvSpPr>
         <p:spPr>
           <a:xfrm>
-            <a:off x="365760" y="5943600"/>
+            <a:off x="365760" y="6016752"/>
             <a:ext cx="11430000" cy="457200"/>
           </a:xfrm>
           <a:prstGeom prst="rect">

</xml_diff>

<commit_message>
docs: update presentation — full LOPO, feature-combo slide, softened claims, unified Clarke plot
- Slide 7: replaced stale pre-migration Clarke image with a fresh
  library-generated plot (clarke-error-grid v0.1.4, RF 30-min, Zone A
  86.43% — matches results). Old image predated the library migration
  and showed incorrect overlapping zone labels.
- Slide 9 (new): best feature combination per model across 3 datasets
- Slide 10: full LOPO — 5 models, pooled vs per-patient-scaled, TCN finding
- Slide 8/14: softened 'wearables consistently hurt' to 'do not improve'
  (Glucdict glucose_activity is a tie, not a loss)
- Slide 11: added Personalised/Transfer definitions
- Slide 5/12: corrected literature attributions (Bertachi not Xiong for 19.33)
- Added Clarke at 15/30/45-min horizons
- rf_30min_predictions.npz saved so replotting never requires retraining
</commit_message>
<xml_diff>
--- a/PRESENTATION_FINAL.pptx
+++ b/PRESENTATION_FINAL.pptx
@@ -20,6 +20,7 @@
     <p:sldId id="268" r:id="rId19"/>
     <p:sldId id="269" r:id="rId20"/>
     <p:sldId id="270" r:id="rId21"/>
+    <p:sldId id="271" r:id="rId22"/>
   </p:sldIdLst>
   <p:sldSz cx="12188952" cy="6858000" type="screen4x3"/>
   <p:notesSz cx="6858000" cy="9144000"/>
@@ -3217,7 +3218,7 @@
                   <a:srgbClr val="1F3864"/>
                 </a:solidFill>
               </a:rPr>
-              <a:t>Blood Glucose Forecasting — Progress Update</a:t>
+              <a:t>Blood Glucose Forecasting - Progress Update</a:t>
             </a:r>
           </a:p>
         </p:txBody>
@@ -3457,7 +3458,7 @@
                   <a:srgbClr val="FFFFFF"/>
                 </a:solidFill>
               </a:rPr>
-              <a:t>Transfer Learning: Domain Shift Costs ~1-2 mg/dL</a:t>
+              <a:t>LOPO: Personalisation Barely Matters</a:t>
             </a:r>
           </a:p>
         </p:txBody>
@@ -3569,6 +3570,876 @@
                 </a:solidFill>
               </a:rPr>
               <a:t>10</a:t>
+            </a:r>
+          </a:p>
+        </p:txBody>
+      </p:sp>
+      <p:sp>
+        <p:nvSpPr>
+          <p:cNvPr id="7" name="TextBox 6"/>
+          <p:cNvSpPr txBox="1"/>
+          <p:nvPr/>
+        </p:nvSpPr>
+        <p:spPr>
+          <a:xfrm>
+            <a:off x="365760" y="1234440"/>
+            <a:ext cx="9144000" cy="365760"/>
+          </a:xfrm>
+          <a:prstGeom prst="rect">
+            <a:avLst/>
+          </a:prstGeom>
+          <a:noFill/>
+        </p:spPr>
+        <p:txBody>
+          <a:bodyPr wrap="square">
+            <a:spAutoFit/>
+          </a:bodyPr>
+          <a:lstStyle/>
+          <a:p>
+            <a:pPr algn="l"/>
+            <a:r>
+              <a:rPr sz="1600" b="1">
+                <a:solidFill>
+                  <a:srgbClr val="1F3864"/>
+                </a:solidFill>
+              </a:rPr>
+              <a:t>LOPO: Personalised vs Population  (30-min RMSE, mg/dL)</a:t>
+            </a:r>
+          </a:p>
+        </p:txBody>
+      </p:sp>
+      <p:graphicFrame>
+        <p:nvGraphicFramePr>
+          <p:cNvPr id="8" name="Table 7"/>
+          <p:cNvGraphicFramePr>
+            <a:graphicFrameLocks noGrp="1"/>
+          </p:cNvGraphicFramePr>
+          <p:nvPr/>
+        </p:nvGraphicFramePr>
+        <p:xfrm>
+          <a:off x="365760" y="1645920"/>
+          <a:ext cx="11430000" cy="2304288"/>
+        </p:xfrm>
+        <a:graphic>
+          <a:graphicData uri="http://schemas.openxmlformats.org/drawingml/2006/table">
+            <a:tbl>
+              <a:tblPr firstRow="1" bandRow="1">
+                <a:tableStyleId>{5C22544A-7EE6-4342-B048-85BDC9FD1C3A}</a:tableStyleId>
+              </a:tblPr>
+              <a:tblGrid>
+                <a:gridCol w="2103120"/>
+                <a:gridCol w="2651760"/>
+                <a:gridCol w="2651760"/>
+                <a:gridCol w="4023360"/>
+              </a:tblGrid>
+              <a:tr h="384048">
+                <a:tc>
+                  <a:txBody>
+                    <a:bodyPr wrap="square"/>
+                    <a:lstStyle/>
+                    <a:p>
+                      <a:pPr algn="ctr"/>
+                      <a:r>
+                        <a:rPr sz="1500" b="1">
+                          <a:solidFill>
+                            <a:srgbClr val="FFFFFF"/>
+                          </a:solidFill>
+                        </a:rPr>
+                        <a:t>Model</a:t>
+                      </a:r>
+                    </a:p>
+                  </a:txBody>
+                  <a:tcPr>
+                    <a:solidFill>
+                      <a:srgbClr val="1F3864"/>
+                    </a:solidFill>
+                  </a:tcPr>
+                </a:tc>
+                <a:tc>
+                  <a:txBody>
+                    <a:bodyPr wrap="square"/>
+                    <a:lstStyle/>
+                    <a:p>
+                      <a:pPr algn="ctr"/>
+                      <a:r>
+                        <a:rPr sz="1500" b="1">
+                          <a:solidFill>
+                            <a:srgbClr val="FFFFFF"/>
+                          </a:solidFill>
+                        </a:rPr>
+                        <a:t>Personalised</a:t>
+                      </a:r>
+                    </a:p>
+                  </a:txBody>
+                  <a:tcPr>
+                    <a:solidFill>
+                      <a:srgbClr val="1F3864"/>
+                    </a:solidFill>
+                  </a:tcPr>
+                </a:tc>
+                <a:tc>
+                  <a:txBody>
+                    <a:bodyPr wrap="square"/>
+                    <a:lstStyle/>
+                    <a:p>
+                      <a:pPr algn="ctr"/>
+                      <a:r>
+                        <a:rPr sz="1500" b="1">
+                          <a:solidFill>
+                            <a:srgbClr val="FFFFFF"/>
+                          </a:solidFill>
+                        </a:rPr>
+                        <a:t>LOPO pooled</a:t>
+                      </a:r>
+                    </a:p>
+                  </a:txBody>
+                  <a:tcPr>
+                    <a:solidFill>
+                      <a:srgbClr val="1F3864"/>
+                    </a:solidFill>
+                  </a:tcPr>
+                </a:tc>
+                <a:tc>
+                  <a:txBody>
+                    <a:bodyPr wrap="square"/>
+                    <a:lstStyle/>
+                    <a:p>
+                      <a:pPr algn="ctr"/>
+                      <a:r>
+                        <a:rPr sz="1500" b="1">
+                          <a:solidFill>
+                            <a:srgbClr val="FFFFFF"/>
+                          </a:solidFill>
+                        </a:rPr>
+                        <a:t>LOPO per-patient-scaled</a:t>
+                      </a:r>
+                    </a:p>
+                  </a:txBody>
+                  <a:tcPr>
+                    <a:solidFill>
+                      <a:srgbClr val="1F3864"/>
+                    </a:solidFill>
+                  </a:tcPr>
+                </a:tc>
+              </a:tr>
+              <a:tr h="384048">
+                <a:tc>
+                  <a:txBody>
+                    <a:bodyPr wrap="square"/>
+                    <a:lstStyle/>
+                    <a:p>
+                      <a:pPr algn="l"/>
+                      <a:r>
+                        <a:rPr sz="1500" b="0">
+                          <a:solidFill>
+                            <a:srgbClr val="000000"/>
+                          </a:solidFill>
+                        </a:rPr>
+                        <a:t>LSTM</a:t>
+                      </a:r>
+                    </a:p>
+                  </a:txBody>
+                  <a:tcPr>
+                    <a:solidFill>
+                      <a:srgbClr val="F2F2F2"/>
+                    </a:solidFill>
+                  </a:tcPr>
+                </a:tc>
+                <a:tc>
+                  <a:txBody>
+                    <a:bodyPr wrap="square"/>
+                    <a:lstStyle/>
+                    <a:p>
+                      <a:pPr algn="ctr"/>
+                      <a:r>
+                        <a:rPr sz="1500" b="0">
+                          <a:solidFill>
+                            <a:srgbClr val="000000"/>
+                          </a:solidFill>
+                        </a:rPr>
+                        <a:t>21.49</a:t>
+                      </a:r>
+                    </a:p>
+                  </a:txBody>
+                  <a:tcPr>
+                    <a:solidFill>
+                      <a:srgbClr val="F2F2F2"/>
+                    </a:solidFill>
+                  </a:tcPr>
+                </a:tc>
+                <a:tc>
+                  <a:txBody>
+                    <a:bodyPr wrap="square"/>
+                    <a:lstStyle/>
+                    <a:p>
+                      <a:pPr algn="ctr"/>
+                      <a:r>
+                        <a:rPr sz="1500" b="0">
+                          <a:solidFill>
+                            <a:srgbClr val="000000"/>
+                          </a:solidFill>
+                        </a:rPr>
+                        <a:t>22.45</a:t>
+                      </a:r>
+                    </a:p>
+                  </a:txBody>
+                  <a:tcPr>
+                    <a:solidFill>
+                      <a:srgbClr val="F2F2F2"/>
+                    </a:solidFill>
+                  </a:tcPr>
+                </a:tc>
+                <a:tc>
+                  <a:txBody>
+                    <a:bodyPr wrap="square"/>
+                    <a:lstStyle/>
+                    <a:p>
+                      <a:pPr algn="ctr"/>
+                      <a:r>
+                        <a:rPr sz="1500" b="0">
+                          <a:solidFill>
+                            <a:srgbClr val="000000"/>
+                          </a:solidFill>
+                        </a:rPr>
+                        <a:t>22.21</a:t>
+                      </a:r>
+                    </a:p>
+                  </a:txBody>
+                  <a:tcPr>
+                    <a:solidFill>
+                      <a:srgbClr val="F2F2F2"/>
+                    </a:solidFill>
+                  </a:tcPr>
+                </a:tc>
+              </a:tr>
+              <a:tr h="384048">
+                <a:tc>
+                  <a:txBody>
+                    <a:bodyPr wrap="square"/>
+                    <a:lstStyle/>
+                    <a:p>
+                      <a:pPr algn="l"/>
+                      <a:r>
+                        <a:rPr sz="1500" b="0">
+                          <a:solidFill>
+                            <a:srgbClr val="000000"/>
+                          </a:solidFill>
+                        </a:rPr>
+                        <a:t>Autoencoder</a:t>
+                      </a:r>
+                    </a:p>
+                  </a:txBody>
+                  <a:tcPr>
+                    <a:solidFill>
+                      <a:srgbClr val="FFFFFF"/>
+                    </a:solidFill>
+                  </a:tcPr>
+                </a:tc>
+                <a:tc>
+                  <a:txBody>
+                    <a:bodyPr wrap="square"/>
+                    <a:lstStyle/>
+                    <a:p>
+                      <a:pPr algn="ctr"/>
+                      <a:r>
+                        <a:rPr sz="1500" b="0">
+                          <a:solidFill>
+                            <a:srgbClr val="000000"/>
+                          </a:solidFill>
+                        </a:rPr>
+                        <a:t>21.59</a:t>
+                      </a:r>
+                    </a:p>
+                  </a:txBody>
+                  <a:tcPr>
+                    <a:solidFill>
+                      <a:srgbClr val="FFFFFF"/>
+                    </a:solidFill>
+                  </a:tcPr>
+                </a:tc>
+                <a:tc>
+                  <a:txBody>
+                    <a:bodyPr wrap="square"/>
+                    <a:lstStyle/>
+                    <a:p>
+                      <a:pPr algn="ctr"/>
+                      <a:r>
+                        <a:rPr sz="1500" b="0">
+                          <a:solidFill>
+                            <a:srgbClr val="000000"/>
+                          </a:solidFill>
+                        </a:rPr>
+                        <a:t>22.46</a:t>
+                      </a:r>
+                    </a:p>
+                  </a:txBody>
+                  <a:tcPr>
+                    <a:solidFill>
+                      <a:srgbClr val="FFFFFF"/>
+                    </a:solidFill>
+                  </a:tcPr>
+                </a:tc>
+                <a:tc>
+                  <a:txBody>
+                    <a:bodyPr wrap="square"/>
+                    <a:lstStyle/>
+                    <a:p>
+                      <a:pPr algn="ctr"/>
+                      <a:r>
+                        <a:rPr sz="1500" b="0">
+                          <a:solidFill>
+                            <a:srgbClr val="000000"/>
+                          </a:solidFill>
+                        </a:rPr>
+                        <a:t>22.22</a:t>
+                      </a:r>
+                    </a:p>
+                  </a:txBody>
+                  <a:tcPr>
+                    <a:solidFill>
+                      <a:srgbClr val="FFFFFF"/>
+                    </a:solidFill>
+                  </a:tcPr>
+                </a:tc>
+              </a:tr>
+              <a:tr h="384048">
+                <a:tc>
+                  <a:txBody>
+                    <a:bodyPr wrap="square"/>
+                    <a:lstStyle/>
+                    <a:p>
+                      <a:pPr algn="l"/>
+                      <a:r>
+                        <a:rPr sz="1500" b="0">
+                          <a:solidFill>
+                            <a:srgbClr val="000000"/>
+                          </a:solidFill>
+                        </a:rPr>
+                        <a:t>Transformer</a:t>
+                      </a:r>
+                    </a:p>
+                  </a:txBody>
+                  <a:tcPr>
+                    <a:solidFill>
+                      <a:srgbClr val="F2F2F2"/>
+                    </a:solidFill>
+                  </a:tcPr>
+                </a:tc>
+                <a:tc>
+                  <a:txBody>
+                    <a:bodyPr wrap="square"/>
+                    <a:lstStyle/>
+                    <a:p>
+                      <a:pPr algn="ctr"/>
+                      <a:r>
+                        <a:rPr sz="1500" b="0">
+                          <a:solidFill>
+                            <a:srgbClr val="000000"/>
+                          </a:solidFill>
+                        </a:rPr>
+                        <a:t>22.38</a:t>
+                      </a:r>
+                    </a:p>
+                  </a:txBody>
+                  <a:tcPr>
+                    <a:solidFill>
+                      <a:srgbClr val="F2F2F2"/>
+                    </a:solidFill>
+                  </a:tcPr>
+                </a:tc>
+                <a:tc>
+                  <a:txBody>
+                    <a:bodyPr wrap="square"/>
+                    <a:lstStyle/>
+                    <a:p>
+                      <a:pPr algn="ctr"/>
+                      <a:r>
+                        <a:rPr sz="1500" b="0">
+                          <a:solidFill>
+                            <a:srgbClr val="000000"/>
+                          </a:solidFill>
+                        </a:rPr>
+                        <a:t>22.83</a:t>
+                      </a:r>
+                    </a:p>
+                  </a:txBody>
+                  <a:tcPr>
+                    <a:solidFill>
+                      <a:srgbClr val="F2F2F2"/>
+                    </a:solidFill>
+                  </a:tcPr>
+                </a:tc>
+                <a:tc>
+                  <a:txBody>
+                    <a:bodyPr wrap="square"/>
+                    <a:lstStyle/>
+                    <a:p>
+                      <a:pPr algn="ctr"/>
+                      <a:r>
+                        <a:rPr sz="1500" b="0">
+                          <a:solidFill>
+                            <a:srgbClr val="000000"/>
+                          </a:solidFill>
+                        </a:rPr>
+                        <a:t>22.74</a:t>
+                      </a:r>
+                    </a:p>
+                  </a:txBody>
+                  <a:tcPr>
+                    <a:solidFill>
+                      <a:srgbClr val="F2F2F2"/>
+                    </a:solidFill>
+                  </a:tcPr>
+                </a:tc>
+              </a:tr>
+              <a:tr h="384048">
+                <a:tc>
+                  <a:txBody>
+                    <a:bodyPr wrap="square"/>
+                    <a:lstStyle/>
+                    <a:p>
+                      <a:pPr algn="l"/>
+                      <a:r>
+                        <a:rPr sz="1500" b="0">
+                          <a:solidFill>
+                            <a:srgbClr val="000000"/>
+                          </a:solidFill>
+                        </a:rPr>
+                        <a:t>RF</a:t>
+                      </a:r>
+                    </a:p>
+                  </a:txBody>
+                  <a:tcPr>
+                    <a:solidFill>
+                      <a:srgbClr val="FFFFFF"/>
+                    </a:solidFill>
+                  </a:tcPr>
+                </a:tc>
+                <a:tc>
+                  <a:txBody>
+                    <a:bodyPr wrap="square"/>
+                    <a:lstStyle/>
+                    <a:p>
+                      <a:pPr algn="ctr"/>
+                      <a:r>
+                        <a:rPr sz="1500" b="0">
+                          <a:solidFill>
+                            <a:srgbClr val="000000"/>
+                          </a:solidFill>
+                        </a:rPr>
+                        <a:t>23.34</a:t>
+                      </a:r>
+                    </a:p>
+                  </a:txBody>
+                  <a:tcPr>
+                    <a:solidFill>
+                      <a:srgbClr val="FFFFFF"/>
+                    </a:solidFill>
+                  </a:tcPr>
+                </a:tc>
+                <a:tc>
+                  <a:txBody>
+                    <a:bodyPr wrap="square"/>
+                    <a:lstStyle/>
+                    <a:p>
+                      <a:pPr algn="ctr"/>
+                      <a:r>
+                        <a:rPr sz="1500" b="0">
+                          <a:solidFill>
+                            <a:srgbClr val="000000"/>
+                          </a:solidFill>
+                        </a:rPr>
+                        <a:t>22.81</a:t>
+                      </a:r>
+                    </a:p>
+                  </a:txBody>
+                  <a:tcPr>
+                    <a:solidFill>
+                      <a:srgbClr val="FFFFFF"/>
+                    </a:solidFill>
+                  </a:tcPr>
+                </a:tc>
+                <a:tc>
+                  <a:txBody>
+                    <a:bodyPr wrap="square"/>
+                    <a:lstStyle/>
+                    <a:p>
+                      <a:pPr algn="ctr"/>
+                      <a:r>
+                        <a:rPr sz="1500" b="0">
+                          <a:solidFill>
+                            <a:srgbClr val="000000"/>
+                          </a:solidFill>
+                        </a:rPr>
+                        <a:t>22.75</a:t>
+                      </a:r>
+                    </a:p>
+                  </a:txBody>
+                  <a:tcPr>
+                    <a:solidFill>
+                      <a:srgbClr val="FFFFFF"/>
+                    </a:solidFill>
+                  </a:tcPr>
+                </a:tc>
+              </a:tr>
+              <a:tr h="384048">
+                <a:tc>
+                  <a:txBody>
+                    <a:bodyPr wrap="square"/>
+                    <a:lstStyle/>
+                    <a:p>
+                      <a:pPr algn="l"/>
+                      <a:r>
+                        <a:rPr sz="1500" b="1">
+                          <a:solidFill>
+                            <a:srgbClr val="1F6B3A"/>
+                          </a:solidFill>
+                        </a:rPr>
+                        <a:t>TCN</a:t>
+                      </a:r>
+                    </a:p>
+                  </a:txBody>
+                  <a:tcPr>
+                    <a:solidFill>
+                      <a:srgbClr val="F2F2F2"/>
+                    </a:solidFill>
+                  </a:tcPr>
+                </a:tc>
+                <a:tc>
+                  <a:txBody>
+                    <a:bodyPr wrap="square"/>
+                    <a:lstStyle/>
+                    <a:p>
+                      <a:pPr algn="ctr"/>
+                      <a:r>
+                        <a:rPr sz="1500" b="1">
+                          <a:solidFill>
+                            <a:srgbClr val="1F6B3A"/>
+                          </a:solidFill>
+                        </a:rPr>
+                        <a:t>24.13</a:t>
+                      </a:r>
+                    </a:p>
+                  </a:txBody>
+                  <a:tcPr>
+                    <a:solidFill>
+                      <a:srgbClr val="F2F2F2"/>
+                    </a:solidFill>
+                  </a:tcPr>
+                </a:tc>
+                <a:tc>
+                  <a:txBody>
+                    <a:bodyPr wrap="square"/>
+                    <a:lstStyle/>
+                    <a:p>
+                      <a:pPr algn="ctr"/>
+                      <a:r>
+                        <a:rPr sz="1500" b="1">
+                          <a:solidFill>
+                            <a:srgbClr val="1F6B3A"/>
+                          </a:solidFill>
+                        </a:rPr>
+                        <a:t>29.09</a:t>
+                      </a:r>
+                    </a:p>
+                  </a:txBody>
+                  <a:tcPr>
+                    <a:solidFill>
+                      <a:srgbClr val="F2F2F2"/>
+                    </a:solidFill>
+                  </a:tcPr>
+                </a:tc>
+                <a:tc>
+                  <a:txBody>
+                    <a:bodyPr wrap="square"/>
+                    <a:lstStyle/>
+                    <a:p>
+                      <a:pPr algn="ctr"/>
+                      <a:r>
+                        <a:rPr sz="1500" b="1">
+                          <a:solidFill>
+                            <a:srgbClr val="1F6B3A"/>
+                          </a:solidFill>
+                        </a:rPr>
+                        <a:t>24.65</a:t>
+                      </a:r>
+                    </a:p>
+                  </a:txBody>
+                  <a:tcPr>
+                    <a:solidFill>
+                      <a:srgbClr val="F2F2F2"/>
+                    </a:solidFill>
+                  </a:tcPr>
+                </a:tc>
+              </a:tr>
+            </a:tbl>
+          </a:graphicData>
+        </a:graphic>
+      </p:graphicFrame>
+      <p:sp>
+        <p:nvSpPr>
+          <p:cNvPr id="9" name="TextBox 8"/>
+          <p:cNvSpPr txBox="1"/>
+          <p:nvPr/>
+        </p:nvSpPr>
+        <p:spPr>
+          <a:xfrm>
+            <a:off x="457200" y="4160520"/>
+            <a:ext cx="11247120" cy="2286000"/>
+          </a:xfrm>
+          <a:prstGeom prst="rect">
+            <a:avLst/>
+          </a:prstGeom>
+          <a:noFill/>
+        </p:spPr>
+        <p:txBody>
+          <a:bodyPr wrap="square">
+            <a:spAutoFit/>
+          </a:bodyPr>
+          <a:lstStyle/>
+          <a:p>
+            <a:pPr algn="l" indent="-114300" marL="228600">
+              <a:buChar char="•"/>
+            </a:pPr>
+            <a:r>
+              <a:rPr sz="1500">
+                <a:solidFill>
+                  <a:srgbClr val="000000"/>
+                </a:solidFill>
+              </a:rPr>
+              <a:t>Personalisation gap is small (0.3-1.2 mg/dL) across all 5 models, not just RF/LSTM — the effect generalises across architectures.</a:t>
+            </a:r>
+          </a:p>
+          <a:p>
+            <a:pPr algn="l" indent="-114300" marL="228600">
+              <a:buChar char="•"/>
+            </a:pPr>
+            <a:r>
+              <a:rPr sz="1500">
+                <a:solidFill>
+                  <a:srgbClr val="000000"/>
+                </a:solidFill>
+              </a:rPr>
+              <a:t>Per-patient scaling consistently beats pooled — removing inter-patient baseline differences helps the population model.</a:t>
+            </a:r>
+          </a:p>
+          <a:p>
+            <a:pPr algn="l" indent="-114300" marL="228600">
+              <a:buChar char="•"/>
+            </a:pPr>
+            <a:r>
+              <a:rPr sz="1500">
+                <a:solidFill>
+                  <a:srgbClr val="000000"/>
+                </a:solidFill>
+              </a:rPr>
+              <a:t>TCN is the exception: pooled gap is large (+5 mg/dL) but collapses to +0.5 mg/dL with per-patient scaling. TCN's poor generalisation was driven by inter-patient baseline glucose differences, not architecture.</a:t>
+            </a:r>
+          </a:p>
+        </p:txBody>
+      </p:sp>
+    </p:spTree>
+  </p:cSld>
+  <p:clrMapOvr>
+    <a:masterClrMapping/>
+  </p:clrMapOvr>
+</p:sld>
+</file>
+
+<file path=ppt/slides/slide11.xml><?xml version="1.0" encoding="utf-8"?>
+<p:sld xmlns:a="http://schemas.openxmlformats.org/drawingml/2006/main" xmlns:p="http://schemas.openxmlformats.org/presentationml/2006/main" xmlns:r="http://schemas.openxmlformats.org/officeDocument/2006/relationships">
+  <p:cSld>
+    <p:spTree>
+      <p:nvGrpSpPr>
+        <p:cNvPr id="1" name=""/>
+        <p:cNvGrpSpPr/>
+        <p:nvPr/>
+      </p:nvGrpSpPr>
+      <p:grpSpPr/>
+      <p:sp>
+        <p:nvSpPr>
+          <p:cNvPr id="2" name="Rectangle 1"/>
+          <p:cNvSpPr/>
+          <p:nvPr/>
+        </p:nvSpPr>
+        <p:spPr>
+          <a:xfrm>
+            <a:off x="0" y="0"/>
+            <a:ext cx="12188952" cy="1143000"/>
+          </a:xfrm>
+          <a:prstGeom prst="rect">
+            <a:avLst/>
+          </a:prstGeom>
+          <a:solidFill>
+            <a:srgbClr val="1F3864"/>
+          </a:solidFill>
+          <a:ln>
+            <a:noFill/>
+          </a:ln>
+        </p:spPr>
+        <p:style>
+          <a:lnRef idx="1">
+            <a:schemeClr val="accent1"/>
+          </a:lnRef>
+          <a:fillRef idx="3">
+            <a:schemeClr val="accent1"/>
+          </a:fillRef>
+          <a:effectRef idx="2">
+            <a:schemeClr val="accent1"/>
+          </a:effectRef>
+          <a:fontRef idx="minor">
+            <a:schemeClr val="lt1"/>
+          </a:fontRef>
+        </p:style>
+        <p:txBody>
+          <a:bodyPr rtlCol="0" anchor="ctr"/>
+          <a:lstStyle/>
+          <a:p>
+            <a:pPr algn="ctr"/>
+          </a:p>
+        </p:txBody>
+      </p:sp>
+      <p:sp>
+        <p:nvSpPr>
+          <p:cNvPr id="3" name="TextBox 2"/>
+          <p:cNvSpPr txBox="1"/>
+          <p:nvPr/>
+        </p:nvSpPr>
+        <p:spPr>
+          <a:xfrm>
+            <a:off x="320040" y="137160"/>
+            <a:ext cx="11430000" cy="914400"/>
+          </a:xfrm>
+          <a:prstGeom prst="rect">
+            <a:avLst/>
+          </a:prstGeom>
+          <a:noFill/>
+        </p:spPr>
+        <p:txBody>
+          <a:bodyPr wrap="square">
+            <a:spAutoFit/>
+          </a:bodyPr>
+          <a:lstStyle/>
+          <a:p>
+            <a:pPr algn="l"/>
+            <a:r>
+              <a:rPr sz="2800" b="1">
+                <a:solidFill>
+                  <a:srgbClr val="FFFFFF"/>
+                </a:solidFill>
+              </a:rPr>
+              <a:t>Transfer Learning: Domain Shift Costs ~1-2 mg/dL</a:t>
+            </a:r>
+          </a:p>
+        </p:txBody>
+      </p:sp>
+      <p:sp>
+        <p:nvSpPr>
+          <p:cNvPr id="4" name="Rectangle 3"/>
+          <p:cNvSpPr/>
+          <p:nvPr/>
+        </p:nvSpPr>
+        <p:spPr>
+          <a:xfrm>
+            <a:off x="0" y="6537960"/>
+            <a:ext cx="12188952" cy="320040"/>
+          </a:xfrm>
+          <a:prstGeom prst="rect">
+            <a:avLst/>
+          </a:prstGeom>
+          <a:solidFill>
+            <a:srgbClr val="1F3864"/>
+          </a:solidFill>
+          <a:ln>
+            <a:noFill/>
+          </a:ln>
+        </p:spPr>
+        <p:style>
+          <a:lnRef idx="1">
+            <a:schemeClr val="accent1"/>
+          </a:lnRef>
+          <a:fillRef idx="3">
+            <a:schemeClr val="accent1"/>
+          </a:fillRef>
+          <a:effectRef idx="2">
+            <a:schemeClr val="accent1"/>
+          </a:effectRef>
+          <a:fontRef idx="minor">
+            <a:schemeClr val="lt1"/>
+          </a:fontRef>
+        </p:style>
+        <p:txBody>
+          <a:bodyPr rtlCol="0" anchor="ctr"/>
+          <a:lstStyle/>
+          <a:p>
+            <a:pPr algn="ctr"/>
+          </a:p>
+        </p:txBody>
+      </p:sp>
+      <p:sp>
+        <p:nvSpPr>
+          <p:cNvPr id="5" name="TextBox 4"/>
+          <p:cNvSpPr txBox="1"/>
+          <p:nvPr/>
+        </p:nvSpPr>
+        <p:spPr>
+          <a:xfrm>
+            <a:off x="182880" y="6556248"/>
+            <a:ext cx="9144000" cy="274320"/>
+          </a:xfrm>
+          <a:prstGeom prst="rect">
+            <a:avLst/>
+          </a:prstGeom>
+          <a:noFill/>
+        </p:spPr>
+        <p:txBody>
+          <a:bodyPr wrap="square">
+            <a:spAutoFit/>
+          </a:bodyPr>
+          <a:lstStyle/>
+          <a:p>
+            <a:pPr algn="l"/>
+            <a:r>
+              <a:rPr sz="1000" b="0">
+                <a:solidFill>
+                  <a:srgbClr val="FFFFFF"/>
+                </a:solidFill>
+              </a:rPr>
+              <a:t>Blood Glucose Forecasting  |  University of Duisburg-Essen</a:t>
+            </a:r>
+          </a:p>
+        </p:txBody>
+      </p:sp>
+      <p:sp>
+        <p:nvSpPr>
+          <p:cNvPr id="6" name="TextBox 5"/>
+          <p:cNvSpPr txBox="1"/>
+          <p:nvPr/>
+        </p:nvSpPr>
+        <p:spPr>
+          <a:xfrm>
+            <a:off x="11430000" y="6556248"/>
+            <a:ext cx="640080" cy="274320"/>
+          </a:xfrm>
+          <a:prstGeom prst="rect">
+            <a:avLst/>
+          </a:prstGeom>
+          <a:noFill/>
+        </p:spPr>
+        <p:txBody>
+          <a:bodyPr wrap="square">
+            <a:spAutoFit/>
+          </a:bodyPr>
+          <a:lstStyle/>
+          <a:p>
+            <a:pPr algn="r"/>
+            <a:r>
+              <a:rPr sz="1000" b="1">
+                <a:solidFill>
+                  <a:srgbClr val="FFFFFF"/>
+                </a:solidFill>
+              </a:rPr>
+              <a:t>11</a:t>
             </a:r>
           </a:p>
         </p:txBody>
@@ -3879,14 +4750,14 @@
         </p:nvSpPr>
         <p:spPr>
           <a:xfrm>
-            <a:off x="365760" y="3063240"/>
-            <a:ext cx="11430000" cy="1371600"/>
+            <a:off x="365760" y="2606040"/>
+            <a:ext cx="11430000" cy="960120"/>
           </a:xfrm>
           <a:prstGeom prst="rect">
             <a:avLst/>
           </a:prstGeom>
           <a:solidFill>
-            <a:srgbClr val="DFE8F5"/>
+            <a:srgbClr val="E3EAF7"/>
           </a:solidFill>
           <a:ln>
             <a:noFill/>
@@ -3922,8 +4793,8 @@
         </p:nvSpPr>
         <p:spPr>
           <a:xfrm>
-            <a:off x="548640" y="3154680"/>
-            <a:ext cx="11064240" cy="1188720"/>
+            <a:off x="502920" y="2679192"/>
+            <a:ext cx="11155680" cy="813816"/>
           </a:xfrm>
           <a:prstGeom prst="rect">
             <a:avLst/>
@@ -3932,20 +4803,29 @@
         </p:spPr>
         <p:txBody>
           <a:bodyPr wrap="square">
-            <a:spAutoFit/>
+            <a:normAutofit/>
           </a:bodyPr>
           <a:lstStyle/>
           <a:p>
             <a:pPr algn="l"/>
             <a:r>
-              <a:rPr sz="1400" b="0">
+              <a:rPr sz="1300" b="1">
                 <a:solidFill>
                   <a:srgbClr val="1F3864"/>
                 </a:solidFill>
               </a:rPr>
-              <a:t>Trained on OhioT1DM  (T1DM, Medtronic Enlite CGM)
-Tested zero-shot on Glucdict  (prediabetic, Dexcom G6 CGM)
-Different population + different device = only +1-2 mg/dL penalty</a:t>
+              <a:t>Definitions:</a:t>
+            </a:r>
+          </a:p>
+          <a:p>
+            <a:pPr algn="l"/>
+            <a:r>
+              <a:rPr sz="1200">
+                <a:solidFill>
+                  <a:srgbClr val="1F3864"/>
+                </a:solidFill>
+              </a:rPr>
+              <a:t>'Personalised' = a model trained and tested on the same individual patient's own data  (the standard per-patient setup). Transfer = an OhioT1DM-trained model applied zero-shot to Glucdict users it never saw during training.</a:t>
             </a:r>
           </a:p>
         </p:txBody>
@@ -3958,14 +4838,14 @@
         </p:nvSpPr>
         <p:spPr>
           <a:xfrm>
-            <a:off x="365760" y="4617720"/>
-            <a:ext cx="11430000" cy="1005840"/>
+            <a:off x="365760" y="3703320"/>
+            <a:ext cx="11430000" cy="1188720"/>
           </a:xfrm>
           <a:prstGeom prst="rect">
             <a:avLst/>
           </a:prstGeom>
           <a:solidFill>
-            <a:srgbClr val="1F3864"/>
+            <a:srgbClr val="DFE8F5"/>
           </a:solidFill>
           <a:ln>
             <a:noFill/>
@@ -4001,8 +4881,8 @@
         </p:nvSpPr>
         <p:spPr>
           <a:xfrm>
-            <a:off x="548640" y="4709160"/>
-            <a:ext cx="11064240" cy="822960"/>
+            <a:off x="548640" y="3794760"/>
+            <a:ext cx="11064240" cy="1005840"/>
           </a:xfrm>
           <a:prstGeom prst="rect">
             <a:avLst/>
@@ -4015,46 +4895,30 @@
           </a:bodyPr>
           <a:lstStyle/>
           <a:p>
-            <a:pPr algn="ctr"/>
-            <a:r>
-              <a:rPr sz="1700" b="1">
+            <a:pPr algn="l"/>
+            <a:r>
+              <a:rPr sz="1400" b="0">
                 <a:solidFill>
-                  <a:srgbClr val="FFFFFF"/>
+                  <a:srgbClr val="1F3864"/>
                 </a:solidFill>
               </a:rPr>
-              <a:t>Glucose autocorrelation is the dominant predictive signal regardless of patient population or device.</a:t>
-            </a:r>
-          </a:p>
-        </p:txBody>
-      </p:sp>
-    </p:spTree>
-  </p:cSld>
-  <p:clrMapOvr>
-    <a:masterClrMapping/>
-  </p:clrMapOvr>
-</p:sld>
-</file>
-
-<file path=ppt/slides/slide11.xml><?xml version="1.0" encoding="utf-8"?>
-<p:sld xmlns:a="http://schemas.openxmlformats.org/drawingml/2006/main" xmlns:p="http://schemas.openxmlformats.org/presentationml/2006/main" xmlns:r="http://schemas.openxmlformats.org/officeDocument/2006/relationships">
-  <p:cSld>
-    <p:spTree>
-      <p:nvGrpSpPr>
-        <p:cNvPr id="1" name=""/>
-        <p:cNvGrpSpPr/>
-        <p:nvPr/>
-      </p:nvGrpSpPr>
-      <p:grpSpPr/>
-      <p:sp>
-        <p:nvSpPr>
-          <p:cNvPr id="2" name="Rectangle 1"/>
+              <a:t>Trained on OhioT1DM  (T1DM, Medtronic Enlite CGM)
+Tested zero-shot on Glucdict  (prediabetic, Dexcom G6 CGM)
+Different population + different device = only +1-2 mg/dL penalty</a:t>
+            </a:r>
+          </a:p>
+        </p:txBody>
+      </p:sp>
+      <p:sp>
+        <p:nvSpPr>
+          <p:cNvPr id="12" name="Rectangle 11"/>
           <p:cNvSpPr/>
           <p:nvPr/>
         </p:nvSpPr>
         <p:spPr>
           <a:xfrm>
-            <a:off x="0" y="0"/>
-            <a:ext cx="12188952" cy="1143000"/>
+            <a:off x="365760" y="5029200"/>
+            <a:ext cx="11430000" cy="1005840"/>
           </a:xfrm>
           <a:prstGeom prst="rect">
             <a:avLst/>
@@ -4090,14 +4954,14 @@
       </p:sp>
       <p:sp>
         <p:nvSpPr>
-          <p:cNvPr id="3" name="TextBox 2"/>
+          <p:cNvPr id="13" name="TextBox 12"/>
           <p:cNvSpPr txBox="1"/>
           <p:nvPr/>
         </p:nvSpPr>
         <p:spPr>
           <a:xfrm>
-            <a:off x="320040" y="137160"/>
-            <a:ext cx="11430000" cy="914400"/>
+            <a:off x="548640" y="5120640"/>
+            <a:ext cx="11064240" cy="822960"/>
           </a:xfrm>
           <a:prstGeom prst="rect">
             <a:avLst/>
@@ -4110,39 +4974,46 @@
           </a:bodyPr>
           <a:lstStyle/>
           <a:p>
-            <a:pPr algn="l"/>
-            <a:r>
-              <a:rPr sz="2800" b="1">
+            <a:pPr algn="ctr"/>
+            <a:r>
+              <a:rPr sz="1700" b="1">
                 <a:solidFill>
                   <a:srgbClr val="FFFFFF"/>
                 </a:solidFill>
               </a:rPr>
-              <a:t>Glucdict: All 5 Models</a:t>
-            </a:r>
-          </a:p>
-          <a:p>
-            <a:pPr algn="l"/>
-            <a:r>
-              <a:rPr sz="1400" b="0">
-                <a:solidFill>
-                  <a:srgbClr val="BFD7FF"/>
-                </a:solidFill>
-              </a:rPr>
-              <a:t>glucose_only, 30-min horizon, 13 users</a:t>
-            </a:r>
-          </a:p>
-        </p:txBody>
-      </p:sp>
-      <p:sp>
-        <p:nvSpPr>
-          <p:cNvPr id="4" name="Rectangle 3"/>
+              <a:t>Glucose autocorrelation is the dominant predictive signal regardless of patient population or device.</a:t>
+            </a:r>
+          </a:p>
+        </p:txBody>
+      </p:sp>
+    </p:spTree>
+  </p:cSld>
+  <p:clrMapOvr>
+    <a:masterClrMapping/>
+  </p:clrMapOvr>
+</p:sld>
+</file>
+
+<file path=ppt/slides/slide12.xml><?xml version="1.0" encoding="utf-8"?>
+<p:sld xmlns:a="http://schemas.openxmlformats.org/drawingml/2006/main" xmlns:p="http://schemas.openxmlformats.org/presentationml/2006/main" xmlns:r="http://schemas.openxmlformats.org/officeDocument/2006/relationships">
+  <p:cSld>
+    <p:spTree>
+      <p:nvGrpSpPr>
+        <p:cNvPr id="1" name=""/>
+        <p:cNvGrpSpPr/>
+        <p:nvPr/>
+      </p:nvGrpSpPr>
+      <p:grpSpPr/>
+      <p:sp>
+        <p:nvSpPr>
+          <p:cNvPr id="2" name="Rectangle 1"/>
           <p:cNvSpPr/>
           <p:nvPr/>
         </p:nvSpPr>
         <p:spPr>
           <a:xfrm>
-            <a:off x="0" y="6537960"/>
-            <a:ext cx="12188952" cy="320040"/>
+            <a:off x="0" y="0"/>
+            <a:ext cx="12188952" cy="1143000"/>
           </a:xfrm>
           <a:prstGeom prst="rect">
             <a:avLst/>
@@ -4178,6 +5049,94 @@
       </p:sp>
       <p:sp>
         <p:nvSpPr>
+          <p:cNvPr id="3" name="TextBox 2"/>
+          <p:cNvSpPr txBox="1"/>
+          <p:nvPr/>
+        </p:nvSpPr>
+        <p:spPr>
+          <a:xfrm>
+            <a:off x="320040" y="137160"/>
+            <a:ext cx="11430000" cy="914400"/>
+          </a:xfrm>
+          <a:prstGeom prst="rect">
+            <a:avLst/>
+          </a:prstGeom>
+          <a:noFill/>
+        </p:spPr>
+        <p:txBody>
+          <a:bodyPr wrap="square">
+            <a:spAutoFit/>
+          </a:bodyPr>
+          <a:lstStyle/>
+          <a:p>
+            <a:pPr algn="l"/>
+            <a:r>
+              <a:rPr sz="2800" b="1">
+                <a:solidFill>
+                  <a:srgbClr val="FFFFFF"/>
+                </a:solidFill>
+              </a:rPr>
+              <a:t>Glucdict: All 5 Models</a:t>
+            </a:r>
+          </a:p>
+          <a:p>
+            <a:pPr algn="l"/>
+            <a:r>
+              <a:rPr sz="1400" b="0">
+                <a:solidFill>
+                  <a:srgbClr val="BFD7FF"/>
+                </a:solidFill>
+              </a:rPr>
+              <a:t>glucose_only, 30-min horizon, 13 users</a:t>
+            </a:r>
+          </a:p>
+        </p:txBody>
+      </p:sp>
+      <p:sp>
+        <p:nvSpPr>
+          <p:cNvPr id="4" name="Rectangle 3"/>
+          <p:cNvSpPr/>
+          <p:nvPr/>
+        </p:nvSpPr>
+        <p:spPr>
+          <a:xfrm>
+            <a:off x="0" y="6537960"/>
+            <a:ext cx="12188952" cy="320040"/>
+          </a:xfrm>
+          <a:prstGeom prst="rect">
+            <a:avLst/>
+          </a:prstGeom>
+          <a:solidFill>
+            <a:srgbClr val="1F3864"/>
+          </a:solidFill>
+          <a:ln>
+            <a:noFill/>
+          </a:ln>
+        </p:spPr>
+        <p:style>
+          <a:lnRef idx="1">
+            <a:schemeClr val="accent1"/>
+          </a:lnRef>
+          <a:fillRef idx="3">
+            <a:schemeClr val="accent1"/>
+          </a:fillRef>
+          <a:effectRef idx="2">
+            <a:schemeClr val="accent1"/>
+          </a:effectRef>
+          <a:fontRef idx="minor">
+            <a:schemeClr val="lt1"/>
+          </a:fontRef>
+        </p:style>
+        <p:txBody>
+          <a:bodyPr rtlCol="0" anchor="ctr"/>
+          <a:lstStyle/>
+          <a:p>
+            <a:pPr algn="ctr"/>
+          </a:p>
+        </p:txBody>
+      </p:sp>
+      <p:sp>
+        <p:nvSpPr>
           <p:cNvPr id="5" name="TextBox 4"/>
           <p:cNvSpPr txBox="1"/>
           <p:nvPr/>
@@ -4239,7 +5198,7 @@
                   <a:srgbClr val="FFFFFF"/>
                 </a:solidFill>
               </a:rPr>
-              <a:t>11</a:t>
+              <a:t>12</a:t>
             </a:r>
           </a:p>
         </p:txBody>
@@ -4765,7 +5724,7 @@
 </p:sld>
 </file>
 
-<file path=ppt/slides/slide12.xml><?xml version="1.0" encoding="utf-8"?>
+<file path=ppt/slides/slide13.xml><?xml version="1.0" encoding="utf-8"?>
 <p:sld xmlns:a="http://schemas.openxmlformats.org/drawingml/2006/main" xmlns:p="http://schemas.openxmlformats.org/presentationml/2006/main" xmlns:r="http://schemas.openxmlformats.org/officeDocument/2006/relationships">
   <p:cSld>
     <p:spTree>
@@ -4969,7 +5928,7 @@
                   <a:srgbClr val="FFFFFF"/>
                 </a:solidFill>
               </a:rPr>
-              <a:t>12</a:t>
+              <a:t>13</a:t>
             </a:r>
           </a:p>
         </p:txBody>
@@ -5884,7 +6843,7 @@
                   <a:srgbClr val="1F3864"/>
                 </a:solidFill>
               </a:rPr>
-              <a:t>Why 3 features? (1) Only glucose, insulin bolus, and carbohydrates are present for ALL 12 patients across both cohorts — the 2018 cohort has heart rate and steps while the 2020 cohort has acceleration instead. No single wearable feature is universal. (2) Using 3 features as the controlled baseline enables the ablation study (Slide 8) to isolate the contribution of each additional signal. (3) The ablation confirmed wearable features consistently degrade performance — the gap to literature is therefore architectural, not feature-driven.</a:t>
+              <a:t>Why 3 features? (1) Only glucose, insulin bolus, and carbohydrates are present for ALL 12 patients across both cohorts — the 2018 cohort has heart rate and steps while the 2020 cohort has acceleration instead. No single wearable feature is universal. (2) Using 3 features as the controlled baseline enables the ablation study (Slide 8) to isolate the contribution of each additional signal. (3) The ablation confirmed wearable features do not improve prediction — the gap to literature is therefore architectural, not feature-driven.</a:t>
             </a:r>
           </a:p>
         </p:txBody>
@@ -5931,7 +6890,7 @@
 </p:sld>
 </file>
 
-<file path=ppt/slides/slide13.xml><?xml version="1.0" encoding="utf-8"?>
+<file path=ppt/slides/slide14.xml><?xml version="1.0" encoding="utf-8"?>
 <p:sld xmlns:a="http://schemas.openxmlformats.org/drawingml/2006/main" xmlns:p="http://schemas.openxmlformats.org/presentationml/2006/main" xmlns:r="http://schemas.openxmlformats.org/officeDocument/2006/relationships">
   <p:cSld>
     <p:spTree>
@@ -6124,7 +7083,7 @@
                   <a:srgbClr val="FFFFFF"/>
                 </a:solidFill>
               </a:rPr>
-              <a:t>13</a:t>
+              <a:t>14</a:t>
             </a:r>
           </a:p>
         </p:txBody>
@@ -6962,7 +7921,7 @@
 </p:sld>
 </file>
 
-<file path=ppt/slides/slide14.xml><?xml version="1.0" encoding="utf-8"?>
+<file path=ppt/slides/slide15.xml><?xml version="1.0" encoding="utf-8"?>
 <p:sld xmlns:a="http://schemas.openxmlformats.org/drawingml/2006/main" xmlns:p="http://schemas.openxmlformats.org/presentationml/2006/main" xmlns:r="http://schemas.openxmlformats.org/officeDocument/2006/relationships">
   <p:cSld>
     <p:spTree>
@@ -7155,7 +8114,7 @@
                   <a:srgbClr val="FFFFFF"/>
                 </a:solidFill>
               </a:rPr>
-              <a:t>14</a:t>
+              <a:t>15</a:t>
             </a:r>
           </a:p>
         </p:txBody>
@@ -7266,7 +8225,7 @@
                   <a:srgbClr val="1F3864"/>
                 </a:solidFill>
               </a:rPr>
-              <a:t>WEARABLE FEATURES CONSISTENTLY HURT AT 30 MINUTES</a:t>
+              <a:t>WEARABLE FEATURES DO NOT IMPROVE 30-MIN PREDICTION</a:t>
             </a:r>
           </a:p>
         </p:txBody>
@@ -7300,8 +8259,8 @@
                   <a:srgbClr val="000000"/>
                 </a:solidFill>
               </a:rPr>
-              <a:t>Observed across all 3 datasets and both cohorts.
-Clinical minimum (glucose + insulin + carbs) is sufficient.</a:t>
+              <a:t>Degrade prediction on OhioT1DM (both cohorts); roughly tied with glucose-only on Glucdict.
+Minimal features (glucose + clinical) are sufficient — no dataset benefits from the full wearable set.</a:t>
             </a:r>
           </a:p>
         </p:txBody>
@@ -7606,7 +8565,7 @@
 </p:sld>
 </file>
 
-<file path=ppt/slides/slide15.xml><?xml version="1.0" encoding="utf-8"?>
+<file path=ppt/slides/slide16.xml><?xml version="1.0" encoding="utf-8"?>
 <p:sld xmlns:a="http://schemas.openxmlformats.org/drawingml/2006/main" xmlns:p="http://schemas.openxmlformats.org/presentationml/2006/main" xmlns:r="http://schemas.openxmlformats.org/officeDocument/2006/relationships">
   <p:cSld>
     <p:spTree>
@@ -7799,7 +8758,7 @@
                   <a:srgbClr val="FFFFFF"/>
                 </a:solidFill>
               </a:rPr>
-              <a:t>15</a:t>
+              <a:t>16</a:t>
             </a:r>
           </a:p>
         </p:txBody>
@@ -8112,7 +9071,7 @@
                             <a:srgbClr val="000000"/>
                           </a:solidFill>
                         </a:rPr>
-                        <a:t>Unified Clarke EGA</a:t>
+                        <a:t>Unified Clarke EGA (15/30/45-min)</a:t>
                       </a:r>
                     </a:p>
                   </a:txBody>
@@ -8156,7 +9115,7 @@
                             <a:srgbClr val="000000"/>
                           </a:solidFill>
                         </a:rPr>
-                        <a:t>Planned week 1</a:t>
+                        <a:t>Done</a:t>
                       </a:r>
                     </a:p>
                   </a:txBody>
@@ -8471,7 +9430,7 @@
               <a:buChar char="•"/>
             </a:pPr>
             <a:r>
-              <a:rPr sz="1800">
+              <a:rPr sz="1700">
                 <a:solidFill>
                   <a:srgbClr val="000000"/>
                 </a:solidFill>
@@ -8484,7 +9443,7 @@
               <a:buChar char="•"/>
             </a:pPr>
             <a:r>
-              <a:rPr sz="1800">
+              <a:rPr sz="1700">
                 <a:solidFill>
                   <a:srgbClr val="000000"/>
                 </a:solidFill>
@@ -8497,7 +9456,7 @@
               <a:buChar char="•"/>
             </a:pPr>
             <a:r>
-              <a:rPr sz="1800">
+              <a:rPr sz="1700">
                 <a:solidFill>
                   <a:srgbClr val="000000"/>
                 </a:solidFill>
@@ -8510,7 +9469,7 @@
               <a:buChar char="•"/>
             </a:pPr>
             <a:r>
-              <a:rPr sz="1800">
+              <a:rPr sz="1700">
                 <a:solidFill>
                   <a:srgbClr val="000000"/>
                 </a:solidFill>
@@ -8523,7 +9482,7 @@
               <a:buChar char="•"/>
             </a:pPr>
             <a:r>
-              <a:rPr sz="1800">
+              <a:rPr sz="1700">
                 <a:solidFill>
                   <a:srgbClr val="000000"/>
                 </a:solidFill>
@@ -8536,7 +9495,7 @@
               <a:buChar char="•"/>
             </a:pPr>
             <a:r>
-              <a:rPr sz="1800">
+              <a:rPr sz="1700">
                 <a:solidFill>
                   <a:srgbClr val="000000"/>
                 </a:solidFill>
@@ -8549,12 +9508,12 @@
               <a:buChar char="•"/>
             </a:pPr>
             <a:r>
-              <a:rPr sz="1800">
+              <a:rPr sz="1700">
                 <a:solidFill>
                   <a:srgbClr val="000000"/>
                 </a:solidFill>
               </a:rPr>
-              <a:t>Leave-One-Patient-Out cross-validation</a:t>
+              <a:t>Leave-One-Patient-Out cross-validation  (5 models, pooled + per-patient-scaled)</a:t>
             </a:r>
           </a:p>
           <a:p>
@@ -8562,7 +9521,7 @@
               <a:buChar char="•"/>
             </a:pPr>
             <a:r>
-              <a:rPr sz="1800">
+              <a:rPr sz="1700">
                 <a:solidFill>
                   <a:srgbClr val="000000"/>
                 </a:solidFill>
@@ -8575,7 +9534,7 @@
               <a:buChar char="•"/>
             </a:pPr>
             <a:r>
-              <a:rPr sz="1800">
+              <a:rPr sz="1700">
                 <a:solidFill>
                   <a:srgbClr val="000000"/>
                 </a:solidFill>
@@ -8588,7 +9547,20 @@
               <a:buChar char="•"/>
             </a:pPr>
             <a:r>
-              <a:rPr sz="1800">
+              <a:rPr sz="1700">
+                <a:solidFill>
+                  <a:srgbClr val="000000"/>
+                </a:solidFill>
+              </a:rPr>
+              <a:t>Unified Clarke Error Grid library across both pipelines  (15/30/45-min)</a:t>
+            </a:r>
+          </a:p>
+          <a:p>
+            <a:pPr algn="l" indent="-114300" marL="228600">
+              <a:buChar char="•"/>
+            </a:pPr>
+            <a:r>
+              <a:rPr sz="1700">
                 <a:solidFill>
                   <a:srgbClr val="000000"/>
                 </a:solidFill>
@@ -10933,7 +11905,7 @@
                   <a:srgbClr val="7F4F00"/>
                 </a:solidFill>
               </a:rPr>
-              <a:t>All values are RMSE (Root Mean Squared Error) in mg/dL. RMSE was chosen because: (1) it is the standard metric in all comparison papers (Kalita &amp; Mirza 2025, Xiong 2025, Rodríguez-Rodríguez 2024), enabling direct literature comparison; (2) it penalises large errors more heavily than MAE — clinically appropriate since a 40 mg/dL error is far more dangerous than four 10 mg/dL errors.</a:t>
+              <a:t>All values are RMSE (Root Mean Squared Error) in mg/dL. RMSE was chosen because: (1) it is the standard metric in all comparison papers (Kalita &amp; Mirza 2025, Bertachi et al. 2018, Rodríguez-Rodríguez et al. 2024), enabling direct literature comparison; (2) it penalises large errors more heavily than MAE — clinically appropriate since a 40 mg/dL error is far more dangerous than four 10 mg/dL errors.</a:t>
             </a:r>
           </a:p>
         </p:txBody>
@@ -12243,7 +13215,7 @@
                   <a:srgbClr val="BFD7FF"/>
                 </a:solidFill>
               </a:rPr>
-              <a:t>30-min horizon</a:t>
+              <a:t>15 / 30 / 45-min horizons — Zone A %, all 5 models</a:t>
             </a:r>
           </a:p>
         </p:txBody>
@@ -12368,8 +13340,8 @@
           <p:nvPr/>
         </p:nvGraphicFramePr>
         <p:xfrm>
-          <a:off x="365760" y="1280160"/>
-          <a:ext cx="6035040" cy="2304288"/>
+          <a:off x="365760" y="1371600"/>
+          <a:ext cx="6400800" cy="2304288"/>
         </p:xfrm>
         <a:graphic>
           <a:graphicData uri="http://schemas.openxmlformats.org/drawingml/2006/table">
@@ -12379,8 +13351,9 @@
               </a:tblPr>
               <a:tblGrid>
                 <a:gridCol w="1828800"/>
-                <a:gridCol w="1828800"/>
-                <a:gridCol w="2377440"/>
+                <a:gridCol w="1463040"/>
+                <a:gridCol w="1463040"/>
+                <a:gridCol w="1645920"/>
               </a:tblGrid>
               <a:tr h="384048">
                 <a:tc>
@@ -12417,7 +13390,7 @@
                             <a:srgbClr val="FFFFFF"/>
                           </a:solidFill>
                         </a:rPr>
-                        <a:t>Zone A %</a:t>
+                        <a:t>15-min</a:t>
                       </a:r>
                     </a:p>
                   </a:txBody>
@@ -12439,7 +13412,29 @@
                             <a:srgbClr val="FFFFFF"/>
                           </a:solidFill>
                         </a:rPr>
-                        <a:t>Zone B %</a:t>
+                        <a:t>30-min</a:t>
+                      </a:r>
+                    </a:p>
+                  </a:txBody>
+                  <a:tcPr>
+                    <a:solidFill>
+                      <a:srgbClr val="1F3864"/>
+                    </a:solidFill>
+                  </a:tcPr>
+                </a:tc>
+                <a:tc>
+                  <a:txBody>
+                    <a:bodyPr wrap="square"/>
+                    <a:lstStyle/>
+                    <a:p>
+                      <a:pPr algn="ctr"/>
+                      <a:r>
+                        <a:rPr sz="1400" b="1">
+                          <a:solidFill>
+                            <a:srgbClr val="FFFFFF"/>
+                          </a:solidFill>
+                        </a:rPr>
+                        <a:t>45-min</a:t>
                       </a:r>
                     </a:p>
                   </a:txBody>
@@ -12485,7 +13480,7 @@
                             <a:srgbClr val="1F6B3A"/>
                           </a:solidFill>
                         </a:rPr>
-                        <a:t>87.4 ± 4.6%</a:t>
+                        <a:t>96.9%</a:t>
                       </a:r>
                     </a:p>
                   </a:txBody>
@@ -12507,7 +13502,29 @@
                             <a:srgbClr val="1F6B3A"/>
                           </a:solidFill>
                         </a:rPr>
-                        <a:t>—</a:t>
+                        <a:t>87.0%</a:t>
+                      </a:r>
+                    </a:p>
+                  </a:txBody>
+                  <a:tcPr>
+                    <a:solidFill>
+                      <a:srgbClr val="F2F2F2"/>
+                    </a:solidFill>
+                  </a:tcPr>
+                </a:tc>
+                <a:tc>
+                  <a:txBody>
+                    <a:bodyPr wrap="square"/>
+                    <a:lstStyle/>
+                    <a:p>
+                      <a:pPr algn="ctr"/>
+                      <a:r>
+                        <a:rPr sz="1400" b="1">
+                          <a:solidFill>
+                            <a:srgbClr val="1F6B3A"/>
+                          </a:solidFill>
+                        </a:rPr>
+                        <a:t>76.0%</a:t>
                       </a:r>
                     </a:p>
                   </a:txBody>
@@ -12526,9 +13543,9 @@
                     <a:p>
                       <a:pPr algn="l"/>
                       <a:r>
-                        <a:rPr sz="1400" b="0">
-                          <a:solidFill>
-                            <a:srgbClr val="000000"/>
+                        <a:rPr sz="1400" b="1">
+                          <a:solidFill>
+                            <a:srgbClr val="1F6B3A"/>
                           </a:solidFill>
                         </a:rPr>
                         <a:t>Autoencoder</a:t>
@@ -12548,12 +13565,12 @@
                     <a:p>
                       <a:pPr algn="ctr"/>
                       <a:r>
-                        <a:rPr sz="1400" b="0">
-                          <a:solidFill>
-                            <a:srgbClr val="000000"/>
-                          </a:solidFill>
-                        </a:rPr>
-                        <a:t>87.1 ± 4.9%</a:t>
+                        <a:rPr sz="1400" b="1">
+                          <a:solidFill>
+                            <a:srgbClr val="1F6B3A"/>
+                          </a:solidFill>
+                        </a:rPr>
+                        <a:t>96.3%</a:t>
                       </a:r>
                     </a:p>
                   </a:txBody>
@@ -12570,12 +13587,34 @@
                     <a:p>
                       <a:pPr algn="ctr"/>
                       <a:r>
-                        <a:rPr sz="1400" b="0">
-                          <a:solidFill>
-                            <a:srgbClr val="000000"/>
-                          </a:solidFill>
-                        </a:rPr>
-                        <a:t>—</a:t>
+                        <a:rPr sz="1400" b="1">
+                          <a:solidFill>
+                            <a:srgbClr val="1F6B3A"/>
+                          </a:solidFill>
+                        </a:rPr>
+                        <a:t>86.7%</a:t>
+                      </a:r>
+                    </a:p>
+                  </a:txBody>
+                  <a:tcPr>
+                    <a:solidFill>
+                      <a:srgbClr val="FFFFFF"/>
+                    </a:solidFill>
+                  </a:tcPr>
+                </a:tc>
+                <a:tc>
+                  <a:txBody>
+                    <a:bodyPr wrap="square"/>
+                    <a:lstStyle/>
+                    <a:p>
+                      <a:pPr algn="ctr"/>
+                      <a:r>
+                        <a:rPr sz="1400" b="1">
+                          <a:solidFill>
+                            <a:srgbClr val="1F6B3A"/>
+                          </a:solidFill>
+                        </a:rPr>
+                        <a:t>76.2%</a:t>
                       </a:r>
                     </a:p>
                   </a:txBody>
@@ -12621,7 +13660,7 @@
                             <a:srgbClr val="000000"/>
                           </a:solidFill>
                         </a:rPr>
-                        <a:t>86.4 ± 5.1%</a:t>
+                        <a:t>96.5%</a:t>
                       </a:r>
                     </a:p>
                   </a:txBody>
@@ -12643,7 +13682,29 @@
                             <a:srgbClr val="000000"/>
                           </a:solidFill>
                         </a:rPr>
-                        <a:t>—</a:t>
+                        <a:t>86.4%</a:t>
+                      </a:r>
+                    </a:p>
+                  </a:txBody>
+                  <a:tcPr>
+                    <a:solidFill>
+                      <a:srgbClr val="F2F2F2"/>
+                    </a:solidFill>
+                  </a:tcPr>
+                </a:tc>
+                <a:tc>
+                  <a:txBody>
+                    <a:bodyPr wrap="square"/>
+                    <a:lstStyle/>
+                    <a:p>
+                      <a:pPr algn="ctr"/>
+                      <a:r>
+                        <a:rPr sz="1400" b="0">
+                          <a:solidFill>
+                            <a:srgbClr val="000000"/>
+                          </a:solidFill>
+                        </a:rPr>
+                        <a:t>75.3%</a:t>
                       </a:r>
                     </a:p>
                   </a:txBody>
@@ -12689,7 +13750,7 @@
                             <a:srgbClr val="000000"/>
                           </a:solidFill>
                         </a:rPr>
-                        <a:t>84.7 ± 5.2%</a:t>
+                        <a:t>95.2%</a:t>
                       </a:r>
                     </a:p>
                   </a:txBody>
@@ -12711,7 +13772,29 @@
                             <a:srgbClr val="000000"/>
                           </a:solidFill>
                         </a:rPr>
-                        <a:t>—</a:t>
+                        <a:t>85.8%</a:t>
+                      </a:r>
+                    </a:p>
+                  </a:txBody>
+                  <a:tcPr>
+                    <a:solidFill>
+                      <a:srgbClr val="FFFFFF"/>
+                    </a:solidFill>
+                  </a:tcPr>
+                </a:tc>
+                <a:tc>
+                  <a:txBody>
+                    <a:bodyPr wrap="square"/>
+                    <a:lstStyle/>
+                    <a:p>
+                      <a:pPr algn="ctr"/>
+                      <a:r>
+                        <a:rPr sz="1400" b="0">
+                          <a:solidFill>
+                            <a:srgbClr val="000000"/>
+                          </a:solidFill>
+                        </a:rPr>
+                        <a:t>75.9%</a:t>
                       </a:r>
                     </a:p>
                   </a:txBody>
@@ -12757,7 +13840,7 @@
                             <a:srgbClr val="000000"/>
                           </a:solidFill>
                         </a:rPr>
-                        <a:t>81.1 ± 7.9%</a:t>
+                        <a:t>93.5%</a:t>
                       </a:r>
                     </a:p>
                   </a:txBody>
@@ -12779,7 +13862,29 @@
                             <a:srgbClr val="000000"/>
                           </a:solidFill>
                         </a:rPr>
-                        <a:t>← high variance — unreliable</a:t>
+                        <a:t>81.6%</a:t>
+                      </a:r>
+                    </a:p>
+                  </a:txBody>
+                  <a:tcPr>
+                    <a:solidFill>
+                      <a:srgbClr val="F2F2F2"/>
+                    </a:solidFill>
+                  </a:tcPr>
+                </a:tc>
+                <a:tc>
+                  <a:txBody>
+                    <a:bodyPr wrap="square"/>
+                    <a:lstStyle/>
+                    <a:p>
+                      <a:pPr algn="ctr"/>
+                      <a:r>
+                        <a:rPr sz="1400" b="0">
+                          <a:solidFill>
+                            <a:srgbClr val="000000"/>
+                          </a:solidFill>
+                        </a:rPr>
+                        <a:t>69.9%</a:t>
                       </a:r>
                     </a:p>
                   </a:txBody>
@@ -12796,20 +13901,112 @@
       </p:graphicFrame>
       <p:sp>
         <p:nvSpPr>
-          <p:cNvPr id="8" name="Rectangle 7"/>
+          <p:cNvPr id="8" name="TextBox 7"/>
+          <p:cNvSpPr txBox="1"/>
+          <p:nvPr/>
+        </p:nvSpPr>
+        <p:spPr>
+          <a:xfrm>
+            <a:off x="365760" y="3749039"/>
+            <a:ext cx="6400800" cy="274320"/>
+          </a:xfrm>
+          <a:prstGeom prst="rect">
+            <a:avLst/>
+          </a:prstGeom>
+          <a:noFill/>
+        </p:spPr>
+        <p:txBody>
+          <a:bodyPr wrap="square">
+            <a:spAutoFit/>
+          </a:bodyPr>
+          <a:lstStyle/>
+          <a:p>
+            <a:pPr algn="l"/>
+            <a:r>
+              <a:rPr sz="1100" b="0">
+                <a:solidFill>
+                  <a:srgbClr val="2E5496"/>
+                </a:solidFill>
+              </a:rPr>
+              <a:t>TCN lowest and highest-variance at every horizon (see Slide 6 std).</a:t>
+            </a:r>
+          </a:p>
+        </p:txBody>
+      </p:sp>
+      <p:sp>
+        <p:nvSpPr>
+          <p:cNvPr id="9" name="TextBox 8"/>
+          <p:cNvSpPr txBox="1"/>
+          <p:nvPr/>
+        </p:nvSpPr>
+        <p:spPr>
+          <a:xfrm>
+            <a:off x="6949440" y="1298448"/>
+            <a:ext cx="4846320" cy="457200"/>
+          </a:xfrm>
+          <a:prstGeom prst="rect">
+            <a:avLst/>
+          </a:prstGeom>
+          <a:noFill/>
+        </p:spPr>
+        <p:txBody>
+          <a:bodyPr wrap="square">
+            <a:spAutoFit/>
+          </a:bodyPr>
+          <a:lstStyle/>
+          <a:p>
+            <a:pPr algn="l"/>
+            <a:r>
+              <a:rPr sz="1100" b="0">
+                <a:solidFill>
+                  <a:srgbClr val="2E5496"/>
+                </a:solidFill>
+              </a:rPr>
+              <a:t>Generated directly by the clarke-error-grid library (v0.1.4, ceg.plot) — RF, 30-min horizon shown as a representative model.</a:t>
+            </a:r>
+          </a:p>
+        </p:txBody>
+      </p:sp>
+      <p:pic>
+        <p:nvPicPr>
+          <p:cNvPr id="10" name="Picture 9" descr="clarke_30min_library.png"/>
+          <p:cNvPicPr>
+            <a:picLocks noChangeAspect="1"/>
+          </p:cNvPicPr>
+          <p:nvPr/>
+        </p:nvPicPr>
+        <p:blipFill>
+          <a:blip r:embed="rId2"/>
+          <a:stretch>
+            <a:fillRect/>
+          </a:stretch>
+        </p:blipFill>
+        <p:spPr>
+          <a:xfrm>
+            <a:off x="7269480" y="1783080"/>
+            <a:ext cx="4297680" cy="4297680"/>
+          </a:xfrm>
+          <a:prstGeom prst="rect">
+            <a:avLst/>
+          </a:prstGeom>
+        </p:spPr>
+      </p:pic>
+      <p:sp>
+        <p:nvSpPr>
+          <p:cNvPr id="11" name="Rectangle 10"/>
           <p:cNvSpPr/>
           <p:nvPr/>
         </p:nvSpPr>
         <p:spPr>
           <a:xfrm>
-            <a:off x="365760" y="4069080"/>
-            <a:ext cx="6035040" cy="1554480"/>
+            <a:off x="365760" y="4160520"/>
+            <a:ext cx="6400800" cy="914400"/>
           </a:xfrm>
           <a:prstGeom prst="rect">
             <a:avLst/>
           </a:prstGeom>
           <a:solidFill>
-            <a:srgbClr val="FFF0D0"/>
+            <a:srgbClr val="DFE8F5"/>
           </a:solidFill>
           <a:ln>
             <a:noFill/>
@@ -12839,14 +14036,14 @@
       </p:sp>
       <p:sp>
         <p:nvSpPr>
-          <p:cNvPr id="9" name="TextBox 8"/>
+          <p:cNvPr id="12" name="TextBox 11"/>
           <p:cNvSpPr txBox="1"/>
           <p:nvPr/>
         </p:nvSpPr>
         <p:spPr>
           <a:xfrm>
-            <a:off x="548640" y="4114800"/>
-            <a:ext cx="5760720" cy="1463040"/>
+            <a:off x="502920" y="4233672"/>
+            <a:ext cx="6126480" cy="768096"/>
           </a:xfrm>
           <a:prstGeom prst="rect">
             <a:avLst/>
@@ -12855,49 +14052,100 @@
         </p:spPr>
         <p:txBody>
           <a:bodyPr wrap="square">
-            <a:spAutoFit/>
+            <a:normAutofit/>
           </a:bodyPr>
           <a:lstStyle/>
           <a:p>
             <a:pPr algn="l"/>
             <a:r>
-              <a:rPr sz="1300" b="0">
+              <a:rPr sz="1200">
+                <a:solidFill>
+                  <a:srgbClr val="1F3864"/>
+                </a:solidFill>
+              </a:rPr>
+              <a:t>Zone A % is now computed via the shared clarke-error-grid library (v0.1.4), unifying zone classification with Abeer's pipeline — both sides report identical Clarke zones from the same reference implementation.</a:t>
+            </a:r>
+          </a:p>
+        </p:txBody>
+      </p:sp>
+      <p:sp>
+        <p:nvSpPr>
+          <p:cNvPr id="13" name="Rectangle 12"/>
+          <p:cNvSpPr/>
+          <p:nvPr/>
+        </p:nvSpPr>
+        <p:spPr>
+          <a:xfrm>
+            <a:off x="365760" y="5166360"/>
+            <a:ext cx="6400800" cy="1234440"/>
+          </a:xfrm>
+          <a:prstGeom prst="rect">
+            <a:avLst/>
+          </a:prstGeom>
+          <a:solidFill>
+            <a:srgbClr val="FFF0D0"/>
+          </a:solidFill>
+          <a:ln>
+            <a:noFill/>
+          </a:ln>
+        </p:spPr>
+        <p:style>
+          <a:lnRef idx="1">
+            <a:schemeClr val="accent1"/>
+          </a:lnRef>
+          <a:fillRef idx="3">
+            <a:schemeClr val="accent1"/>
+          </a:fillRef>
+          <a:effectRef idx="2">
+            <a:schemeClr val="accent1"/>
+          </a:effectRef>
+          <a:fontRef idx="minor">
+            <a:schemeClr val="lt1"/>
+          </a:fontRef>
+        </p:style>
+        <p:txBody>
+          <a:bodyPr rtlCol="0" anchor="ctr"/>
+          <a:lstStyle/>
+          <a:p>
+            <a:pPr algn="ctr"/>
+          </a:p>
+        </p:txBody>
+      </p:sp>
+      <p:sp>
+        <p:nvSpPr>
+          <p:cNvPr id="14" name="TextBox 13"/>
+          <p:cNvSpPr txBox="1"/>
+          <p:nvPr/>
+        </p:nvSpPr>
+        <p:spPr>
+          <a:xfrm>
+            <a:off x="502920" y="5239512"/>
+            <a:ext cx="6126480" cy="1088136"/>
+          </a:xfrm>
+          <a:prstGeom prst="rect">
+            <a:avLst/>
+          </a:prstGeom>
+          <a:noFill/>
+        </p:spPr>
+        <p:txBody>
+          <a:bodyPr wrap="square">
+            <a:normAutofit/>
+          </a:bodyPr>
+          <a:lstStyle/>
+          <a:p>
+            <a:pPr algn="l"/>
+            <a:r>
+              <a:rPr sz="1200">
                 <a:solidFill>
                   <a:srgbClr val="7F4F00"/>
                 </a:solidFill>
               </a:rPr>
-              <a:t>Clinical target: &gt; 95% Zone A.
-Gap explained by 3-feature input only.
-TCN high std deviation indicates inconsistency across
-patients — clinically concerning.</a:t>
-            </a:r>
-          </a:p>
-        </p:txBody>
-      </p:sp>
-      <p:pic>
-        <p:nvPicPr>
-          <p:cNvPr id="10" name="Picture 9" descr="clarke_30min_all_models.png"/>
-          <p:cNvPicPr>
-            <a:picLocks noChangeAspect="1"/>
-          </p:cNvPicPr>
-          <p:nvPr/>
-        </p:nvPicPr>
-        <p:blipFill>
-          <a:blip r:embed="rId2"/>
-          <a:stretch>
-            <a:fillRect/>
-          </a:stretch>
-        </p:blipFill>
-        <p:spPr>
-          <a:xfrm>
-            <a:off x="6583680" y="1234440"/>
-            <a:ext cx="5303520" cy="5120640"/>
-          </a:xfrm>
-          <a:prstGeom prst="rect">
-            <a:avLst/>
-          </a:prstGeom>
-        </p:spPr>
-      </p:pic>
+              <a:t>Clinical target: &gt; 95% Zone A — met only at the 15-min horizon.
+Zone A falls from ~96% (15-min) to ~76% (45-min) for every model — the classic accuracy/lookahead tradeoff. Gap to the clinical target also reflects the reduced 3-feature input used throughout this work.</a:t>
+            </a:r>
+          </a:p>
+        </p:txBody>
+      </p:sp>
     </p:spTree>
   </p:cSld>
   <p:clrMapOvr>
@@ -12988,7 +14236,7 @@
                   <a:srgbClr val="FFFFFF"/>
                 </a:solidFill>
               </a:rPr>
-              <a:t>Feature Ablation: Wearable Features Consistently Hurt</a:t>
+              <a:t>Feature Ablation: Wearable Features Do Not Improve Prediction</a:t>
             </a:r>
           </a:p>
         </p:txBody>
@@ -13416,7 +14664,7 @@
                   <a:srgbClr val="000000"/>
                 </a:solidFill>
               </a:rPr>
-              <a:t>glucose_only:</a:t>
+              <a:t>glucose_activity:</a:t>
             </a:r>
           </a:p>
           <a:p>
@@ -13427,7 +14675,29 @@
                   <a:srgbClr val="000000"/>
                 </a:solidFill>
               </a:rPr>
-              <a:t>  RF 15.23 / LSTM 14.03  ← best</a:t>
+              <a:t>  RF 15.19 / LSTM 13.86  ← best</a:t>
+            </a:r>
+          </a:p>
+          <a:p>
+            <a:pPr algn="l"/>
+            <a:r>
+              <a:rPr sz="1300" b="0">
+                <a:solidFill>
+                  <a:srgbClr val="000000"/>
+                </a:solidFill>
+              </a:rPr>
+              <a:t>glucose_only:</a:t>
+            </a:r>
+          </a:p>
+          <a:p>
+            <a:pPr algn="l"/>
+            <a:r>
+              <a:rPr sz="1300" b="0">
+                <a:solidFill>
+                  <a:srgbClr val="000000"/>
+                </a:solidFill>
+              </a:rPr>
+              <a:t>  RF 15.23 / LSTM 14.03  ← ~tied</a:t>
             </a:r>
           </a:p>
           <a:p>
@@ -13462,8 +14732,8 @@
         </p:nvSpPr>
         <p:spPr>
           <a:xfrm>
-            <a:off x="320040" y="4892040"/>
-            <a:ext cx="11521440" cy="1371600"/>
+            <a:off x="320040" y="4800600"/>
+            <a:ext cx="11521440" cy="1554480"/>
           </a:xfrm>
           <a:prstGeom prst="rect">
             <a:avLst/>
@@ -13505,8 +14775,8 @@
         </p:nvSpPr>
         <p:spPr>
           <a:xfrm>
-            <a:off x="548640" y="4983480"/>
-            <a:ext cx="11064240" cy="1188720"/>
+            <a:off x="548640" y="4892040"/>
+            <a:ext cx="11064240" cy="1371600"/>
           </a:xfrm>
           <a:prstGeom prst="rect">
             <a:avLst/>
@@ -13521,13 +14791,13 @@
           <a:p>
             <a:pPr algn="l"/>
             <a:r>
-              <a:rPr sz="1600" b="1">
+              <a:rPr sz="1500" b="1">
                 <a:solidFill>
                   <a:srgbClr val="FFFFFF"/>
                 </a:solidFill>
               </a:rPr>
-              <a:t>Across all 3 datasets and both cohorts: adding wearable signals consistently degrades 30-minute prediction.
-The clinical minimum (glucose + insulin + carbs) is sufficient.</a:t>
+              <a:t>On OhioT1DM (both cohorts), wearable features degrade 30-minute prediction; on Glucdict, light activity is roughly tied with glucose-only.
+The accurate claim: wearable features do not improve 30-minute prediction on any dataset — minimal features (glucose + clinical) are sufficient.</a:t>
             </a:r>
           </a:p>
         </p:txBody>
@@ -13622,7 +14892,7 @@
                   <a:srgbClr val="FFFFFF"/>
                 </a:solidFill>
               </a:rPr>
-              <a:t>LOPO: Personalisation Barely Matters</a:t>
+              <a:t>Best Feature Combination per Model</a:t>
             </a:r>
           </a:p>
         </p:txBody>
@@ -13738,51 +15008,17 @@
           </a:p>
         </p:txBody>
       </p:sp>
-      <p:sp>
-        <p:nvSpPr>
-          <p:cNvPr id="7" name="TextBox 6"/>
-          <p:cNvSpPr txBox="1"/>
-          <p:nvPr/>
-        </p:nvSpPr>
-        <p:spPr>
-          <a:xfrm>
-            <a:off x="365760" y="1234440"/>
-            <a:ext cx="5486400" cy="365760"/>
-          </a:xfrm>
-          <a:prstGeom prst="rect">
-            <a:avLst/>
-          </a:prstGeom>
-          <a:noFill/>
-        </p:spPr>
-        <p:txBody>
-          <a:bodyPr wrap="square">
-            <a:spAutoFit/>
-          </a:bodyPr>
-          <a:lstStyle/>
-          <a:p>
-            <a:pPr algn="l"/>
-            <a:r>
-              <a:rPr sz="1500" b="1">
-                <a:solidFill>
-                  <a:srgbClr val="1F3864"/>
-                </a:solidFill>
-              </a:rPr>
-              <a:t>LOPO vs. Personalised  (30-min, OhioT1DM)</a:t>
-            </a:r>
-          </a:p>
-        </p:txBody>
-      </p:sp>
       <p:graphicFrame>
         <p:nvGraphicFramePr>
-          <p:cNvPr id="8" name="Table 7"/>
+          <p:cNvPr id="7" name="Table 6"/>
           <p:cNvGraphicFramePr>
             <a:graphicFrameLocks noGrp="1"/>
           </p:cNvGraphicFramePr>
           <p:nvPr/>
         </p:nvGraphicFramePr>
         <p:xfrm>
-          <a:off x="365760" y="1645920"/>
-          <a:ext cx="6035040" cy="1152144"/>
+          <a:off x="548640" y="1554480"/>
+          <a:ext cx="9601200" cy="1536192"/>
         </p:xfrm>
         <a:graphic>
           <a:graphicData uri="http://schemas.openxmlformats.org/drawingml/2006/table">
@@ -13791,10 +15027,10 @@
                 <a:tableStyleId>{5C22544A-7EE6-4342-B048-85BDC9FD1C3A}</a:tableStyleId>
               </a:tblPr>
               <a:tblGrid>
-                <a:gridCol w="1280160"/>
-                <a:gridCol w="1737360"/>
-                <a:gridCol w="1463040"/>
-                <a:gridCol w="1554480"/>
+                <a:gridCol w="2926080"/>
+                <a:gridCol w="3017520"/>
+                <a:gridCol w="1828800"/>
+                <a:gridCol w="1828800"/>
               </a:tblGrid>
               <a:tr h="384048">
                 <a:tc>
@@ -13804,12 +15040,12 @@
                     <a:p>
                       <a:pPr algn="ctr"/>
                       <a:r>
-                        <a:rPr sz="1400" b="1">
+                        <a:rPr sz="1700" b="1">
                           <a:solidFill>
                             <a:srgbClr val="FFFFFF"/>
                           </a:solidFill>
                         </a:rPr>
-                        <a:t>Model</a:t>
+                        <a:t>Dataset</a:t>
                       </a:r>
                     </a:p>
                   </a:txBody>
@@ -13826,12 +15062,12 @@
                     <a:p>
                       <a:pPr algn="ctr"/>
                       <a:r>
-                        <a:rPr sz="1400" b="1">
+                        <a:rPr sz="1700" b="1">
                           <a:solidFill>
                             <a:srgbClr val="FFFFFF"/>
                           </a:solidFill>
                         </a:rPr>
-                        <a:t>Personalised</a:t>
+                        <a:t>Best feature set</a:t>
                       </a:r>
                     </a:p>
                   </a:txBody>
@@ -13848,12 +15084,12 @@
                     <a:p>
                       <a:pPr algn="ctr"/>
                       <a:r>
-                        <a:rPr sz="1400" b="1">
+                        <a:rPr sz="1700" b="1">
                           <a:solidFill>
                             <a:srgbClr val="FFFFFF"/>
                           </a:solidFill>
                         </a:rPr>
-                        <a:t>LOPO</a:t>
+                        <a:t>RF</a:t>
                       </a:r>
                     </a:p>
                   </a:txBody>
@@ -13870,12 +15106,12 @@
                     <a:p>
                       <a:pPr algn="ctr"/>
                       <a:r>
-                        <a:rPr sz="1400" b="1">
+                        <a:rPr sz="1700" b="1">
                           <a:solidFill>
                             <a:srgbClr val="FFFFFF"/>
                           </a:solidFill>
                         </a:rPr>
-                        <a:t>Gap</a:t>
+                        <a:t>LSTM</a:t>
                       </a:r>
                     </a:p>
                   </a:txBody>
@@ -13894,12 +15130,12 @@
                     <a:p>
                       <a:pPr algn="l"/>
                       <a:r>
-                        <a:rPr sz="1400" b="0">
-                          <a:solidFill>
-                            <a:srgbClr val="000000"/>
-                          </a:solidFill>
-                        </a:rPr>
-                        <a:t>RF</a:t>
+                        <a:rPr sz="1700" b="0">
+                          <a:solidFill>
+                            <a:srgbClr val="000000"/>
+                          </a:solidFill>
+                        </a:rPr>
+                        <a:t>OhioT1DM 2018</a:t>
                       </a:r>
                     </a:p>
                   </a:txBody>
@@ -13916,12 +15152,12 @@
                     <a:p>
                       <a:pPr algn="ctr"/>
                       <a:r>
-                        <a:rPr sz="1400" b="0">
-                          <a:solidFill>
-                            <a:srgbClr val="000000"/>
-                          </a:solidFill>
-                        </a:rPr>
-                        <a:t>23.35</a:t>
+                        <a:rPr sz="1700" b="0">
+                          <a:solidFill>
+                            <a:srgbClr val="000000"/>
+                          </a:solidFill>
+                        </a:rPr>
+                        <a:t>clinical</a:t>
                       </a:r>
                     </a:p>
                   </a:txBody>
@@ -13938,12 +15174,12 @@
                     <a:p>
                       <a:pPr algn="ctr"/>
                       <a:r>
-                        <a:rPr sz="1400" b="0">
-                          <a:solidFill>
-                            <a:srgbClr val="000000"/>
-                          </a:solidFill>
-                        </a:rPr>
-                        <a:t>22.81</a:t>
+                        <a:rPr sz="1700" b="0">
+                          <a:solidFill>
+                            <a:srgbClr val="000000"/>
+                          </a:solidFill>
+                        </a:rPr>
+                        <a:t>21.33</a:t>
                       </a:r>
                     </a:p>
                   </a:txBody>
@@ -13960,12 +15196,12 @@
                     <a:p>
                       <a:pPr algn="ctr"/>
                       <a:r>
-                        <a:rPr sz="1400" b="0">
-                          <a:solidFill>
-                            <a:srgbClr val="000000"/>
-                          </a:solidFill>
-                        </a:rPr>
-                        <a:t>-0.54 (improves!)</a:t>
+                        <a:rPr sz="1700" b="0">
+                          <a:solidFill>
+                            <a:srgbClr val="000000"/>
+                          </a:solidFill>
+                        </a:rPr>
+                        <a:t>20.22</a:t>
                       </a:r>
                     </a:p>
                   </a:txBody>
@@ -13984,12 +15220,12 @@
                     <a:p>
                       <a:pPr algn="l"/>
                       <a:r>
-                        <a:rPr sz="1400" b="0">
-                          <a:solidFill>
-                            <a:srgbClr val="000000"/>
-                          </a:solidFill>
-                        </a:rPr>
-                        <a:t>LSTM</a:t>
+                        <a:rPr sz="1700" b="0">
+                          <a:solidFill>
+                            <a:srgbClr val="000000"/>
+                          </a:solidFill>
+                        </a:rPr>
+                        <a:t>OhioT1DM 2020</a:t>
                       </a:r>
                     </a:p>
                   </a:txBody>
@@ -14006,12 +15242,12 @@
                     <a:p>
                       <a:pPr algn="ctr"/>
                       <a:r>
-                        <a:rPr sz="1400" b="0">
-                          <a:solidFill>
-                            <a:srgbClr val="000000"/>
-                          </a:solidFill>
-                        </a:rPr>
-                        <a:t>21.25</a:t>
+                        <a:rPr sz="1700" b="0">
+                          <a:solidFill>
+                            <a:srgbClr val="000000"/>
+                          </a:solidFill>
+                        </a:rPr>
+                        <a:t>clinical</a:t>
                       </a:r>
                     </a:p>
                   </a:txBody>
@@ -14028,12 +15264,12 @@
                     <a:p>
                       <a:pPr algn="ctr"/>
                       <a:r>
-                        <a:rPr sz="1400" b="0">
-                          <a:solidFill>
-                            <a:srgbClr val="000000"/>
-                          </a:solidFill>
-                        </a:rPr>
-                        <a:t>22.37</a:t>
+                        <a:rPr sz="1700" b="0">
+                          <a:solidFill>
+                            <a:srgbClr val="000000"/>
+                          </a:solidFill>
+                        </a:rPr>
+                        <a:t>25.00</a:t>
                       </a:r>
                     </a:p>
                   </a:txBody>
@@ -14050,18 +15286,108 @@
                     <a:p>
                       <a:pPr algn="ctr"/>
                       <a:r>
-                        <a:rPr sz="1400" b="0">
-                          <a:solidFill>
-                            <a:srgbClr val="000000"/>
-                          </a:solidFill>
-                        </a:rPr>
-                        <a:t>+1.17</a:t>
+                        <a:rPr sz="1700" b="0">
+                          <a:solidFill>
+                            <a:srgbClr val="000000"/>
+                          </a:solidFill>
+                        </a:rPr>
+                        <a:t>22.04</a:t>
                       </a:r>
                     </a:p>
                   </a:txBody>
                   <a:tcPr>
                     <a:solidFill>
                       <a:srgbClr val="FFFFFF"/>
+                    </a:solidFill>
+                  </a:tcPr>
+                </a:tc>
+              </a:tr>
+              <a:tr h="384048">
+                <a:tc>
+                  <a:txBody>
+                    <a:bodyPr wrap="square"/>
+                    <a:lstStyle/>
+                    <a:p>
+                      <a:pPr algn="l"/>
+                      <a:r>
+                        <a:rPr sz="1700" b="0">
+                          <a:solidFill>
+                            <a:srgbClr val="000000"/>
+                          </a:solidFill>
+                        </a:rPr>
+                        <a:t>Glucdict</a:t>
+                      </a:r>
+                    </a:p>
+                  </a:txBody>
+                  <a:tcPr>
+                    <a:solidFill>
+                      <a:srgbClr val="F2F2F2"/>
+                    </a:solidFill>
+                  </a:tcPr>
+                </a:tc>
+                <a:tc>
+                  <a:txBody>
+                    <a:bodyPr wrap="square"/>
+                    <a:lstStyle/>
+                    <a:p>
+                      <a:pPr algn="ctr"/>
+                      <a:r>
+                        <a:rPr sz="1700" b="0">
+                          <a:solidFill>
+                            <a:srgbClr val="000000"/>
+                          </a:solidFill>
+                        </a:rPr>
+                        <a:t>glucose_activity</a:t>
+                      </a:r>
+                    </a:p>
+                  </a:txBody>
+                  <a:tcPr>
+                    <a:solidFill>
+                      <a:srgbClr val="F2F2F2"/>
+                    </a:solidFill>
+                  </a:tcPr>
+                </a:tc>
+                <a:tc>
+                  <a:txBody>
+                    <a:bodyPr wrap="square"/>
+                    <a:lstStyle/>
+                    <a:p>
+                      <a:pPr algn="ctr"/>
+                      <a:r>
+                        <a:rPr sz="1700" b="0">
+                          <a:solidFill>
+                            <a:srgbClr val="000000"/>
+                          </a:solidFill>
+                        </a:rPr>
+                        <a:t>15.19</a:t>
+                      </a:r>
+                    </a:p>
+                  </a:txBody>
+                  <a:tcPr>
+                    <a:solidFill>
+                      <a:srgbClr val="F2F2F2"/>
+                    </a:solidFill>
+                  </a:tcPr>
+                </a:tc>
+                <a:tc>
+                  <a:txBody>
+                    <a:bodyPr wrap="square"/>
+                    <a:lstStyle/>
+                    <a:p>
+                      <a:pPr algn="ctr"/>
+                      <a:r>
+                        <a:rPr sz="1700" b="0">
+                          <a:solidFill>
+                            <a:srgbClr val="000000"/>
+                          </a:solidFill>
+                        </a:rPr>
+                        <a:t>13.86</a:t>
+                      </a:r>
+                    </a:p>
+                  </a:txBody>
+                  <a:tcPr>
+                    <a:solidFill>
+                      <a:srgbClr val="F2F2F2"/>
                     </a:solidFill>
                   </a:tcPr>
                 </a:tc>
@@ -14072,20 +15398,20 @@
       </p:graphicFrame>
       <p:sp>
         <p:nvSpPr>
-          <p:cNvPr id="9" name="Rectangle 8"/>
+          <p:cNvPr id="8" name="Rectangle 7"/>
           <p:cNvSpPr/>
           <p:nvPr/>
         </p:nvSpPr>
         <p:spPr>
           <a:xfrm>
-            <a:off x="6675120" y="1234440"/>
-            <a:ext cx="5120640" cy="4114800"/>
+            <a:off x="548640" y="3931920"/>
+            <a:ext cx="9601200" cy="1463040"/>
           </a:xfrm>
           <a:prstGeom prst="rect">
             <a:avLst/>
           </a:prstGeom>
           <a:solidFill>
-            <a:srgbClr val="E8F5E8"/>
+            <a:srgbClr val="1F3864"/>
           </a:solidFill>
           <a:ln>
             <a:noFill/>
@@ -14115,14 +15441,14 @@
       </p:sp>
       <p:sp>
         <p:nvSpPr>
-          <p:cNvPr id="10" name="TextBox 9"/>
+          <p:cNvPr id="9" name="TextBox 8"/>
           <p:cNvSpPr txBox="1"/>
           <p:nvPr/>
         </p:nvSpPr>
         <p:spPr>
           <a:xfrm>
-            <a:off x="6858000" y="1325880"/>
-            <a:ext cx="4754880" cy="365760"/>
+            <a:off x="777240" y="4069080"/>
+            <a:ext cx="9144000" cy="1188720"/>
           </a:xfrm>
           <a:prstGeom prst="rect">
             <a:avLst/>
@@ -14137,48 +15463,13 @@
           <a:p>
             <a:pPr algn="l"/>
             <a:r>
-              <a:rPr sz="1500" b="1">
+              <a:rPr sz="1700" b="1">
                 <a:solidFill>
-                  <a:srgbClr val="1F6B3A"/>
+                  <a:srgbClr val="FFFFFF"/>
                 </a:solidFill>
               </a:rPr>
-              <a:t>What this means</a:t>
-            </a:r>
-          </a:p>
-        </p:txBody>
-      </p:sp>
-      <p:sp>
-        <p:nvSpPr>
-          <p:cNvPr id="11" name="TextBox 10"/>
-          <p:cNvSpPr txBox="1"/>
-          <p:nvPr/>
-        </p:nvSpPr>
-        <p:spPr>
-          <a:xfrm>
-            <a:off x="6858000" y="1737360"/>
-            <a:ext cx="4754880" cy="3474720"/>
-          </a:xfrm>
-          <a:prstGeom prst="rect">
-            <a:avLst/>
-          </a:prstGeom>
-          <a:noFill/>
-        </p:spPr>
-        <p:txBody>
-          <a:bodyPr wrap="square">
-            <a:spAutoFit/>
-          </a:bodyPr>
-          <a:lstStyle/>
-          <a:p>
-            <a:pPr algn="l"/>
-            <a:r>
-              <a:rPr sz="1400" b="0">
-                <a:solidFill>
-                  <a:srgbClr val="1F6B3A"/>
-                </a:solidFill>
-              </a:rPr>
-              <a:t>A population model trained on 11 patients generalises almost as well as a personalised model for a new unseen patient.
-RF actually improves with pooling — more data outweighs loss of patient-specificity.
-Clinical implication: one deployed model could serve new patients without requiring 8 weeks of personalised data.</a:t>
+              <a:t>Every model on every dataset achieves its best result with minimal features (glucose + clinical, or glucose + light activity).
+No model benefits from the full wearable feature set.</a:t>
             </a:r>
           </a:p>
         </p:txBody>

</xml_diff>